<commit_message>
Resolve independent slide review finding for 3.1.3
</commit_message>
<xml_diff>
--- a/edities/books34-v3/books/book-3/chapters/3.1/paragraph-pdfs/3.1.3 Subsidies – presentatie.pptx
+++ b/edities/books34-v3/books/book-3/chapters/3.1/paragraph-pdfs/3.1.3 Subsidies – presentatie.pptx
@@ -2,41 +2,41 @@
 <file path=ppt/presentation.xml><?xml version="1.0" encoding="utf-8"?>
 <p:presentation xmlns:p="http://schemas.openxmlformats.org/presentationml/2006/main">
   <p:sldMasterIdLst>
-    <p:sldMasterId xmlns:r="http://schemas.openxmlformats.org/officeDocument/2006/relationships" id="2147483648" r:id="R47490c37d01f4ee6"/>
+    <p:sldMasterId xmlns:r="http://schemas.openxmlformats.org/officeDocument/2006/relationships" id="2147483648" r:id="R23a371e6ebd34def"/>
   </p:sldMasterIdLst>
   <p:notesMasterIdLst>
-    <p:notesMasterId xmlns:r="http://schemas.openxmlformats.org/officeDocument/2006/relationships" r:id="Rd3346ec58cac487e"/>
+    <p:notesMasterId xmlns:r="http://schemas.openxmlformats.org/officeDocument/2006/relationships" r:id="R76d5c7ef29544041"/>
   </p:notesMasterIdLst>
   <p:sldIdLst>
-    <p:sldId xmlns:r="http://schemas.openxmlformats.org/officeDocument/2006/relationships" id="256" r:id="Rccecc524263347af"/>
-    <p:sldId xmlns:r="http://schemas.openxmlformats.org/officeDocument/2006/relationships" id="257" r:id="Reaff8a9fbe254d55"/>
-    <p:sldId xmlns:r="http://schemas.openxmlformats.org/officeDocument/2006/relationships" id="258" r:id="R103dc5c3c43d4222"/>
-    <p:sldId xmlns:r="http://schemas.openxmlformats.org/officeDocument/2006/relationships" id="259" r:id="R7f56c185d8d648f0"/>
-    <p:sldId xmlns:r="http://schemas.openxmlformats.org/officeDocument/2006/relationships" id="260" r:id="R6b1bf701486b4c76"/>
-    <p:sldId xmlns:r="http://schemas.openxmlformats.org/officeDocument/2006/relationships" id="261" r:id="R652167933f944e73"/>
-    <p:sldId xmlns:r="http://schemas.openxmlformats.org/officeDocument/2006/relationships" id="262" r:id="R77fe5e123cd24a23"/>
-    <p:sldId xmlns:r="http://schemas.openxmlformats.org/officeDocument/2006/relationships" id="263" r:id="Rf99fe231d01d48db"/>
-    <p:sldId xmlns:r="http://schemas.openxmlformats.org/officeDocument/2006/relationships" id="264" r:id="R8583703a0bf84533"/>
-    <p:sldId xmlns:r="http://schemas.openxmlformats.org/officeDocument/2006/relationships" id="265" r:id="Ra06711d097f54c87"/>
-    <p:sldId xmlns:r="http://schemas.openxmlformats.org/officeDocument/2006/relationships" id="266" r:id="Rb428a39c83ec4d7c"/>
-    <p:sldId xmlns:r="http://schemas.openxmlformats.org/officeDocument/2006/relationships" id="267" r:id="R3dfe267d7fa942fd"/>
-    <p:sldId xmlns:r="http://schemas.openxmlformats.org/officeDocument/2006/relationships" id="268" r:id="R0852e0919c124c4c"/>
-    <p:sldId xmlns:r="http://schemas.openxmlformats.org/officeDocument/2006/relationships" id="269" r:id="Rf5893df9b4f64cf6"/>
-    <p:sldId xmlns:r="http://schemas.openxmlformats.org/officeDocument/2006/relationships" id="270" r:id="R9d7fda58f9fe453c"/>
-    <p:sldId xmlns:r="http://schemas.openxmlformats.org/officeDocument/2006/relationships" id="271" r:id="R8d48041ac9dc42ba"/>
-    <p:sldId xmlns:r="http://schemas.openxmlformats.org/officeDocument/2006/relationships" id="272" r:id="Ra8ce3cae0c104aee"/>
-    <p:sldId xmlns:r="http://schemas.openxmlformats.org/officeDocument/2006/relationships" id="273" r:id="R1549962ff87a48ef"/>
-    <p:sldId xmlns:r="http://schemas.openxmlformats.org/officeDocument/2006/relationships" id="274" r:id="R00e987369df74303"/>
-    <p:sldId xmlns:r="http://schemas.openxmlformats.org/officeDocument/2006/relationships" id="275" r:id="R400ef86f8428463f"/>
-    <p:sldId xmlns:r="http://schemas.openxmlformats.org/officeDocument/2006/relationships" id="276" r:id="R659ed93fccfb4cd2"/>
-    <p:sldId xmlns:r="http://schemas.openxmlformats.org/officeDocument/2006/relationships" id="277" r:id="Rd40d3435cb684257"/>
-    <p:sldId xmlns:r="http://schemas.openxmlformats.org/officeDocument/2006/relationships" id="278" r:id="R546790822c7a41c0"/>
-    <p:sldId xmlns:r="http://schemas.openxmlformats.org/officeDocument/2006/relationships" id="279" r:id="R19c7ed45048a43ff"/>
-    <p:sldId xmlns:r="http://schemas.openxmlformats.org/officeDocument/2006/relationships" id="280" r:id="Re7249db991a34d53"/>
-    <p:sldId xmlns:r="http://schemas.openxmlformats.org/officeDocument/2006/relationships" id="281" r:id="R0355bda8c6ad42a9"/>
-    <p:sldId xmlns:r="http://schemas.openxmlformats.org/officeDocument/2006/relationships" id="282" r:id="R100c4e6216904b0e"/>
-    <p:sldId xmlns:r="http://schemas.openxmlformats.org/officeDocument/2006/relationships" id="283" r:id="Ra100245bf78d4adf"/>
-    <p:sldId xmlns:r="http://schemas.openxmlformats.org/officeDocument/2006/relationships" id="284" r:id="R6edd295853534266"/>
+    <p:sldId xmlns:r="http://schemas.openxmlformats.org/officeDocument/2006/relationships" id="256" r:id="Rd8973a95517a4943"/>
+    <p:sldId xmlns:r="http://schemas.openxmlformats.org/officeDocument/2006/relationships" id="257" r:id="R20f32154b5814dcf"/>
+    <p:sldId xmlns:r="http://schemas.openxmlformats.org/officeDocument/2006/relationships" id="258" r:id="R1dc4f1dc1001446c"/>
+    <p:sldId xmlns:r="http://schemas.openxmlformats.org/officeDocument/2006/relationships" id="259" r:id="R245a806b2d0249e9"/>
+    <p:sldId xmlns:r="http://schemas.openxmlformats.org/officeDocument/2006/relationships" id="260" r:id="Rf9949ac8d71d43ec"/>
+    <p:sldId xmlns:r="http://schemas.openxmlformats.org/officeDocument/2006/relationships" id="261" r:id="R2673cc801b3c4f6c"/>
+    <p:sldId xmlns:r="http://schemas.openxmlformats.org/officeDocument/2006/relationships" id="262" r:id="R49a6489cee4e44aa"/>
+    <p:sldId xmlns:r="http://schemas.openxmlformats.org/officeDocument/2006/relationships" id="263" r:id="Rb123523281da4d88"/>
+    <p:sldId xmlns:r="http://schemas.openxmlformats.org/officeDocument/2006/relationships" id="264" r:id="R26ab997fabcb4239"/>
+    <p:sldId xmlns:r="http://schemas.openxmlformats.org/officeDocument/2006/relationships" id="265" r:id="Rc16301b572aa42ba"/>
+    <p:sldId xmlns:r="http://schemas.openxmlformats.org/officeDocument/2006/relationships" id="266" r:id="R9bfef3f52e4941ec"/>
+    <p:sldId xmlns:r="http://schemas.openxmlformats.org/officeDocument/2006/relationships" id="267" r:id="Re944fb3ad8bb4f7c"/>
+    <p:sldId xmlns:r="http://schemas.openxmlformats.org/officeDocument/2006/relationships" id="268" r:id="R7aceda054ed94f43"/>
+    <p:sldId xmlns:r="http://schemas.openxmlformats.org/officeDocument/2006/relationships" id="269" r:id="R8bd434d4214b4425"/>
+    <p:sldId xmlns:r="http://schemas.openxmlformats.org/officeDocument/2006/relationships" id="270" r:id="R170ff1fe33364e9e"/>
+    <p:sldId xmlns:r="http://schemas.openxmlformats.org/officeDocument/2006/relationships" id="271" r:id="R9a4ccff6e106421b"/>
+    <p:sldId xmlns:r="http://schemas.openxmlformats.org/officeDocument/2006/relationships" id="272" r:id="R04982246d68147a4"/>
+    <p:sldId xmlns:r="http://schemas.openxmlformats.org/officeDocument/2006/relationships" id="273" r:id="R945bc0db459c4e94"/>
+    <p:sldId xmlns:r="http://schemas.openxmlformats.org/officeDocument/2006/relationships" id="274" r:id="Ra9d6eaab79cf4b82"/>
+    <p:sldId xmlns:r="http://schemas.openxmlformats.org/officeDocument/2006/relationships" id="275" r:id="R30abcf6714fc4674"/>
+    <p:sldId xmlns:r="http://schemas.openxmlformats.org/officeDocument/2006/relationships" id="276" r:id="R300e8275d3044cdc"/>
+    <p:sldId xmlns:r="http://schemas.openxmlformats.org/officeDocument/2006/relationships" id="277" r:id="Ra5ab12e121064e7c"/>
+    <p:sldId xmlns:r="http://schemas.openxmlformats.org/officeDocument/2006/relationships" id="278" r:id="Rad9e956e87a849b4"/>
+    <p:sldId xmlns:r="http://schemas.openxmlformats.org/officeDocument/2006/relationships" id="279" r:id="R930c60a2636b4b0d"/>
+    <p:sldId xmlns:r="http://schemas.openxmlformats.org/officeDocument/2006/relationships" id="280" r:id="R7a88f6b52d4e4d7c"/>
+    <p:sldId xmlns:r="http://schemas.openxmlformats.org/officeDocument/2006/relationships" id="281" r:id="R2d756cc1b32142a5"/>
+    <p:sldId xmlns:r="http://schemas.openxmlformats.org/officeDocument/2006/relationships" id="282" r:id="Rbc946e41ac38418d"/>
+    <p:sldId xmlns:r="http://schemas.openxmlformats.org/officeDocument/2006/relationships" id="283" r:id="Rca980e3349d542b6"/>
+    <p:sldId xmlns:r="http://schemas.openxmlformats.org/officeDocument/2006/relationships" id="284" r:id="Rb6a25a39d68f4605"/>
   </p:sldIdLst>
   <p:sldSz cx="15240000" cy="8572500"/>
   <p:notesSz cx="6858000" cy="9144000"/>
@@ -3758,7 +3758,7 @@
           <a:p xmlns:a="http://schemas.openxmlformats.org/drawingml/2006/main">
             <a:r>
               <a:rPr sz="1400"/>
-              <a:t>Uitleg: Construeer twee punten van A−s: bij Q=0 is Pc=2, bij Q=100 is Pc=12. De helling blijft 0,10. Vergelijk bij dezelfde hoeveelheid met A: steeds zes euro lager. Het snijpunt van V met A−s gaat de nieuwe verkoop bepalen.</a:t>
+              <a:t>Uitleg: Construeer twee punten van A−s: bij Q=0 is Pc=2, bij Q=100 is Pc=12. De helling blijft 0,10. De horizontale pijl vergelijkt bij dezelfde kopersprijs van € 10: op A zijn dat 20 controles en op A−s 80 controles. Dit is een andere vergelijking dan de verticale subsidiewig bij dezelfde Q. Vergelijk bij dezelfde hoeveelheid met A: steeds zes euro lager. Het snijpunt van V met A−s gaat de nieuwe verkoop bepalen.</a:t>
             </a:r>
           </a:p>
           <a:p xmlns:a="http://schemas.openxmlformats.org/drawingml/2006/main">
@@ -4267,7 +4267,7 @@
   </p:cSld>
   <p:clrMap bg1="lt1" tx1="dk1" bg2="lt2" tx2="dk2" accent1="accent1" accent2="accent2" accent3="accent3" accent4="accent4" accent5="accent5" accent6="accent6" hlink="hlink" folHlink="folHlink"/>
   <p:sldLayoutIdLst>
-    <p:sldLayoutId xmlns:r="http://schemas.openxmlformats.org/officeDocument/2006/relationships" id="2147483649" r:id="Rcc2108a8f32a471e"/>
+    <p:sldLayoutId xmlns:r="http://schemas.openxmlformats.org/officeDocument/2006/relationships" id="2147483649" r:id="R9c48b75228814b1c"/>
   </p:sldLayoutIdLst>
   <p:txStyles>
     <p:titleStyle>
@@ -5628,6 +5628,108 @@
           </c:yVal>
           <c:smooth val="0"/>
         </c:ser>
+        <c:ser>
+          <c:idx val="3"/>
+          <c:order val="3"/>
+          <c:tx>
+            <c:v>Verschuiving bij dezelfde kopersprijs</c:v>
+          </c:tx>
+          <c:spPr>
+            <a:ln xmlns:a="http://schemas.openxmlformats.org/drawingml/2006/main" w="23813">
+              <a:solidFill>
+                <a:srgbClr val="445B6B"/>
+              </a:solidFill>
+            </a:ln>
+          </c:spPr>
+          <c:marker>
+            <c:symbol val="none"/>
+          </c:marker>
+          <c:xVal>
+            <c:numRef>
+              <c:f>'Chart Data'!$G$2:$G$3</c:f>
+              <c:numCache>
+                <c:formatCode>General</c:formatCode>
+                <c:ptCount val="2"/>
+                <c:pt idx="0">
+                  <c:v>20</c:v>
+                </c:pt>
+                <c:pt idx="1">
+                  <c:v>80</c:v>
+                </c:pt>
+              </c:numCache>
+            </c:numRef>
+          </c:xVal>
+          <c:yVal>
+            <c:numRef>
+              <c:f>'Chart Data'!$H$2:$H$3</c:f>
+              <c:numCache>
+                <c:formatCode>0</c:formatCode>
+                <c:ptCount val="2"/>
+                <c:pt idx="0">
+                  <c:v>10</c:v>
+                </c:pt>
+                <c:pt idx="1">
+                  <c:v>10</c:v>
+                </c:pt>
+              </c:numCache>
+            </c:numRef>
+          </c:yVal>
+          <c:smooth val="0"/>
+        </c:ser>
+        <c:ser>
+          <c:idx val="4"/>
+          <c:order val="4"/>
+          <c:tx>
+            <c:v>Pijlpunt verschuiving</c:v>
+          </c:tx>
+          <c:spPr>
+            <a:ln xmlns:a="http://schemas.openxmlformats.org/drawingml/2006/main" w="23813">
+              <a:solidFill>
+                <a:srgbClr val="445B6B"/>
+              </a:solidFill>
+            </a:ln>
+          </c:spPr>
+          <c:marker>
+            <c:symbol val="none"/>
+          </c:marker>
+          <c:xVal>
+            <c:numRef>
+              <c:f>'Chart Data'!$I$2:$I$4</c:f>
+              <c:numCache>
+                <c:formatCode>General</c:formatCode>
+                <c:ptCount val="3"/>
+                <c:pt idx="0">
+                  <c:v>76</c:v>
+                </c:pt>
+                <c:pt idx="1">
+                  <c:v>80</c:v>
+                </c:pt>
+                <c:pt idx="2">
+                  <c:v>76</c:v>
+                </c:pt>
+              </c:numCache>
+            </c:numRef>
+          </c:xVal>
+          <c:yVal>
+            <c:numRef>
+              <c:f>'Chart Data'!$J$2:$J$4</c:f>
+              <c:numCache>
+                <c:formatCode>0</c:formatCode>
+                <c:ptCount val="3"/>
+                <c:pt idx="0">
+                  <c:v>10.4</c:v>
+                </c:pt>
+                <c:pt idx="1">
+                  <c:v>10</c:v>
+                </c:pt>
+                <c:pt idx="2">
+                  <c:v>9.6</c:v>
+                </c:pt>
+              </c:numCache>
+            </c:numRef>
+          </c:yVal>
+          <c:smooth val="0"/>
+        </c:ser>
         <c:dLbls>
           <c:txPr>
             <a:bodyPr xmlns:a="http://schemas.openxmlformats.org/drawingml/2006/main" anchorCtr="1"/>
@@ -16545,7 +16647,7 @@
           <p:cNvPr id="29" name="Deze les: §3.1.3 Subsidies">
             <a:extLst xmlns:a="http://schemas.openxmlformats.org/drawingml/2006/main">
               <a:ext uri="{FF2B5EF4-FFF2-40B4-BE49-F238E27FC236}">
-                <a16:creationId xmlns:a16="http://schemas.microsoft.com/office/drawing/2014/main" id="{F4EA8C30-B0D6-4636-B658-B96C643E12B7}"/>
+                <a16:creationId xmlns:a16="http://schemas.microsoft.com/office/drawing/2014/main" id="{B8BCCC13-8D80-4952-9E1F-4F880774094E}"/>
               </a:ext>
             </a:extLst>
           </p:cNvPr>
@@ -16602,7 +16704,7 @@
           <p:cNvPr id="2" name="">
             <a:extLst xmlns:a="http://schemas.openxmlformats.org/drawingml/2006/main">
               <a:ext uri="{FF2B5EF4-FFF2-40B4-BE49-F238E27FC236}">
-                <a16:creationId xmlns:a16="http://schemas.microsoft.com/office/drawing/2014/main" id="{77C2D171-343E-481F-959F-B5FB7E1ECF25}"/>
+                <a16:creationId xmlns:a16="http://schemas.microsoft.com/office/drawing/2014/main" id="{263E64A0-42C3-41AF-AE3B-58E1683512E2}"/>
               </a:ext>
             </a:extLst>
           </p:cNvPr>
@@ -16631,7 +16733,7 @@
           <p:cNvPr id="3" name="§3.1.3 Subsidies">
             <a:extLst xmlns:a="http://schemas.openxmlformats.org/drawingml/2006/main">
               <a:ext uri="{FF2B5EF4-FFF2-40B4-BE49-F238E27FC236}">
-                <a16:creationId xmlns:a16="http://schemas.microsoft.com/office/drawing/2014/main" id="{6833331A-AB33-4EC1-AD1A-23EB94734CAD}"/>
+                <a16:creationId xmlns:a16="http://schemas.microsoft.com/office/drawing/2014/main" id="{14019CEF-0C05-4E8D-9356-D9EB29AA19C5}"/>
               </a:ext>
             </a:extLst>
           </p:cNvPr>
@@ -16688,7 +16790,7 @@
           <p:cNvPr id="4" name="1">
             <a:extLst xmlns:a="http://schemas.openxmlformats.org/drawingml/2006/main">
               <a:ext uri="{FF2B5EF4-FFF2-40B4-BE49-F238E27FC236}">
-                <a16:creationId xmlns:a16="http://schemas.microsoft.com/office/drawing/2014/main" id="{881D5859-36C2-4788-9DC2-25A2A2DFA6C5}"/>
+                <a16:creationId xmlns:a16="http://schemas.microsoft.com/office/drawing/2014/main" id="{45746BC6-E44F-4EF3-BC93-F2074F7D6C41}"/>
               </a:ext>
             </a:extLst>
           </p:cNvPr>
@@ -16745,7 +16847,7 @@
           <p:cNvPr id="5" name="phase">
             <a:extLst xmlns:a="http://schemas.openxmlformats.org/drawingml/2006/main">
               <a:ext uri="{FF2B5EF4-FFF2-40B4-BE49-F238E27FC236}">
-                <a16:creationId xmlns:a16="http://schemas.microsoft.com/office/drawing/2014/main" id="{5CC3EB85-7EFB-4785-BC43-257C11C3DDB4}"/>
+                <a16:creationId xmlns:a16="http://schemas.microsoft.com/office/drawing/2014/main" id="{B4E4D35F-BB27-40F3-BCD4-D93EC83688B0}"/>
               </a:ext>
             </a:extLst>
           </p:cNvPr>
@@ -16802,7 +16904,7 @@
           <p:cNvPr id="6" name="Lesroute">
             <a:extLst xmlns:a="http://schemas.openxmlformats.org/drawingml/2006/main">
               <a:ext uri="{FF2B5EF4-FFF2-40B4-BE49-F238E27FC236}">
-                <a16:creationId xmlns:a16="http://schemas.microsoft.com/office/drawing/2014/main" id="{9B88A011-432D-4247-A3C1-222D7592B5EF}"/>
+                <a16:creationId xmlns:a16="http://schemas.microsoft.com/office/drawing/2014/main" id="{C77E4D31-C194-4AF6-8F8F-E25D949E87C9}"/>
               </a:ext>
             </a:extLst>
           </p:cNvPr>
@@ -16859,7 +16961,7 @@
           <p:cNvPr id="7" name="route-number-0">
             <a:extLst xmlns:a="http://schemas.openxmlformats.org/drawingml/2006/main">
               <a:ext uri="{FF2B5EF4-FFF2-40B4-BE49-F238E27FC236}">
-                <a16:creationId xmlns:a16="http://schemas.microsoft.com/office/drawing/2014/main" id="{B1B02EBC-D862-4BDA-8F19-2E42310D2E86}"/>
+                <a16:creationId xmlns:a16="http://schemas.microsoft.com/office/drawing/2014/main" id="{B5E62DBE-BEB1-4343-9A73-868B2E637744}"/>
               </a:ext>
             </a:extLst>
           </p:cNvPr>
@@ -16916,7 +17018,7 @@
           <p:cNvPr id="8" name="route-0">
             <a:extLst xmlns:a="http://schemas.openxmlformats.org/drawingml/2006/main">
               <a:ext uri="{FF2B5EF4-FFF2-40B4-BE49-F238E27FC236}">
-                <a16:creationId xmlns:a16="http://schemas.microsoft.com/office/drawing/2014/main" id="{EE37398A-A6E9-471C-8A96-C214EA140DBD}"/>
+                <a16:creationId xmlns:a16="http://schemas.microsoft.com/office/drawing/2014/main" id="{79A21735-43C8-41EF-9794-4855DD13CB53}"/>
               </a:ext>
             </a:extLst>
           </p:cNvPr>
@@ -16973,7 +17075,7 @@
           <p:cNvPr id="9" name="route-number-1">
             <a:extLst xmlns:a="http://schemas.openxmlformats.org/drawingml/2006/main">
               <a:ext uri="{FF2B5EF4-FFF2-40B4-BE49-F238E27FC236}">
-                <a16:creationId xmlns:a16="http://schemas.microsoft.com/office/drawing/2014/main" id="{31DC8759-1389-478B-B7D3-DD0D1D274A80}"/>
+                <a16:creationId xmlns:a16="http://schemas.microsoft.com/office/drawing/2014/main" id="{DAA833A7-0C2A-4AC4-AC02-06814D660B8A}"/>
               </a:ext>
             </a:extLst>
           </p:cNvPr>
@@ -17030,7 +17132,7 @@
           <p:cNvPr id="10" name="route-1">
             <a:extLst xmlns:a="http://schemas.openxmlformats.org/drawingml/2006/main">
               <a:ext uri="{FF2B5EF4-FFF2-40B4-BE49-F238E27FC236}">
-                <a16:creationId xmlns:a16="http://schemas.microsoft.com/office/drawing/2014/main" id="{A74A8757-6983-4FF0-97C5-FFEF29ECCE90}"/>
+                <a16:creationId xmlns:a16="http://schemas.microsoft.com/office/drawing/2014/main" id="{3A4F5D7F-FA9E-4382-9987-9C673CA111B1}"/>
               </a:ext>
             </a:extLst>
           </p:cNvPr>
@@ -17087,7 +17189,7 @@
           <p:cNvPr id="11" name="route-number-2">
             <a:extLst xmlns:a="http://schemas.openxmlformats.org/drawingml/2006/main">
               <a:ext uri="{FF2B5EF4-FFF2-40B4-BE49-F238E27FC236}">
-                <a16:creationId xmlns:a16="http://schemas.microsoft.com/office/drawing/2014/main" id="{7DF12C3D-0DE0-4992-AE47-5B4B27CB0D79}"/>
+                <a16:creationId xmlns:a16="http://schemas.microsoft.com/office/drawing/2014/main" id="{A25FFD7F-EA55-4B97-8516-AAEC5E54CB8E}"/>
               </a:ext>
             </a:extLst>
           </p:cNvPr>
@@ -17144,7 +17246,7 @@
           <p:cNvPr id="12" name="route-2">
             <a:extLst xmlns:a="http://schemas.openxmlformats.org/drawingml/2006/main">
               <a:ext uri="{FF2B5EF4-FFF2-40B4-BE49-F238E27FC236}">
-                <a16:creationId xmlns:a16="http://schemas.microsoft.com/office/drawing/2014/main" id="{0F0BC7AC-3209-435A-BEDA-B74080368CC2}"/>
+                <a16:creationId xmlns:a16="http://schemas.microsoft.com/office/drawing/2014/main" id="{1FF2F8F2-947C-4AB5-A89F-98C039862157}"/>
               </a:ext>
             </a:extLst>
           </p:cNvPr>
@@ -17201,7 +17303,7 @@
           <p:cNvPr id="13" name="route-number-3">
             <a:extLst xmlns:a="http://schemas.openxmlformats.org/drawingml/2006/main">
               <a:ext uri="{FF2B5EF4-FFF2-40B4-BE49-F238E27FC236}">
-                <a16:creationId xmlns:a16="http://schemas.microsoft.com/office/drawing/2014/main" id="{BB513B9D-2D07-496A-AB27-1F9CA04AD917}"/>
+                <a16:creationId xmlns:a16="http://schemas.microsoft.com/office/drawing/2014/main" id="{5F8576B2-8273-4536-9462-2276F407CDF9}"/>
               </a:ext>
             </a:extLst>
           </p:cNvPr>
@@ -17258,7 +17360,7 @@
           <p:cNvPr id="14" name="route-3">
             <a:extLst xmlns:a="http://schemas.openxmlformats.org/drawingml/2006/main">
               <a:ext uri="{FF2B5EF4-FFF2-40B4-BE49-F238E27FC236}">
-                <a16:creationId xmlns:a16="http://schemas.microsoft.com/office/drawing/2014/main" id="{C9E416C8-AEFD-4FA0-9B9B-0C2E02735044}"/>
+                <a16:creationId xmlns:a16="http://schemas.microsoft.com/office/drawing/2014/main" id="{806B6DCF-E784-4053-8E24-1FEBB109AE7D}"/>
               </a:ext>
             </a:extLst>
           </p:cNvPr>
@@ -17315,7 +17417,7 @@
           <p:cNvPr id="15" name="route-number-4">
             <a:extLst xmlns:a="http://schemas.openxmlformats.org/drawingml/2006/main">
               <a:ext uri="{FF2B5EF4-FFF2-40B4-BE49-F238E27FC236}">
-                <a16:creationId xmlns:a16="http://schemas.microsoft.com/office/drawing/2014/main" id="{CA674121-AE41-4A57-A7F0-B5A4703B4154}"/>
+                <a16:creationId xmlns:a16="http://schemas.microsoft.com/office/drawing/2014/main" id="{56936BE5-D58C-4AD9-8783-1FCE38F40F48}"/>
               </a:ext>
             </a:extLst>
           </p:cNvPr>
@@ -17372,7 +17474,7 @@
           <p:cNvPr id="16" name="route-4">
             <a:extLst xmlns:a="http://schemas.openxmlformats.org/drawingml/2006/main">
               <a:ext uri="{FF2B5EF4-FFF2-40B4-BE49-F238E27FC236}">
-                <a16:creationId xmlns:a16="http://schemas.microsoft.com/office/drawing/2014/main" id="{2DABFC71-1D98-4D57-B2B1-A43E4C686317}"/>
+                <a16:creationId xmlns:a16="http://schemas.microsoft.com/office/drawing/2014/main" id="{B778875A-9045-4D41-8D41-F0187EFF9412}"/>
               </a:ext>
             </a:extLst>
           </p:cNvPr>
@@ -17429,7 +17531,7 @@
           <p:cNvPr id="17" name="route-number-5">
             <a:extLst xmlns:a="http://schemas.openxmlformats.org/drawingml/2006/main">
               <a:ext uri="{FF2B5EF4-FFF2-40B4-BE49-F238E27FC236}">
-                <a16:creationId xmlns:a16="http://schemas.microsoft.com/office/drawing/2014/main" id="{1BEA2BCE-6200-46B5-A193-5F4249DDAE54}"/>
+                <a16:creationId xmlns:a16="http://schemas.microsoft.com/office/drawing/2014/main" id="{D4944AC0-5F3C-4CB3-8102-201CA6469BFA}"/>
               </a:ext>
             </a:extLst>
           </p:cNvPr>
@@ -17486,7 +17588,7 @@
           <p:cNvPr id="18" name="route-5">
             <a:extLst xmlns:a="http://schemas.openxmlformats.org/drawingml/2006/main">
               <a:ext uri="{FF2B5EF4-FFF2-40B4-BE49-F238E27FC236}">
-                <a16:creationId xmlns:a16="http://schemas.microsoft.com/office/drawing/2014/main" id="{7585713C-6058-4230-8338-A98EEEBE97A0}"/>
+                <a16:creationId xmlns:a16="http://schemas.microsoft.com/office/drawing/2014/main" id="{8B1ADA9D-E066-42B3-94EB-C52F0FF21D39}"/>
               </a:ext>
             </a:extLst>
           </p:cNvPr>
@@ -17543,7 +17645,7 @@
           <p:cNvPr id="19" name="route-number-6">
             <a:extLst xmlns:a="http://schemas.openxmlformats.org/drawingml/2006/main">
               <a:ext uri="{FF2B5EF4-FFF2-40B4-BE49-F238E27FC236}">
-                <a16:creationId xmlns:a16="http://schemas.microsoft.com/office/drawing/2014/main" id="{D1F01D16-3E74-4B2A-8A5A-865DF5722FF2}"/>
+                <a16:creationId xmlns:a16="http://schemas.microsoft.com/office/drawing/2014/main" id="{A27F631E-B9E1-4CDF-9F32-CCD79289555D}"/>
               </a:ext>
             </a:extLst>
           </p:cNvPr>
@@ -17600,7 +17702,7 @@
           <p:cNvPr id="20" name="route-6">
             <a:extLst xmlns:a="http://schemas.openxmlformats.org/drawingml/2006/main">
               <a:ext uri="{FF2B5EF4-FFF2-40B4-BE49-F238E27FC236}">
-                <a16:creationId xmlns:a16="http://schemas.microsoft.com/office/drawing/2014/main" id="{EEDBB815-6676-48C3-A71C-28B304C37824}"/>
+                <a16:creationId xmlns:a16="http://schemas.microsoft.com/office/drawing/2014/main" id="{C4A77DCF-8917-4769-9F80-4CC9AC10FAEB}"/>
               </a:ext>
             </a:extLst>
           </p:cNvPr>
@@ -17657,7 +17759,7 @@
           <p:cNvPr id="21" name="Lesdoelen">
             <a:extLst xmlns:a="http://schemas.openxmlformats.org/drawingml/2006/main">
               <a:ext uri="{FF2B5EF4-FFF2-40B4-BE49-F238E27FC236}">
-                <a16:creationId xmlns:a16="http://schemas.microsoft.com/office/drawing/2014/main" id="{D1B90AB4-68FF-4353-9E74-571F0D09F2AA}"/>
+                <a16:creationId xmlns:a16="http://schemas.microsoft.com/office/drawing/2014/main" id="{9D1315A6-ECB6-4354-8398-A1E2637A4E35}"/>
               </a:ext>
             </a:extLst>
           </p:cNvPr>
@@ -17714,7 +17816,7 @@
           <p:cNvPr id="22" name="overview-goals">
             <a:extLst xmlns:a="http://schemas.openxmlformats.org/drawingml/2006/main">
               <a:ext uri="{FF2B5EF4-FFF2-40B4-BE49-F238E27FC236}">
-                <a16:creationId xmlns:a16="http://schemas.microsoft.com/office/drawing/2014/main" id="{F9878D92-2432-42F0-97E2-2EC4BD7B4BC0}"/>
+                <a16:creationId xmlns:a16="http://schemas.microsoft.com/office/drawing/2014/main" id="{8AB1CCDE-7352-4F47-992C-14E7C04A0478}"/>
               </a:ext>
             </a:extLst>
           </p:cNvPr>
@@ -17817,7 +17919,7 @@
           <p:cNvPr id="23" name="">
             <a:extLst xmlns:a="http://schemas.openxmlformats.org/drawingml/2006/main">
               <a:ext uri="{FF2B5EF4-FFF2-40B4-BE49-F238E27FC236}">
-                <a16:creationId xmlns:a16="http://schemas.microsoft.com/office/drawing/2014/main" id="{85C1BD2E-0CAE-4DD4-A953-97ACF4603EF7}"/>
+                <a16:creationId xmlns:a16="http://schemas.microsoft.com/office/drawing/2014/main" id="{C7ED930C-2005-4571-86CB-036968B6E12F}"/>
               </a:ext>
             </a:extLst>
           </p:cNvPr>
@@ -17846,7 +17948,7 @@
           <p:cNvPr id="24" name="Startopdracht">
             <a:extLst xmlns:a="http://schemas.openxmlformats.org/drawingml/2006/main">
               <a:ext uri="{FF2B5EF4-FFF2-40B4-BE49-F238E27FC236}">
-                <a16:creationId xmlns:a16="http://schemas.microsoft.com/office/drawing/2014/main" id="{01A2275F-AC46-4538-9945-93E3EF28F305}"/>
+                <a16:creationId xmlns:a16="http://schemas.microsoft.com/office/drawing/2014/main" id="{AD4EF8B4-70EA-4114-85BF-81B42B9DCA1C}"/>
               </a:ext>
             </a:extLst>
           </p:cNvPr>
@@ -17903,7 +18005,7 @@
           <p:cNvPr id="25" name="overview-start">
             <a:extLst xmlns:a="http://schemas.openxmlformats.org/drawingml/2006/main">
               <a:ext uri="{FF2B5EF4-FFF2-40B4-BE49-F238E27FC236}">
-                <a16:creationId xmlns:a16="http://schemas.microsoft.com/office/drawing/2014/main" id="{9346A650-9133-4499-BD7C-B2901FA472EA}"/>
+                <a16:creationId xmlns:a16="http://schemas.microsoft.com/office/drawing/2014/main" id="{BA0E76AF-AA99-4549-A7C6-389949BEE4F0}"/>
               </a:ext>
             </a:extLst>
           </p:cNvPr>
@@ -18006,7 +18108,7 @@
           <p:cNvPr id="26" name="">
             <a:extLst xmlns:a="http://schemas.openxmlformats.org/drawingml/2006/main">
               <a:ext uri="{FF2B5EF4-FFF2-40B4-BE49-F238E27FC236}">
-                <a16:creationId xmlns:a16="http://schemas.microsoft.com/office/drawing/2014/main" id="{2542C477-1DAE-43C6-8542-F6E5615AEB1F}"/>
+                <a16:creationId xmlns:a16="http://schemas.microsoft.com/office/drawing/2014/main" id="{464C7270-F82B-4F24-8F2E-F275E0B4809A}"/>
               </a:ext>
             </a:extLst>
           </p:cNvPr>
@@ -18035,7 +18137,7 @@
           <p:cNvPr id="27" name="Huiswerk">
             <a:extLst xmlns:a="http://schemas.openxmlformats.org/drawingml/2006/main">
               <a:ext uri="{FF2B5EF4-FFF2-40B4-BE49-F238E27FC236}">
-                <a16:creationId xmlns:a16="http://schemas.microsoft.com/office/drawing/2014/main" id="{50F3C23C-366B-4E8E-B76B-EDC0C658BBF5}"/>
+                <a16:creationId xmlns:a16="http://schemas.microsoft.com/office/drawing/2014/main" id="{0534F378-94CA-41F8-B35B-60D4B1B92E90}"/>
               </a:ext>
             </a:extLst>
           </p:cNvPr>
@@ -18092,7 +18194,7 @@
           <p:cNvPr id="28" name="overview-homework">
             <a:extLst xmlns:a="http://schemas.openxmlformats.org/drawingml/2006/main">
               <a:ext uri="{FF2B5EF4-FFF2-40B4-BE49-F238E27FC236}">
-                <a16:creationId xmlns:a16="http://schemas.microsoft.com/office/drawing/2014/main" id="{A9F66CF2-A414-4E36-9A4A-4EDB18B086C4}"/>
+                <a16:creationId xmlns:a16="http://schemas.microsoft.com/office/drawing/2014/main" id="{AE334663-C1F2-44F4-A779-2707BA441699}"/>
               </a:ext>
             </a:extLst>
           </p:cNvPr>
@@ -18239,7 +18341,7 @@
     </p:spTree>
     <p:extLst>
       <p:ext uri="{BB962C8B-B14F-4D97-AF65-F5344CB8AC3E}">
-        <p14:creationId xmlns:p14="http://schemas.microsoft.com/office/powerpoint/2010/main" val="1185763983"/>
+        <p14:creationId xmlns:p14="http://schemas.microsoft.com/office/powerpoint/2010/main" val="819496598"/>
       </p:ext>
     </p:extLst>
   </p:cSld>
@@ -18270,7 +18372,7 @@
           <p:cNvPr id="9" name="De overheid betaalt voor alle 100 controles">
             <a:extLst xmlns:a="http://schemas.openxmlformats.org/drawingml/2006/main">
               <a:ext uri="{FF2B5EF4-FFF2-40B4-BE49-F238E27FC236}">
-                <a16:creationId xmlns:a16="http://schemas.microsoft.com/office/drawing/2014/main" id="{DC5E7195-9D46-4377-B9B2-D571DA6206D4}"/>
+                <a16:creationId xmlns:a16="http://schemas.microsoft.com/office/drawing/2014/main" id="{7F8EEA50-89F5-4F7F-8CA4-A7C01D7ED4B1}"/>
               </a:ext>
             </a:extLst>
           </p:cNvPr>
@@ -18327,7 +18429,7 @@
           <p:cNvPr id="2" name="">
             <a:extLst xmlns:a="http://schemas.openxmlformats.org/drawingml/2006/main">
               <a:ext uri="{FF2B5EF4-FFF2-40B4-BE49-F238E27FC236}">
-                <a16:creationId xmlns:a16="http://schemas.microsoft.com/office/drawing/2014/main" id="{762F1A6B-28C8-43B7-8F1C-2168E52B1E4A}"/>
+                <a16:creationId xmlns:a16="http://schemas.microsoft.com/office/drawing/2014/main" id="{C2C2E0B9-3EE2-456E-97AB-F6E798332503}"/>
               </a:ext>
             </a:extLst>
           </p:cNvPr>
@@ -18356,7 +18458,7 @@
           <p:cNvPr id="3" name="Uitlegvoorbeeld — niet uit het boek">
             <a:extLst xmlns:a="http://schemas.openxmlformats.org/drawingml/2006/main">
               <a:ext uri="{FF2B5EF4-FFF2-40B4-BE49-F238E27FC236}">
-                <a16:creationId xmlns:a16="http://schemas.microsoft.com/office/drawing/2014/main" id="{B1787B29-8DDE-45D0-8534-510091C329DA}"/>
+                <a16:creationId xmlns:a16="http://schemas.microsoft.com/office/drawing/2014/main" id="{10EFEF19-74AF-4EFF-B8C8-F3EA93C9DDE3}"/>
               </a:ext>
             </a:extLst>
           </p:cNvPr>
@@ -18413,7 +18515,7 @@
           <p:cNvPr id="4" name="10">
             <a:extLst xmlns:a="http://schemas.openxmlformats.org/drawingml/2006/main">
               <a:ext uri="{FF2B5EF4-FFF2-40B4-BE49-F238E27FC236}">
-                <a16:creationId xmlns:a16="http://schemas.microsoft.com/office/drawing/2014/main" id="{9915F9D6-2B15-4512-94CE-FF31F93B69B2}"/>
+                <a16:creationId xmlns:a16="http://schemas.microsoft.com/office/drawing/2014/main" id="{F9A43D5D-1694-4181-A546-3EA842167641}"/>
               </a:ext>
             </a:extLst>
           </p:cNvPr>
@@ -18477,7 +18579,7 @@
         </p:xfrm>
         <a:graphic xmlns:a="http://schemas.openxmlformats.org/drawingml/2006/main">
           <a:graphicData uri="http://schemas.openxmlformats.org/drawingml/2006/chart">
-            <c:chart xmlns:r="http://schemas.openxmlformats.org/officeDocument/2006/relationships" xmlns:c="http://schemas.openxmlformats.org/drawingml/2006/chart" r:id="R7c0f1a9776cf4ba3"/>
+            <c:chart xmlns:r="http://schemas.openxmlformats.org/officeDocument/2006/relationships" xmlns:c="http://schemas.openxmlformats.org/drawingml/2006/chart" r:id="Rc29e8370cf5042cb"/>
           </a:graphicData>
         </a:graphic>
       </p:graphicFrame>
@@ -18486,7 +18588,7 @@
           <p:cNvPr id="6" name="Uitgaven U">
             <a:extLst xmlns:a="http://schemas.openxmlformats.org/drawingml/2006/main">
               <a:ext uri="{FF2B5EF4-FFF2-40B4-BE49-F238E27FC236}">
-                <a16:creationId xmlns:a16="http://schemas.microsoft.com/office/drawing/2014/main" id="{A189563D-7ECB-4310-B5A1-F1E868494A6A}"/>
+                <a16:creationId xmlns:a16="http://schemas.microsoft.com/office/drawing/2014/main" id="{5CCD2202-AB21-4E05-B3E1-3BC53DB9D5EA}"/>
               </a:ext>
             </a:extLst>
           </p:cNvPr>
@@ -18543,7 +18645,7 @@
           <p:cNvPr id="7" name="U = s × Qsub&#10;&#10;U = 6 × 100&#10;&#10;U = € 600&#10;per week">
             <a:extLst xmlns:a="http://schemas.openxmlformats.org/drawingml/2006/main">
               <a:ext uri="{FF2B5EF4-FFF2-40B4-BE49-F238E27FC236}">
-                <a16:creationId xmlns:a16="http://schemas.microsoft.com/office/drawing/2014/main" id="{839CC8DB-D649-4961-AE4F-36B0295AFF59}"/>
+                <a16:creationId xmlns:a16="http://schemas.microsoft.com/office/drawing/2014/main" id="{3135F667-4C4B-4D5D-BEA0-764CFC2C82DD}"/>
               </a:ext>
             </a:extLst>
           </p:cNvPr>
@@ -18679,7 +18781,7 @@
           <p:cNvPr id="8" name="Rechthoek:&#10;breedte 100&#10;hoogte € 6">
             <a:extLst xmlns:a="http://schemas.openxmlformats.org/drawingml/2006/main">
               <a:ext uri="{FF2B5EF4-FFF2-40B4-BE49-F238E27FC236}">
-                <a16:creationId xmlns:a16="http://schemas.microsoft.com/office/drawing/2014/main" id="{A2E72836-E4FC-4AD1-ADDC-F5169F5E8F79}"/>
+                <a16:creationId xmlns:a16="http://schemas.microsoft.com/office/drawing/2014/main" id="{C306D682-8727-4C0B-914D-21AFB3C4267E}"/>
               </a:ext>
             </a:extLst>
           </p:cNvPr>
@@ -18780,7 +18882,7 @@
     </p:spTree>
     <p:extLst>
       <p:ext uri="{BB962C8B-B14F-4D97-AF65-F5344CB8AC3E}">
-        <p14:creationId xmlns:p14="http://schemas.microsoft.com/office/powerpoint/2010/main" val="12681321"/>
+        <p14:creationId xmlns:p14="http://schemas.microsoft.com/office/powerpoint/2010/main" val="1675852424"/>
       </p:ext>
     </p:extLst>
   </p:cSld>
@@ -18811,7 +18913,7 @@
           <p:cNvPr id="9" name="Consumentensurplus na subsidie">
             <a:extLst xmlns:a="http://schemas.openxmlformats.org/drawingml/2006/main">
               <a:ext uri="{FF2B5EF4-FFF2-40B4-BE49-F238E27FC236}">
-                <a16:creationId xmlns:a16="http://schemas.microsoft.com/office/drawing/2014/main" id="{B9CE5BEC-60E3-4800-AB19-B74A08E7B353}"/>
+                <a16:creationId xmlns:a16="http://schemas.microsoft.com/office/drawing/2014/main" id="{43A76010-1A5E-4B6C-AAE6-459A6D7D9AB1}"/>
               </a:ext>
             </a:extLst>
           </p:cNvPr>
@@ -18868,7 +18970,7 @@
           <p:cNvPr id="2" name="">
             <a:extLst xmlns:a="http://schemas.openxmlformats.org/drawingml/2006/main">
               <a:ext uri="{FF2B5EF4-FFF2-40B4-BE49-F238E27FC236}">
-                <a16:creationId xmlns:a16="http://schemas.microsoft.com/office/drawing/2014/main" id="{E43C2A12-D9B0-4138-B635-13AAF83BCA1E}"/>
+                <a16:creationId xmlns:a16="http://schemas.microsoft.com/office/drawing/2014/main" id="{CC6DC4A7-B564-4D10-B3ED-69389929EE2F}"/>
               </a:ext>
             </a:extLst>
           </p:cNvPr>
@@ -18897,7 +18999,7 @@
           <p:cNvPr id="3" name="Uitlegvoorbeeld — niet uit het boek">
             <a:extLst xmlns:a="http://schemas.openxmlformats.org/drawingml/2006/main">
               <a:ext uri="{FF2B5EF4-FFF2-40B4-BE49-F238E27FC236}">
-                <a16:creationId xmlns:a16="http://schemas.microsoft.com/office/drawing/2014/main" id="{45700BB7-9C05-4CC1-81ED-A4AA4FCEBB58}"/>
+                <a16:creationId xmlns:a16="http://schemas.microsoft.com/office/drawing/2014/main" id="{324A700C-53D8-4D6A-8E92-03DB9736A6D7}"/>
               </a:ext>
             </a:extLst>
           </p:cNvPr>
@@ -18954,7 +19056,7 @@
           <p:cNvPr id="4" name="11">
             <a:extLst xmlns:a="http://schemas.openxmlformats.org/drawingml/2006/main">
               <a:ext uri="{FF2B5EF4-FFF2-40B4-BE49-F238E27FC236}">
-                <a16:creationId xmlns:a16="http://schemas.microsoft.com/office/drawing/2014/main" id="{7C9FF509-49C2-49B2-A66A-DFA60A2E8D3B}"/>
+                <a16:creationId xmlns:a16="http://schemas.microsoft.com/office/drawing/2014/main" id="{FBE9E1DD-6C7B-4DC5-AD8D-6E400C843DB8}"/>
               </a:ext>
             </a:extLst>
           </p:cNvPr>
@@ -19018,7 +19120,7 @@
         </p:xfrm>
         <a:graphic xmlns:a="http://schemas.openxmlformats.org/drawingml/2006/main">
           <a:graphicData uri="http://schemas.openxmlformats.org/drawingml/2006/chart">
-            <c:chart xmlns:r="http://schemas.openxmlformats.org/officeDocument/2006/relationships" xmlns:c="http://schemas.openxmlformats.org/drawingml/2006/chart" r:id="R76e524c8123144a6"/>
+            <c:chart xmlns:r="http://schemas.openxmlformats.org/officeDocument/2006/relationships" xmlns:c="http://schemas.openxmlformats.org/drawingml/2006/chart" r:id="R4e969cc20e024861"/>
           </a:graphicData>
         </a:graphic>
       </p:graphicFrame>
@@ -19027,7 +19129,7 @@
           <p:cNvPr id="6" name="CS">
             <a:extLst xmlns:a="http://schemas.openxmlformats.org/drawingml/2006/main">
               <a:ext uri="{FF2B5EF4-FFF2-40B4-BE49-F238E27FC236}">
-                <a16:creationId xmlns:a16="http://schemas.microsoft.com/office/drawing/2014/main" id="{B10D3B2D-EA36-4BEE-8972-DCB7C7FD6492}"/>
+                <a16:creationId xmlns:a16="http://schemas.microsoft.com/office/drawing/2014/main" id="{266D9FE4-D800-4ADC-972E-7EB251A2033C}"/>
               </a:ext>
             </a:extLst>
           </p:cNvPr>
@@ -19084,7 +19186,7 @@
           <p:cNvPr id="7" name="½ × basis × hoogte&#10;&#10;½ × 100 × (32 − 12)&#10;&#10;= € 1.000 per ">
             <a:extLst xmlns:a="http://schemas.openxmlformats.org/drawingml/2006/main">
               <a:ext uri="{FF2B5EF4-FFF2-40B4-BE49-F238E27FC236}">
-                <a16:creationId xmlns:a16="http://schemas.microsoft.com/office/drawing/2014/main" id="{48FAD05D-864B-4B70-8797-109871387793}"/>
+                <a16:creationId xmlns:a16="http://schemas.microsoft.com/office/drawing/2014/main" id="{BC1C60B6-EEFD-4594-9D1C-6979C6BC8F65}"/>
               </a:ext>
             </a:extLst>
           </p:cNvPr>
@@ -19197,7 +19299,7 @@
           <p:cNvPr id="8" name="Boven Pc,&#10;onder V">
             <a:extLst xmlns:a="http://schemas.openxmlformats.org/drawingml/2006/main">
               <a:ext uri="{FF2B5EF4-FFF2-40B4-BE49-F238E27FC236}">
-                <a16:creationId xmlns:a16="http://schemas.microsoft.com/office/drawing/2014/main" id="{293DD5C6-892E-42E4-8D35-812A9026E33A}"/>
+                <a16:creationId xmlns:a16="http://schemas.microsoft.com/office/drawing/2014/main" id="{6EA6F2F0-41AF-481B-8AB0-C0BC011AAB51}"/>
               </a:ext>
             </a:extLst>
           </p:cNvPr>
@@ -19275,7 +19377,7 @@
     </p:spTree>
     <p:extLst>
       <p:ext uri="{BB962C8B-B14F-4D97-AF65-F5344CB8AC3E}">
-        <p14:creationId xmlns:p14="http://schemas.microsoft.com/office/powerpoint/2010/main" val="1229558933"/>
+        <p14:creationId xmlns:p14="http://schemas.microsoft.com/office/powerpoint/2010/main" val="347240680"/>
       </p:ext>
     </p:extLst>
   </p:cSld>
@@ -19306,7 +19408,7 @@
           <p:cNvPr id="9" name="Producentensurplus na subsidie">
             <a:extLst xmlns:a="http://schemas.openxmlformats.org/drawingml/2006/main">
               <a:ext uri="{FF2B5EF4-FFF2-40B4-BE49-F238E27FC236}">
-                <a16:creationId xmlns:a16="http://schemas.microsoft.com/office/drawing/2014/main" id="{33384FE5-A102-454D-BBA0-6627E31A2566}"/>
+                <a16:creationId xmlns:a16="http://schemas.microsoft.com/office/drawing/2014/main" id="{51D24C3A-4FBC-45F8-AACD-B847795E2915}"/>
               </a:ext>
             </a:extLst>
           </p:cNvPr>
@@ -19363,7 +19465,7 @@
           <p:cNvPr id="2" name="">
             <a:extLst xmlns:a="http://schemas.openxmlformats.org/drawingml/2006/main">
               <a:ext uri="{FF2B5EF4-FFF2-40B4-BE49-F238E27FC236}">
-                <a16:creationId xmlns:a16="http://schemas.microsoft.com/office/drawing/2014/main" id="{3037875A-2368-49B9-BC49-4888BD34EAF7}"/>
+                <a16:creationId xmlns:a16="http://schemas.microsoft.com/office/drawing/2014/main" id="{6D08093E-701E-4997-A475-D4C9525266F7}"/>
               </a:ext>
             </a:extLst>
           </p:cNvPr>
@@ -19392,7 +19494,7 @@
           <p:cNvPr id="3" name="Uitlegvoorbeeld — niet uit het boek">
             <a:extLst xmlns:a="http://schemas.openxmlformats.org/drawingml/2006/main">
               <a:ext uri="{FF2B5EF4-FFF2-40B4-BE49-F238E27FC236}">
-                <a16:creationId xmlns:a16="http://schemas.microsoft.com/office/drawing/2014/main" id="{F8AB72AD-3810-427B-BE06-32B1BB06C2AF}"/>
+                <a16:creationId xmlns:a16="http://schemas.microsoft.com/office/drawing/2014/main" id="{18ECEABA-1C59-4086-A69F-946154E7A48C}"/>
               </a:ext>
             </a:extLst>
           </p:cNvPr>
@@ -19449,7 +19551,7 @@
           <p:cNvPr id="4" name="12">
             <a:extLst xmlns:a="http://schemas.openxmlformats.org/drawingml/2006/main">
               <a:ext uri="{FF2B5EF4-FFF2-40B4-BE49-F238E27FC236}">
-                <a16:creationId xmlns:a16="http://schemas.microsoft.com/office/drawing/2014/main" id="{AAA828BA-6FB6-4CB3-B5A8-E458C30033C5}"/>
+                <a16:creationId xmlns:a16="http://schemas.microsoft.com/office/drawing/2014/main" id="{12E76204-4F11-4C97-9309-4DA15CA64A3A}"/>
               </a:ext>
             </a:extLst>
           </p:cNvPr>
@@ -19513,7 +19615,7 @@
         </p:xfrm>
         <a:graphic xmlns:a="http://schemas.openxmlformats.org/drawingml/2006/main">
           <a:graphicData uri="http://schemas.openxmlformats.org/drawingml/2006/chart">
-            <c:chart xmlns:r="http://schemas.openxmlformats.org/officeDocument/2006/relationships" xmlns:c="http://schemas.openxmlformats.org/drawingml/2006/chart" r:id="R87a0ca387ecb48dc"/>
+            <c:chart xmlns:r="http://schemas.openxmlformats.org/officeDocument/2006/relationships" xmlns:c="http://schemas.openxmlformats.org/drawingml/2006/chart" r:id="R60649e7fe7fa4369"/>
           </a:graphicData>
         </a:graphic>
       </p:graphicFrame>
@@ -19522,7 +19624,7 @@
           <p:cNvPr id="6" name="PS">
             <a:extLst xmlns:a="http://schemas.openxmlformats.org/drawingml/2006/main">
               <a:ext uri="{FF2B5EF4-FFF2-40B4-BE49-F238E27FC236}">
-                <a16:creationId xmlns:a16="http://schemas.microsoft.com/office/drawing/2014/main" id="{68D633C0-F1CA-4C04-90E0-2408183D3B30}"/>
+                <a16:creationId xmlns:a16="http://schemas.microsoft.com/office/drawing/2014/main" id="{F7A3B510-A92A-401B-9718-5EEAC8A70DB7}"/>
               </a:ext>
             </a:extLst>
           </p:cNvPr>
@@ -19579,7 +19681,7 @@
           <p:cNvPr id="7" name="½ × basis × hoogte&#10;&#10;½ × 100 × (18 − 8)&#10;&#10;= € 500 per wee">
             <a:extLst xmlns:a="http://schemas.openxmlformats.org/drawingml/2006/main">
               <a:ext uri="{FF2B5EF4-FFF2-40B4-BE49-F238E27FC236}">
-                <a16:creationId xmlns:a16="http://schemas.microsoft.com/office/drawing/2014/main" id="{0A3CFE4E-C687-4C7C-B16C-70317F8E09FF}"/>
+                <a16:creationId xmlns:a16="http://schemas.microsoft.com/office/drawing/2014/main" id="{64497257-5036-45C8-B392-618127A1D865}"/>
               </a:ext>
             </a:extLst>
           </p:cNvPr>
@@ -19692,7 +19794,7 @@
           <p:cNvPr id="8" name="Onder Pp,&#10;boven A">
             <a:extLst xmlns:a="http://schemas.openxmlformats.org/drawingml/2006/main">
               <a:ext uri="{FF2B5EF4-FFF2-40B4-BE49-F238E27FC236}">
-                <a16:creationId xmlns:a16="http://schemas.microsoft.com/office/drawing/2014/main" id="{777AD0FE-1595-45C0-A1C1-C8A9738EDBD5}"/>
+                <a16:creationId xmlns:a16="http://schemas.microsoft.com/office/drawing/2014/main" id="{CE5A27CF-B7A4-4127-AD67-EA0E03B280D2}"/>
               </a:ext>
             </a:extLst>
           </p:cNvPr>
@@ -19770,7 +19872,7 @@
     </p:spTree>
     <p:extLst>
       <p:ext uri="{BB962C8B-B14F-4D97-AF65-F5344CB8AC3E}">
-        <p14:creationId xmlns:p14="http://schemas.microsoft.com/office/powerpoint/2010/main" val="272990387"/>
+        <p14:creationId xmlns:p14="http://schemas.microsoft.com/office/powerpoint/2010/main" val="994025624"/>
       </p:ext>
     </p:extLst>
   </p:cSld>
@@ -19801,7 +19903,7 @@
           <p:cNvPr id="8" name="De volledige welvaartsrekening">
             <a:extLst xmlns:a="http://schemas.openxmlformats.org/drawingml/2006/main">
               <a:ext uri="{FF2B5EF4-FFF2-40B4-BE49-F238E27FC236}">
-                <a16:creationId xmlns:a16="http://schemas.microsoft.com/office/drawing/2014/main" id="{2FC4CAE7-56CA-4B4E-B512-EC5A22239B56}"/>
+                <a16:creationId xmlns:a16="http://schemas.microsoft.com/office/drawing/2014/main" id="{C4FC4ED2-9431-47FC-AA36-45C0BB62B85F}"/>
               </a:ext>
             </a:extLst>
           </p:cNvPr>
@@ -19858,7 +19960,7 @@
           <p:cNvPr id="2" name="">
             <a:extLst xmlns:a="http://schemas.openxmlformats.org/drawingml/2006/main">
               <a:ext uri="{FF2B5EF4-FFF2-40B4-BE49-F238E27FC236}">
-                <a16:creationId xmlns:a16="http://schemas.microsoft.com/office/drawing/2014/main" id="{A5949265-0B38-44ED-B520-EE4F8449473E}"/>
+                <a16:creationId xmlns:a16="http://schemas.microsoft.com/office/drawing/2014/main" id="{C9122600-906C-4406-898B-E0F7DE63D8CC}"/>
               </a:ext>
             </a:extLst>
           </p:cNvPr>
@@ -19887,7 +19989,7 @@
           <p:cNvPr id="3" name="Uitlegvoorbeeld — niet uit het boek">
             <a:extLst xmlns:a="http://schemas.openxmlformats.org/drawingml/2006/main">
               <a:ext uri="{FF2B5EF4-FFF2-40B4-BE49-F238E27FC236}">
-                <a16:creationId xmlns:a16="http://schemas.microsoft.com/office/drawing/2014/main" id="{72485931-61D8-4054-81D6-E47ACC0395B2}"/>
+                <a16:creationId xmlns:a16="http://schemas.microsoft.com/office/drawing/2014/main" id="{A84BF08F-AE8D-46E8-98A1-1FBA77D8BAA2}"/>
               </a:ext>
             </a:extLst>
           </p:cNvPr>
@@ -19944,7 +20046,7 @@
           <p:cNvPr id="4" name="13">
             <a:extLst xmlns:a="http://schemas.openxmlformats.org/drawingml/2006/main">
               <a:ext uri="{FF2B5EF4-FFF2-40B4-BE49-F238E27FC236}">
-                <a16:creationId xmlns:a16="http://schemas.microsoft.com/office/drawing/2014/main" id="{168E43C5-A6C7-4B94-9671-BDCE9E53D4BA}"/>
+                <a16:creationId xmlns:a16="http://schemas.microsoft.com/office/drawing/2014/main" id="{29C93D1B-1E00-47C4-B1B5-70F4DD634A48}"/>
               </a:ext>
             </a:extLst>
           </p:cNvPr>
@@ -20394,7 +20496,7 @@
           <p:cNvPr id="6" name="CS en PS stijgen samen € 540. De overheid betaalt € 600">
             <a:extLst xmlns:a="http://schemas.openxmlformats.org/drawingml/2006/main">
               <a:ext uri="{FF2B5EF4-FFF2-40B4-BE49-F238E27FC236}">
-                <a16:creationId xmlns:a16="http://schemas.microsoft.com/office/drawing/2014/main" id="{49A339D3-2CED-4167-B68C-37198C564FBE}"/>
+                <a16:creationId xmlns:a16="http://schemas.microsoft.com/office/drawing/2014/main" id="{1131115A-347F-4DC4-B858-956DFA4E8FCA}"/>
               </a:ext>
             </a:extLst>
           </p:cNvPr>
@@ -20451,7 +20553,7 @@
           <p:cNvPr id="7" name="Welvaartsverlies: € 960 − € 900 = € 60 per week">
             <a:extLst xmlns:a="http://schemas.openxmlformats.org/drawingml/2006/main">
               <a:ext uri="{FF2B5EF4-FFF2-40B4-BE49-F238E27FC236}">
-                <a16:creationId xmlns:a16="http://schemas.microsoft.com/office/drawing/2014/main" id="{404AAB74-5A28-49E3-B45B-8E629734CBB0}"/>
+                <a16:creationId xmlns:a16="http://schemas.microsoft.com/office/drawing/2014/main" id="{77E8D378-A573-4323-9A8A-E64BE2FE351A}"/>
               </a:ext>
             </a:extLst>
           </p:cNvPr>
@@ -20506,7 +20608,7 @@
     </p:spTree>
     <p:extLst>
       <p:ext uri="{BB962C8B-B14F-4D97-AF65-F5344CB8AC3E}">
-        <p14:creationId xmlns:p14="http://schemas.microsoft.com/office/powerpoint/2010/main" val="664453116"/>
+        <p14:creationId xmlns:p14="http://schemas.microsoft.com/office/powerpoint/2010/main" val="1421103861"/>
       </p:ext>
     </p:extLst>
   </p:cSld>
@@ -20537,7 +20639,7 @@
           <p:cNvPr id="9" name="Extra handel kan voordeel kosten">
             <a:extLst xmlns:a="http://schemas.openxmlformats.org/drawingml/2006/main">
               <a:ext uri="{FF2B5EF4-FFF2-40B4-BE49-F238E27FC236}">
-                <a16:creationId xmlns:a16="http://schemas.microsoft.com/office/drawing/2014/main" id="{67A48F0F-5A84-458B-9013-92BB9F06D8D2}"/>
+                <a16:creationId xmlns:a16="http://schemas.microsoft.com/office/drawing/2014/main" id="{6ABED829-8C92-48E5-ACBD-78D918CC6394}"/>
               </a:ext>
             </a:extLst>
           </p:cNvPr>
@@ -20594,7 +20696,7 @@
           <p:cNvPr id="2" name="">
             <a:extLst xmlns:a="http://schemas.openxmlformats.org/drawingml/2006/main">
               <a:ext uri="{FF2B5EF4-FFF2-40B4-BE49-F238E27FC236}">
-                <a16:creationId xmlns:a16="http://schemas.microsoft.com/office/drawing/2014/main" id="{E80BC843-D4FF-4564-B96F-B0B429BE4DCB}"/>
+                <a16:creationId xmlns:a16="http://schemas.microsoft.com/office/drawing/2014/main" id="{BEC72DA4-85A9-420C-8C63-DAE133508647}"/>
               </a:ext>
             </a:extLst>
           </p:cNvPr>
@@ -20623,7 +20725,7 @@
           <p:cNvPr id="3" name="Uitlegvoorbeeld — niet uit het boek">
             <a:extLst xmlns:a="http://schemas.openxmlformats.org/drawingml/2006/main">
               <a:ext uri="{FF2B5EF4-FFF2-40B4-BE49-F238E27FC236}">
-                <a16:creationId xmlns:a16="http://schemas.microsoft.com/office/drawing/2014/main" id="{641D0A76-6BE3-4C23-857E-365598777D42}"/>
+                <a16:creationId xmlns:a16="http://schemas.microsoft.com/office/drawing/2014/main" id="{AA36BCA2-4D26-4342-A0E8-86516DD194D3}"/>
               </a:ext>
             </a:extLst>
           </p:cNvPr>
@@ -20680,7 +20782,7 @@
           <p:cNvPr id="4" name="14">
             <a:extLst xmlns:a="http://schemas.openxmlformats.org/drawingml/2006/main">
               <a:ext uri="{FF2B5EF4-FFF2-40B4-BE49-F238E27FC236}">
-                <a16:creationId xmlns:a16="http://schemas.microsoft.com/office/drawing/2014/main" id="{A3F6CBE3-0EDD-4A28-9DB9-37CC9A03D72C}"/>
+                <a16:creationId xmlns:a16="http://schemas.microsoft.com/office/drawing/2014/main" id="{A25A2BA4-3A12-453C-968F-EAD6DB6E46E7}"/>
               </a:ext>
             </a:extLst>
           </p:cNvPr>
@@ -20744,7 +20846,7 @@
         </p:xfrm>
         <a:graphic xmlns:a="http://schemas.openxmlformats.org/drawingml/2006/main">
           <a:graphicData uri="http://schemas.openxmlformats.org/drawingml/2006/chart">
-            <c:chart xmlns:r="http://schemas.openxmlformats.org/officeDocument/2006/relationships" xmlns:c="http://schemas.openxmlformats.org/drawingml/2006/chart" r:id="R745fc0cbfabf445d"/>
+            <c:chart xmlns:r="http://schemas.openxmlformats.org/officeDocument/2006/relationships" xmlns:c="http://schemas.openxmlformats.org/drawingml/2006/chart" r:id="R5cd7e5c034404b92"/>
           </a:graphicData>
         </a:graphic>
       </p:graphicFrame>
@@ -20753,7 +20855,7 @@
           <p:cNvPr id="6" name="Welvaartsverlies W">
             <a:extLst xmlns:a="http://schemas.openxmlformats.org/drawingml/2006/main">
               <a:ext uri="{FF2B5EF4-FFF2-40B4-BE49-F238E27FC236}">
-                <a16:creationId xmlns:a16="http://schemas.microsoft.com/office/drawing/2014/main" id="{2D1E5886-9117-4F7D-A1AB-ECA0CE980142}"/>
+                <a16:creationId xmlns:a16="http://schemas.microsoft.com/office/drawing/2014/main" id="{36DAB7B2-049F-464B-B6DB-645E98CE7DDD}"/>
               </a:ext>
             </a:extLst>
           </p:cNvPr>
@@ -20810,7 +20912,7 @@
           <p:cNvPr id="7" name="½ × (100 − 80) × 6&#10;= € 60 per week&#10;&#10;Bij Q = 90:&#10;waarde ">
             <a:extLst xmlns:a="http://schemas.openxmlformats.org/drawingml/2006/main">
               <a:ext uri="{FF2B5EF4-FFF2-40B4-BE49-F238E27FC236}">
-                <a16:creationId xmlns:a16="http://schemas.microsoft.com/office/drawing/2014/main" id="{BD23DD72-8623-43B6-9F57-F2CF28A2D888}"/>
+                <a16:creationId xmlns:a16="http://schemas.microsoft.com/office/drawing/2014/main" id="{891AAAD5-B7E4-45AB-A3AF-1C3424EEB6EB}"/>
               </a:ext>
             </a:extLst>
           </p:cNvPr>
@@ -20964,7 +21066,7 @@
           <p:cNvPr id="8" name="Geen externe baten&#10;in dit model">
             <a:extLst xmlns:a="http://schemas.openxmlformats.org/drawingml/2006/main">
               <a:ext uri="{FF2B5EF4-FFF2-40B4-BE49-F238E27FC236}">
-                <a16:creationId xmlns:a16="http://schemas.microsoft.com/office/drawing/2014/main" id="{64AC2CE5-84E9-4BB2-9643-15A00DE22135}"/>
+                <a16:creationId xmlns:a16="http://schemas.microsoft.com/office/drawing/2014/main" id="{E1012111-6DE3-4845-9BD6-7E241514C15A}"/>
               </a:ext>
             </a:extLst>
           </p:cNvPr>
@@ -21042,7 +21144,7 @@
     </p:spTree>
     <p:extLst>
       <p:ext uri="{BB962C8B-B14F-4D97-AF65-F5344CB8AC3E}">
-        <p14:creationId xmlns:p14="http://schemas.microsoft.com/office/powerpoint/2010/main" val="1683254950"/>
+        <p14:creationId xmlns:p14="http://schemas.microsoft.com/office/powerpoint/2010/main" val="1591370849"/>
       </p:ext>
     </p:extLst>
   </p:cSld>
@@ -21073,7 +21175,7 @@
           <p:cNvPr id="8" name="Korte controle">
             <a:extLst xmlns:a="http://schemas.openxmlformats.org/drawingml/2006/main">
               <a:ext uri="{FF2B5EF4-FFF2-40B4-BE49-F238E27FC236}">
-                <a16:creationId xmlns:a16="http://schemas.microsoft.com/office/drawing/2014/main" id="{DD53BABA-562A-4E74-A5C4-EF2DFE08F12C}"/>
+                <a16:creationId xmlns:a16="http://schemas.microsoft.com/office/drawing/2014/main" id="{BA25AC20-C9A0-4F52-B2D0-C32710344F29}"/>
               </a:ext>
             </a:extLst>
           </p:cNvPr>
@@ -21130,7 +21232,7 @@
           <p:cNvPr id="2" name="">
             <a:extLst xmlns:a="http://schemas.openxmlformats.org/drawingml/2006/main">
               <a:ext uri="{FF2B5EF4-FFF2-40B4-BE49-F238E27FC236}">
-                <a16:creationId xmlns:a16="http://schemas.microsoft.com/office/drawing/2014/main" id="{5129F5A0-E246-4FED-9F4E-0FDD784F8F14}"/>
+                <a16:creationId xmlns:a16="http://schemas.microsoft.com/office/drawing/2014/main" id="{B9408E12-FB4F-4114-8544-A3A4CCBB4D7E}"/>
               </a:ext>
             </a:extLst>
           </p:cNvPr>
@@ -21159,7 +21261,7 @@
           <p:cNvPr id="3" name="Uitlegvoorbeeld — niet uit het boek">
             <a:extLst xmlns:a="http://schemas.openxmlformats.org/drawingml/2006/main">
               <a:ext uri="{FF2B5EF4-FFF2-40B4-BE49-F238E27FC236}">
-                <a16:creationId xmlns:a16="http://schemas.microsoft.com/office/drawing/2014/main" id="{1C28AD46-EE22-4D9E-9BE4-EDBA276873E7}"/>
+                <a16:creationId xmlns:a16="http://schemas.microsoft.com/office/drawing/2014/main" id="{DA699008-3560-4FDB-9014-C5BCEB82C303}"/>
               </a:ext>
             </a:extLst>
           </p:cNvPr>
@@ -21216,7 +21318,7 @@
           <p:cNvPr id="4" name="15">
             <a:extLst xmlns:a="http://schemas.openxmlformats.org/drawingml/2006/main">
               <a:ext uri="{FF2B5EF4-FFF2-40B4-BE49-F238E27FC236}">
-                <a16:creationId xmlns:a16="http://schemas.microsoft.com/office/drawing/2014/main" id="{6DCD3C03-BACE-4186-87BA-8C119D087BEC}"/>
+                <a16:creationId xmlns:a16="http://schemas.microsoft.com/office/drawing/2014/main" id="{B4E93834-2C91-44FF-B020-CE85A8747EE3}"/>
               </a:ext>
             </a:extLst>
           </p:cNvPr>
@@ -21273,7 +21375,7 @@
           <p:cNvPr id="5" name="Welke hoeveelheid gebruik je bij U: 20 of 100?">
             <a:extLst xmlns:a="http://schemas.openxmlformats.org/drawingml/2006/main">
               <a:ext uri="{FF2B5EF4-FFF2-40B4-BE49-F238E27FC236}">
-                <a16:creationId xmlns:a16="http://schemas.microsoft.com/office/drawing/2014/main" id="{6B4D5BBE-BE14-48AE-91A0-D1B91F7DFD3F}"/>
+                <a16:creationId xmlns:a16="http://schemas.microsoft.com/office/drawing/2014/main" id="{506FE1FE-267E-4D2F-91FF-7E76A0AE44BD}"/>
               </a:ext>
             </a:extLst>
           </p:cNvPr>
@@ -21330,7 +21432,7 @@
           <p:cNvPr id="6" name="Welke prijs gebruik je voor CS? En voor PS?">
             <a:extLst xmlns:a="http://schemas.openxmlformats.org/drawingml/2006/main">
               <a:ext uri="{FF2B5EF4-FFF2-40B4-BE49-F238E27FC236}">
-                <a16:creationId xmlns:a16="http://schemas.microsoft.com/office/drawing/2014/main" id="{FE2B71F3-76B9-46B0-BE1A-D767DA079A7D}"/>
+                <a16:creationId xmlns:a16="http://schemas.microsoft.com/office/drawing/2014/main" id="{3487B605-254E-4E99-A7EB-520275F133B3}"/>
               </a:ext>
             </a:extLst>
           </p:cNvPr>
@@ -21387,7 +21489,7 @@
           <p:cNvPr id="7" name="Waarom zijn € 600 uitgaven en € 60 verlies verschillend">
             <a:extLst xmlns:a="http://schemas.openxmlformats.org/drawingml/2006/main">
               <a:ext uri="{FF2B5EF4-FFF2-40B4-BE49-F238E27FC236}">
-                <a16:creationId xmlns:a16="http://schemas.microsoft.com/office/drawing/2014/main" id="{42C7469E-A8BB-465B-ACB6-12FB895FCF35}"/>
+                <a16:creationId xmlns:a16="http://schemas.microsoft.com/office/drawing/2014/main" id="{D14D6E3C-BBBD-4639-AAF6-ABF8FA909188}"/>
               </a:ext>
             </a:extLst>
           </p:cNvPr>
@@ -21442,7 +21544,7 @@
     </p:spTree>
     <p:extLst>
       <p:ext uri="{BB962C8B-B14F-4D97-AF65-F5344CB8AC3E}">
-        <p14:creationId xmlns:p14="http://schemas.microsoft.com/office/powerpoint/2010/main" val="1538332976"/>
+        <p14:creationId xmlns:p14="http://schemas.microsoft.com/office/powerpoint/2010/main" val="1355648692"/>
       </p:ext>
     </p:extLst>
   </p:cSld>
@@ -21473,7 +21575,7 @@
           <p:cNvPr id="29" name="Deze les: §3.1.3 Subsidies">
             <a:extLst xmlns:a="http://schemas.openxmlformats.org/drawingml/2006/main">
               <a:ext uri="{FF2B5EF4-FFF2-40B4-BE49-F238E27FC236}">
-                <a16:creationId xmlns:a16="http://schemas.microsoft.com/office/drawing/2014/main" id="{0C725FFD-FB68-4DE8-ABC6-853DF27CE144}"/>
+                <a16:creationId xmlns:a16="http://schemas.microsoft.com/office/drawing/2014/main" id="{B86B5B7D-1C3D-426A-8CE6-6BE233909BAC}"/>
               </a:ext>
             </a:extLst>
           </p:cNvPr>
@@ -21530,7 +21632,7 @@
           <p:cNvPr id="2" name="">
             <a:extLst xmlns:a="http://schemas.openxmlformats.org/drawingml/2006/main">
               <a:ext uri="{FF2B5EF4-FFF2-40B4-BE49-F238E27FC236}">
-                <a16:creationId xmlns:a16="http://schemas.microsoft.com/office/drawing/2014/main" id="{1279FDEB-734B-42E9-9FB5-A4A6D86DB0E1}"/>
+                <a16:creationId xmlns:a16="http://schemas.microsoft.com/office/drawing/2014/main" id="{7C6AD415-72EC-497D-959F-0C53FF151659}"/>
               </a:ext>
             </a:extLst>
           </p:cNvPr>
@@ -21559,7 +21661,7 @@
           <p:cNvPr id="3" name="§3.1.3 Subsidies">
             <a:extLst xmlns:a="http://schemas.openxmlformats.org/drawingml/2006/main">
               <a:ext uri="{FF2B5EF4-FFF2-40B4-BE49-F238E27FC236}">
-                <a16:creationId xmlns:a16="http://schemas.microsoft.com/office/drawing/2014/main" id="{339FF8FD-9A0A-423D-82E6-2DB257299B80}"/>
+                <a16:creationId xmlns:a16="http://schemas.microsoft.com/office/drawing/2014/main" id="{9CBF70CE-C79E-4959-A651-09EA783605B6}"/>
               </a:ext>
             </a:extLst>
           </p:cNvPr>
@@ -21616,7 +21718,7 @@
           <p:cNvPr id="4" name="16">
             <a:extLst xmlns:a="http://schemas.openxmlformats.org/drawingml/2006/main">
               <a:ext uri="{FF2B5EF4-FFF2-40B4-BE49-F238E27FC236}">
-                <a16:creationId xmlns:a16="http://schemas.microsoft.com/office/drawing/2014/main" id="{7706210E-88F9-4941-A380-1224427C065F}"/>
+                <a16:creationId xmlns:a16="http://schemas.microsoft.com/office/drawing/2014/main" id="{2FC2C1A0-56C6-4FD8-8F33-9F17C7012962}"/>
               </a:ext>
             </a:extLst>
           </p:cNvPr>
@@ -21673,7 +21775,7 @@
           <p:cNvPr id="5" name="phase">
             <a:extLst xmlns:a="http://schemas.openxmlformats.org/drawingml/2006/main">
               <a:ext uri="{FF2B5EF4-FFF2-40B4-BE49-F238E27FC236}">
-                <a16:creationId xmlns:a16="http://schemas.microsoft.com/office/drawing/2014/main" id="{1FD1CF74-4D5A-4037-8655-2A710AF0D1F8}"/>
+                <a16:creationId xmlns:a16="http://schemas.microsoft.com/office/drawing/2014/main" id="{FB5095DA-125A-4CF2-99E1-E302FD990B57}"/>
               </a:ext>
             </a:extLst>
           </p:cNvPr>
@@ -21730,7 +21832,7 @@
           <p:cNvPr id="6" name="Lesroute">
             <a:extLst xmlns:a="http://schemas.openxmlformats.org/drawingml/2006/main">
               <a:ext uri="{FF2B5EF4-FFF2-40B4-BE49-F238E27FC236}">
-                <a16:creationId xmlns:a16="http://schemas.microsoft.com/office/drawing/2014/main" id="{39962D1F-AFC0-4283-97EA-F7A416910C27}"/>
+                <a16:creationId xmlns:a16="http://schemas.microsoft.com/office/drawing/2014/main" id="{6903DF62-7E13-4BE1-8AFA-1149F45F75F3}"/>
               </a:ext>
             </a:extLst>
           </p:cNvPr>
@@ -21787,7 +21889,7 @@
           <p:cNvPr id="7" name="route-number-0">
             <a:extLst xmlns:a="http://schemas.openxmlformats.org/drawingml/2006/main">
               <a:ext uri="{FF2B5EF4-FFF2-40B4-BE49-F238E27FC236}">
-                <a16:creationId xmlns:a16="http://schemas.microsoft.com/office/drawing/2014/main" id="{BC1F1BE1-F5ED-4E51-91A4-E675F741002A}"/>
+                <a16:creationId xmlns:a16="http://schemas.microsoft.com/office/drawing/2014/main" id="{EB696489-D52D-42B0-987E-0ED554ACA170}"/>
               </a:ext>
             </a:extLst>
           </p:cNvPr>
@@ -21844,7 +21946,7 @@
           <p:cNvPr id="8" name="route-0">
             <a:extLst xmlns:a="http://schemas.openxmlformats.org/drawingml/2006/main">
               <a:ext uri="{FF2B5EF4-FFF2-40B4-BE49-F238E27FC236}">
-                <a16:creationId xmlns:a16="http://schemas.microsoft.com/office/drawing/2014/main" id="{3F0F807A-64CD-4F80-878C-E1F41BA41E82}"/>
+                <a16:creationId xmlns:a16="http://schemas.microsoft.com/office/drawing/2014/main" id="{1B0D4586-3D55-41A0-AFE2-190C76395176}"/>
               </a:ext>
             </a:extLst>
           </p:cNvPr>
@@ -21901,7 +22003,7 @@
           <p:cNvPr id="9" name="route-number-1">
             <a:extLst xmlns:a="http://schemas.openxmlformats.org/drawingml/2006/main">
               <a:ext uri="{FF2B5EF4-FFF2-40B4-BE49-F238E27FC236}">
-                <a16:creationId xmlns:a16="http://schemas.microsoft.com/office/drawing/2014/main" id="{0C23E417-DEBB-4331-9C67-E057B4FF4F0A}"/>
+                <a16:creationId xmlns:a16="http://schemas.microsoft.com/office/drawing/2014/main" id="{BE726865-E193-4107-94A7-0EBCCE1C5DE9}"/>
               </a:ext>
             </a:extLst>
           </p:cNvPr>
@@ -21958,7 +22060,7 @@
           <p:cNvPr id="10" name="route-1">
             <a:extLst xmlns:a="http://schemas.openxmlformats.org/drawingml/2006/main">
               <a:ext uri="{FF2B5EF4-FFF2-40B4-BE49-F238E27FC236}">
-                <a16:creationId xmlns:a16="http://schemas.microsoft.com/office/drawing/2014/main" id="{D31D8230-ED5A-46AE-B8BC-E8A23C4DEEA2}"/>
+                <a16:creationId xmlns:a16="http://schemas.microsoft.com/office/drawing/2014/main" id="{6C208AFC-C156-4EBF-9E98-B70719385545}"/>
               </a:ext>
             </a:extLst>
           </p:cNvPr>
@@ -22015,7 +22117,7 @@
           <p:cNvPr id="11" name="route-number-2">
             <a:extLst xmlns:a="http://schemas.openxmlformats.org/drawingml/2006/main">
               <a:ext uri="{FF2B5EF4-FFF2-40B4-BE49-F238E27FC236}">
-                <a16:creationId xmlns:a16="http://schemas.microsoft.com/office/drawing/2014/main" id="{DC619071-A1DA-4B9F-A19A-E1D49FAA039E}"/>
+                <a16:creationId xmlns:a16="http://schemas.microsoft.com/office/drawing/2014/main" id="{2DE246BE-FD5B-43B0-AA91-3AD63959CE61}"/>
               </a:ext>
             </a:extLst>
           </p:cNvPr>
@@ -22072,7 +22174,7 @@
           <p:cNvPr id="12" name="route-2">
             <a:extLst xmlns:a="http://schemas.openxmlformats.org/drawingml/2006/main">
               <a:ext uri="{FF2B5EF4-FFF2-40B4-BE49-F238E27FC236}">
-                <a16:creationId xmlns:a16="http://schemas.microsoft.com/office/drawing/2014/main" id="{52BE12F1-45CE-4318-857A-0E300BF5FC0D}"/>
+                <a16:creationId xmlns:a16="http://schemas.microsoft.com/office/drawing/2014/main" id="{0A65A48E-6F8B-404E-B86D-0FF2A1A8C442}"/>
               </a:ext>
             </a:extLst>
           </p:cNvPr>
@@ -22129,7 +22231,7 @@
           <p:cNvPr id="13" name="route-number-3">
             <a:extLst xmlns:a="http://schemas.openxmlformats.org/drawingml/2006/main">
               <a:ext uri="{FF2B5EF4-FFF2-40B4-BE49-F238E27FC236}">
-                <a16:creationId xmlns:a16="http://schemas.microsoft.com/office/drawing/2014/main" id="{CF51D585-A9F4-466F-8AEC-B01DBEBC3460}"/>
+                <a16:creationId xmlns:a16="http://schemas.microsoft.com/office/drawing/2014/main" id="{033478C1-AF26-4C11-8149-BE697E4ADFE1}"/>
               </a:ext>
             </a:extLst>
           </p:cNvPr>
@@ -22186,7 +22288,7 @@
           <p:cNvPr id="14" name="route-3">
             <a:extLst xmlns:a="http://schemas.openxmlformats.org/drawingml/2006/main">
               <a:ext uri="{FF2B5EF4-FFF2-40B4-BE49-F238E27FC236}">
-                <a16:creationId xmlns:a16="http://schemas.microsoft.com/office/drawing/2014/main" id="{53F8728F-9EDC-480F-BAAC-059778C5CBB5}"/>
+                <a16:creationId xmlns:a16="http://schemas.microsoft.com/office/drawing/2014/main" id="{0AC88CFF-A409-448C-AA0E-6DF9BF2019BF}"/>
               </a:ext>
             </a:extLst>
           </p:cNvPr>
@@ -22243,7 +22345,7 @@
           <p:cNvPr id="15" name="route-number-4">
             <a:extLst xmlns:a="http://schemas.openxmlformats.org/drawingml/2006/main">
               <a:ext uri="{FF2B5EF4-FFF2-40B4-BE49-F238E27FC236}">
-                <a16:creationId xmlns:a16="http://schemas.microsoft.com/office/drawing/2014/main" id="{C6FDD1E4-A3D2-46C8-A70D-2071ABC6E583}"/>
+                <a16:creationId xmlns:a16="http://schemas.microsoft.com/office/drawing/2014/main" id="{10D5FEA4-7BCD-4916-8C28-2A032D5DE11C}"/>
               </a:ext>
             </a:extLst>
           </p:cNvPr>
@@ -22300,7 +22402,7 @@
           <p:cNvPr id="16" name="route-4">
             <a:extLst xmlns:a="http://schemas.openxmlformats.org/drawingml/2006/main">
               <a:ext uri="{FF2B5EF4-FFF2-40B4-BE49-F238E27FC236}">
-                <a16:creationId xmlns:a16="http://schemas.microsoft.com/office/drawing/2014/main" id="{9B184F0D-1780-44F0-821D-C6A464D0D0B5}"/>
+                <a16:creationId xmlns:a16="http://schemas.microsoft.com/office/drawing/2014/main" id="{E7A74FA6-CAA9-4A72-8963-A067011E63CC}"/>
               </a:ext>
             </a:extLst>
           </p:cNvPr>
@@ -22357,7 +22459,7 @@
           <p:cNvPr id="17" name="route-number-5">
             <a:extLst xmlns:a="http://schemas.openxmlformats.org/drawingml/2006/main">
               <a:ext uri="{FF2B5EF4-FFF2-40B4-BE49-F238E27FC236}">
-                <a16:creationId xmlns:a16="http://schemas.microsoft.com/office/drawing/2014/main" id="{1C55B70D-FCE7-4DB4-AB6A-B370586FFB25}"/>
+                <a16:creationId xmlns:a16="http://schemas.microsoft.com/office/drawing/2014/main" id="{BFC53041-1CFB-4461-8E96-78B09C9D2B5C}"/>
               </a:ext>
             </a:extLst>
           </p:cNvPr>
@@ -22414,7 +22516,7 @@
           <p:cNvPr id="18" name="route-5">
             <a:extLst xmlns:a="http://schemas.openxmlformats.org/drawingml/2006/main">
               <a:ext uri="{FF2B5EF4-FFF2-40B4-BE49-F238E27FC236}">
-                <a16:creationId xmlns:a16="http://schemas.microsoft.com/office/drawing/2014/main" id="{7271238B-4A64-4015-84EF-7A830E49A69A}"/>
+                <a16:creationId xmlns:a16="http://schemas.microsoft.com/office/drawing/2014/main" id="{A6F1E379-F69D-474B-B252-415038D4E1E6}"/>
               </a:ext>
             </a:extLst>
           </p:cNvPr>
@@ -22471,7 +22573,7 @@
           <p:cNvPr id="19" name="route-number-6">
             <a:extLst xmlns:a="http://schemas.openxmlformats.org/drawingml/2006/main">
               <a:ext uri="{FF2B5EF4-FFF2-40B4-BE49-F238E27FC236}">
-                <a16:creationId xmlns:a16="http://schemas.microsoft.com/office/drawing/2014/main" id="{529D53A3-7F88-438C-9DCE-A50B263E1109}"/>
+                <a16:creationId xmlns:a16="http://schemas.microsoft.com/office/drawing/2014/main" id="{547AA5EA-A18F-4167-A0AE-8915317571A4}"/>
               </a:ext>
             </a:extLst>
           </p:cNvPr>
@@ -22528,7 +22630,7 @@
           <p:cNvPr id="20" name="route-6">
             <a:extLst xmlns:a="http://schemas.openxmlformats.org/drawingml/2006/main">
               <a:ext uri="{FF2B5EF4-FFF2-40B4-BE49-F238E27FC236}">
-                <a16:creationId xmlns:a16="http://schemas.microsoft.com/office/drawing/2014/main" id="{373A3381-E019-483E-A33B-94F73BFAF6BC}"/>
+                <a16:creationId xmlns:a16="http://schemas.microsoft.com/office/drawing/2014/main" id="{B3B4731A-5DB3-4841-A696-A08148036D9B}"/>
               </a:ext>
             </a:extLst>
           </p:cNvPr>
@@ -22585,7 +22687,7 @@
           <p:cNvPr id="21" name="Lesdoelen">
             <a:extLst xmlns:a="http://schemas.openxmlformats.org/drawingml/2006/main">
               <a:ext uri="{FF2B5EF4-FFF2-40B4-BE49-F238E27FC236}">
-                <a16:creationId xmlns:a16="http://schemas.microsoft.com/office/drawing/2014/main" id="{278BE1A1-2AAA-43E2-B033-2559BB77C39F}"/>
+                <a16:creationId xmlns:a16="http://schemas.microsoft.com/office/drawing/2014/main" id="{A5117C64-3FC2-444C-8E05-1A58E6AAE40D}"/>
               </a:ext>
             </a:extLst>
           </p:cNvPr>
@@ -22642,7 +22744,7 @@
           <p:cNvPr id="22" name="overview-goals">
             <a:extLst xmlns:a="http://schemas.openxmlformats.org/drawingml/2006/main">
               <a:ext uri="{FF2B5EF4-FFF2-40B4-BE49-F238E27FC236}">
-                <a16:creationId xmlns:a16="http://schemas.microsoft.com/office/drawing/2014/main" id="{E942A611-81E6-457B-AB19-C53DAFA7A303}"/>
+                <a16:creationId xmlns:a16="http://schemas.microsoft.com/office/drawing/2014/main" id="{211B92F3-49F3-44B8-B881-7944F7073279}"/>
               </a:ext>
             </a:extLst>
           </p:cNvPr>
@@ -22745,7 +22847,7 @@
           <p:cNvPr id="23" name="">
             <a:extLst xmlns:a="http://schemas.openxmlformats.org/drawingml/2006/main">
               <a:ext uri="{FF2B5EF4-FFF2-40B4-BE49-F238E27FC236}">
-                <a16:creationId xmlns:a16="http://schemas.microsoft.com/office/drawing/2014/main" id="{52E5B33B-9FAC-46A1-BD23-85FF22FBEBD3}"/>
+                <a16:creationId xmlns:a16="http://schemas.microsoft.com/office/drawing/2014/main" id="{5B5812BD-4088-441C-A837-8F863F8F5256}"/>
               </a:ext>
             </a:extLst>
           </p:cNvPr>
@@ -22774,7 +22876,7 @@
           <p:cNvPr id="24" name="Startopdracht">
             <a:extLst xmlns:a="http://schemas.openxmlformats.org/drawingml/2006/main">
               <a:ext uri="{FF2B5EF4-FFF2-40B4-BE49-F238E27FC236}">
-                <a16:creationId xmlns:a16="http://schemas.microsoft.com/office/drawing/2014/main" id="{4C523FE0-0BCE-48B9-9FB3-49AC73CA94AC}"/>
+                <a16:creationId xmlns:a16="http://schemas.microsoft.com/office/drawing/2014/main" id="{5CA50DF5-54CC-4C17-9774-79965F93E6C9}"/>
               </a:ext>
             </a:extLst>
           </p:cNvPr>
@@ -22831,7 +22933,7 @@
           <p:cNvPr id="25" name="overview-start">
             <a:extLst xmlns:a="http://schemas.openxmlformats.org/drawingml/2006/main">
               <a:ext uri="{FF2B5EF4-FFF2-40B4-BE49-F238E27FC236}">
-                <a16:creationId xmlns:a16="http://schemas.microsoft.com/office/drawing/2014/main" id="{DA9D37B6-E78E-409E-8F78-B249720CD1AF}"/>
+                <a16:creationId xmlns:a16="http://schemas.microsoft.com/office/drawing/2014/main" id="{912807B8-7DAD-4FE3-B679-3BE0927974EF}"/>
               </a:ext>
             </a:extLst>
           </p:cNvPr>
@@ -22934,7 +23036,7 @@
           <p:cNvPr id="26" name="">
             <a:extLst xmlns:a="http://schemas.openxmlformats.org/drawingml/2006/main">
               <a:ext uri="{FF2B5EF4-FFF2-40B4-BE49-F238E27FC236}">
-                <a16:creationId xmlns:a16="http://schemas.microsoft.com/office/drawing/2014/main" id="{F5C26DB2-43A0-41B8-9ABA-D25022EF183B}"/>
+                <a16:creationId xmlns:a16="http://schemas.microsoft.com/office/drawing/2014/main" id="{C2A5DC5D-2B12-4A33-8480-6FC0A91711C0}"/>
               </a:ext>
             </a:extLst>
           </p:cNvPr>
@@ -22963,7 +23065,7 @@
           <p:cNvPr id="27" name="Huiswerk">
             <a:extLst xmlns:a="http://schemas.openxmlformats.org/drawingml/2006/main">
               <a:ext uri="{FF2B5EF4-FFF2-40B4-BE49-F238E27FC236}">
-                <a16:creationId xmlns:a16="http://schemas.microsoft.com/office/drawing/2014/main" id="{19F9F9D8-9BC9-4D8D-A2F4-A942FA68B8C8}"/>
+                <a16:creationId xmlns:a16="http://schemas.microsoft.com/office/drawing/2014/main" id="{7D862A64-9566-40D5-81EC-B8D61718B54E}"/>
               </a:ext>
             </a:extLst>
           </p:cNvPr>
@@ -23020,7 +23122,7 @@
           <p:cNvPr id="28" name="overview-homework">
             <a:extLst xmlns:a="http://schemas.openxmlformats.org/drawingml/2006/main">
               <a:ext uri="{FF2B5EF4-FFF2-40B4-BE49-F238E27FC236}">
-                <a16:creationId xmlns:a16="http://schemas.microsoft.com/office/drawing/2014/main" id="{2A8D0C9D-047F-4BBE-8F32-189AFFED7766}"/>
+                <a16:creationId xmlns:a16="http://schemas.microsoft.com/office/drawing/2014/main" id="{88CBF3EF-91EE-4BB2-A286-F8FA4B8B6C2A}"/>
               </a:ext>
             </a:extLst>
           </p:cNvPr>
@@ -23167,7 +23269,7 @@
     </p:spTree>
     <p:extLst>
       <p:ext uri="{BB962C8B-B14F-4D97-AF65-F5344CB8AC3E}">
-        <p14:creationId xmlns:p14="http://schemas.microsoft.com/office/powerpoint/2010/main" val="1839411089"/>
+        <p14:creationId xmlns:p14="http://schemas.microsoft.com/office/powerpoint/2010/main" val="316076195"/>
       </p:ext>
     </p:extLst>
   </p:cSld>
@@ -23198,7 +23300,7 @@
           <p:cNvPr id="10" name="Opgave 25 · Cursusplaatsen">
             <a:extLst xmlns:a="http://schemas.openxmlformats.org/drawingml/2006/main">
               <a:ext uri="{FF2B5EF4-FFF2-40B4-BE49-F238E27FC236}">
-                <a16:creationId xmlns:a16="http://schemas.microsoft.com/office/drawing/2014/main" id="{46247084-E734-447B-B233-7B5E1E51A75D}"/>
+                <a16:creationId xmlns:a16="http://schemas.microsoft.com/office/drawing/2014/main" id="{26258F33-886A-4031-B7D8-0431A858C8E0}"/>
               </a:ext>
             </a:extLst>
           </p:cNvPr>
@@ -23255,7 +23357,7 @@
           <p:cNvPr id="2" name="">
             <a:extLst xmlns:a="http://schemas.openxmlformats.org/drawingml/2006/main">
               <a:ext uri="{FF2B5EF4-FFF2-40B4-BE49-F238E27FC236}">
-                <a16:creationId xmlns:a16="http://schemas.microsoft.com/office/drawing/2014/main" id="{7F888256-8DA2-49C4-9268-14FA8432E130}"/>
+                <a16:creationId xmlns:a16="http://schemas.microsoft.com/office/drawing/2014/main" id="{57CDA291-AFDD-483D-9716-F14B9CA7D733}"/>
               </a:ext>
             </a:extLst>
           </p:cNvPr>
@@ -23284,7 +23386,7 @@
           <p:cNvPr id="3" name="§3.1.3 Subsidies">
             <a:extLst xmlns:a="http://schemas.openxmlformats.org/drawingml/2006/main">
               <a:ext uri="{FF2B5EF4-FFF2-40B4-BE49-F238E27FC236}">
-                <a16:creationId xmlns:a16="http://schemas.microsoft.com/office/drawing/2014/main" id="{90E41BE0-7B8A-4A52-A7EA-C70ECA595819}"/>
+                <a16:creationId xmlns:a16="http://schemas.microsoft.com/office/drawing/2014/main" id="{D425550E-59E2-4431-AFCD-C18CB2C8BCA1}"/>
               </a:ext>
             </a:extLst>
           </p:cNvPr>
@@ -23341,7 +23443,7 @@
           <p:cNvPr id="4" name="17">
             <a:extLst xmlns:a="http://schemas.openxmlformats.org/drawingml/2006/main">
               <a:ext uri="{FF2B5EF4-FFF2-40B4-BE49-F238E27FC236}">
-                <a16:creationId xmlns:a16="http://schemas.microsoft.com/office/drawing/2014/main" id="{DFD5CE76-A61A-42C4-8B40-8BD122F858CE}"/>
+                <a16:creationId xmlns:a16="http://schemas.microsoft.com/office/drawing/2014/main" id="{BE390C3D-91EE-4903-9C75-41B2F0CF4B4A}"/>
               </a:ext>
             </a:extLst>
           </p:cNvPr>
@@ -23398,7 +23500,7 @@
           <p:cNvPr id="5" name="Boekpagina 30 · Gegevens">
             <a:extLst xmlns:a="http://schemas.openxmlformats.org/drawingml/2006/main">
               <a:ext uri="{FF2B5EF4-FFF2-40B4-BE49-F238E27FC236}">
-                <a16:creationId xmlns:a16="http://schemas.microsoft.com/office/drawing/2014/main" id="{1165B129-FECD-46F7-B121-F689033C6E51}"/>
+                <a16:creationId xmlns:a16="http://schemas.microsoft.com/office/drawing/2014/main" id="{10B1D162-376B-4295-89AA-9B77EBA2DC66}"/>
               </a:ext>
             </a:extLst>
           </p:cNvPr>
@@ -23455,7 +23557,7 @@
           <p:cNvPr id="6" name="Vraag Pc = 26 − 0,20Q; aanbod Pp = 8 + 0,10Q">
             <a:extLst xmlns:a="http://schemas.openxmlformats.org/drawingml/2006/main">
               <a:ext uri="{FF2B5EF4-FFF2-40B4-BE49-F238E27FC236}">
-                <a16:creationId xmlns:a16="http://schemas.microsoft.com/office/drawing/2014/main" id="{8D09B141-F2CB-4BA9-ACD8-902DB6F66694}"/>
+                <a16:creationId xmlns:a16="http://schemas.microsoft.com/office/drawing/2014/main" id="{D6C304FF-2F3C-4966-A765-2B98E62E4E1A}"/>
               </a:ext>
             </a:extLst>
           </p:cNvPr>
@@ -23512,7 +23614,7 @@
           <p:cNvPr id="7" name="Q is cursusplaatsen per week.">
             <a:extLst xmlns:a="http://schemas.openxmlformats.org/drawingml/2006/main">
               <a:ext uri="{FF2B5EF4-FFF2-40B4-BE49-F238E27FC236}">
-                <a16:creationId xmlns:a16="http://schemas.microsoft.com/office/drawing/2014/main" id="{FA67D363-280B-40A6-BF8E-01E8BB02EE34}"/>
+                <a16:creationId xmlns:a16="http://schemas.microsoft.com/office/drawing/2014/main" id="{FE01EFCF-AA83-489C-A6C2-9EDFB9539904}"/>
               </a:ext>
             </a:extLst>
           </p:cNvPr>
@@ -23569,7 +23671,7 @@
           <p:cNvPr id="8" name="Eerst: Q₀ = 60, P₀ = € 14, CS = € 360 en PS = € 180 per">
             <a:extLst xmlns:a="http://schemas.openxmlformats.org/drawingml/2006/main">
               <a:ext uri="{FF2B5EF4-FFF2-40B4-BE49-F238E27FC236}">
-                <a16:creationId xmlns:a16="http://schemas.microsoft.com/office/drawing/2014/main" id="{686713F3-FD09-4475-AD49-CE832C5EB28A}"/>
+                <a16:creationId xmlns:a16="http://schemas.microsoft.com/office/drawing/2014/main" id="{31282B7D-07E2-450D-A716-E4FDAE7FA29F}"/>
               </a:ext>
             </a:extLst>
           </p:cNvPr>
@@ -23626,7 +23728,7 @@
           <p:cNvPr id="9" name="Aanbieders ontvangen € 3 subsidie per werkelijk verkoch">
             <a:extLst xmlns:a="http://schemas.openxmlformats.org/drawingml/2006/main">
               <a:ext uri="{FF2B5EF4-FFF2-40B4-BE49-F238E27FC236}">
-                <a16:creationId xmlns:a16="http://schemas.microsoft.com/office/drawing/2014/main" id="{C7464013-6938-41B1-9773-D51E163E60EA}"/>
+                <a16:creationId xmlns:a16="http://schemas.microsoft.com/office/drawing/2014/main" id="{9EC706CE-3C2B-4AE1-AE10-77058345F06E}"/>
               </a:ext>
             </a:extLst>
           </p:cNvPr>
@@ -23704,7 +23806,7 @@
     </p:spTree>
     <p:extLst>
       <p:ext uri="{BB962C8B-B14F-4D97-AF65-F5344CB8AC3E}">
-        <p14:creationId xmlns:p14="http://schemas.microsoft.com/office/powerpoint/2010/main" val="788222334"/>
+        <p14:creationId xmlns:p14="http://schemas.microsoft.com/office/powerpoint/2010/main" val="1344361946"/>
       </p:ext>
     </p:extLst>
   </p:cSld>
@@ -23735,7 +23837,7 @@
           <p:cNvPr id="8" name="Opgave 25 · Vragen a–c">
             <a:extLst xmlns:a="http://schemas.openxmlformats.org/drawingml/2006/main">
               <a:ext uri="{FF2B5EF4-FFF2-40B4-BE49-F238E27FC236}">
-                <a16:creationId xmlns:a16="http://schemas.microsoft.com/office/drawing/2014/main" id="{CF1D34F1-F8E8-4655-89C2-E29C77C54DBB}"/>
+                <a16:creationId xmlns:a16="http://schemas.microsoft.com/office/drawing/2014/main" id="{5DEF8410-0812-43EF-8E22-303F039F3DFB}"/>
               </a:ext>
             </a:extLst>
           </p:cNvPr>
@@ -23792,7 +23894,7 @@
           <p:cNvPr id="2" name="">
             <a:extLst xmlns:a="http://schemas.openxmlformats.org/drawingml/2006/main">
               <a:ext uri="{FF2B5EF4-FFF2-40B4-BE49-F238E27FC236}">
-                <a16:creationId xmlns:a16="http://schemas.microsoft.com/office/drawing/2014/main" id="{50908793-9840-40FC-8150-C1EBDC137718}"/>
+                <a16:creationId xmlns:a16="http://schemas.microsoft.com/office/drawing/2014/main" id="{C666A8AE-2B32-41A7-8DCA-B0E38FD6172C}"/>
               </a:ext>
             </a:extLst>
           </p:cNvPr>
@@ -23821,7 +23923,7 @@
           <p:cNvPr id="3" name="§3.1.3 Subsidies">
             <a:extLst xmlns:a="http://schemas.openxmlformats.org/drawingml/2006/main">
               <a:ext uri="{FF2B5EF4-FFF2-40B4-BE49-F238E27FC236}">
-                <a16:creationId xmlns:a16="http://schemas.microsoft.com/office/drawing/2014/main" id="{90280183-5885-4787-A76B-E4F6BE20F443}"/>
+                <a16:creationId xmlns:a16="http://schemas.microsoft.com/office/drawing/2014/main" id="{1C9C2DA2-5C96-4CE8-A39A-BADC87B3FDAF}"/>
               </a:ext>
             </a:extLst>
           </p:cNvPr>
@@ -23878,7 +23980,7 @@
           <p:cNvPr id="4" name="18">
             <a:extLst xmlns:a="http://schemas.openxmlformats.org/drawingml/2006/main">
               <a:ext uri="{FF2B5EF4-FFF2-40B4-BE49-F238E27FC236}">
-                <a16:creationId xmlns:a16="http://schemas.microsoft.com/office/drawing/2014/main" id="{0047B69E-2241-42D7-AEFB-E39CC0D0E477}"/>
+                <a16:creationId xmlns:a16="http://schemas.microsoft.com/office/drawing/2014/main" id="{086E747C-88BC-492F-A1B9-5876BC7DEF36}"/>
               </a:ext>
             </a:extLst>
           </p:cNvPr>
@@ -23935,7 +24037,7 @@
           <p:cNvPr id="5" name="a. Stel het aanbod in kopersprijzen mét subsidie op.&#10;  ">
             <a:extLst xmlns:a="http://schemas.openxmlformats.org/drawingml/2006/main">
               <a:ext uri="{FF2B5EF4-FFF2-40B4-BE49-F238E27FC236}">
-                <a16:creationId xmlns:a16="http://schemas.microsoft.com/office/drawing/2014/main" id="{E29FFDB6-B45D-41B2-902F-BB18D40D792F}"/>
+                <a16:creationId xmlns:a16="http://schemas.microsoft.com/office/drawing/2014/main" id="{76627718-1235-4BF3-83E1-2A95597292B3}"/>
               </a:ext>
             </a:extLst>
           </p:cNvPr>
@@ -24015,7 +24117,7 @@
           <p:cNvPr id="6" name="b. Bereken de overheidsuitgaven per week.">
             <a:extLst xmlns:a="http://schemas.openxmlformats.org/drawingml/2006/main">
               <a:ext uri="{FF2B5EF4-FFF2-40B4-BE49-F238E27FC236}">
-                <a16:creationId xmlns:a16="http://schemas.microsoft.com/office/drawing/2014/main" id="{F5492630-1AEE-4942-AF0E-EA624545DBED}"/>
+                <a16:creationId xmlns:a16="http://schemas.microsoft.com/office/drawing/2014/main" id="{6D96C3CA-4BB4-400E-953E-53EBA94D7C1C}"/>
               </a:ext>
             </a:extLst>
           </p:cNvPr>
@@ -24072,7 +24174,7 @@
           <p:cNvPr id="7" name="c. Bereken het voordeel per plaats voor kopers en aanbi">
             <a:extLst xmlns:a="http://schemas.openxmlformats.org/drawingml/2006/main">
               <a:ext uri="{FF2B5EF4-FFF2-40B4-BE49-F238E27FC236}">
-                <a16:creationId xmlns:a16="http://schemas.microsoft.com/office/drawing/2014/main" id="{FA76FB94-4E5A-4157-B6DF-7B768FF5246E}"/>
+                <a16:creationId xmlns:a16="http://schemas.microsoft.com/office/drawing/2014/main" id="{36E178C8-4A41-4D36-A6B8-3A1EF103F7B9}"/>
               </a:ext>
             </a:extLst>
           </p:cNvPr>
@@ -24173,7 +24275,7 @@
     </p:spTree>
     <p:extLst>
       <p:ext uri="{BB962C8B-B14F-4D97-AF65-F5344CB8AC3E}">
-        <p14:creationId xmlns:p14="http://schemas.microsoft.com/office/powerpoint/2010/main" val="8836743"/>
+        <p14:creationId xmlns:p14="http://schemas.microsoft.com/office/powerpoint/2010/main" val="355225519"/>
       </p:ext>
     </p:extLst>
   </p:cSld>
@@ -24204,7 +24306,7 @@
           <p:cNvPr id="7" name="Opgave 25 · Vragen d–e">
             <a:extLst xmlns:a="http://schemas.openxmlformats.org/drawingml/2006/main">
               <a:ext uri="{FF2B5EF4-FFF2-40B4-BE49-F238E27FC236}">
-                <a16:creationId xmlns:a16="http://schemas.microsoft.com/office/drawing/2014/main" id="{B9FA4487-88F2-4E14-9162-46A3A2E1D46C}"/>
+                <a16:creationId xmlns:a16="http://schemas.microsoft.com/office/drawing/2014/main" id="{A4738082-AFCC-4506-886B-8D8245D32E94}"/>
               </a:ext>
             </a:extLst>
           </p:cNvPr>
@@ -24261,7 +24363,7 @@
           <p:cNvPr id="2" name="">
             <a:extLst xmlns:a="http://schemas.openxmlformats.org/drawingml/2006/main">
               <a:ext uri="{FF2B5EF4-FFF2-40B4-BE49-F238E27FC236}">
-                <a16:creationId xmlns:a16="http://schemas.microsoft.com/office/drawing/2014/main" id="{BA6DA1F1-8037-4FDC-A853-ADC30BFD7EB5}"/>
+                <a16:creationId xmlns:a16="http://schemas.microsoft.com/office/drawing/2014/main" id="{97EC23D0-A834-491C-82DB-A466865BCAA2}"/>
               </a:ext>
             </a:extLst>
           </p:cNvPr>
@@ -24290,7 +24392,7 @@
           <p:cNvPr id="3" name="§3.1.3 Subsidies">
             <a:extLst xmlns:a="http://schemas.openxmlformats.org/drawingml/2006/main">
               <a:ext uri="{FF2B5EF4-FFF2-40B4-BE49-F238E27FC236}">
-                <a16:creationId xmlns:a16="http://schemas.microsoft.com/office/drawing/2014/main" id="{78C4FD7A-0AFC-478A-A21F-ED971F45EFE3}"/>
+                <a16:creationId xmlns:a16="http://schemas.microsoft.com/office/drawing/2014/main" id="{CB989CE0-C02E-4FC5-BD64-89E0AC95A7D4}"/>
               </a:ext>
             </a:extLst>
           </p:cNvPr>
@@ -24347,7 +24449,7 @@
           <p:cNvPr id="4" name="19">
             <a:extLst xmlns:a="http://schemas.openxmlformats.org/drawingml/2006/main">
               <a:ext uri="{FF2B5EF4-FFF2-40B4-BE49-F238E27FC236}">
-                <a16:creationId xmlns:a16="http://schemas.microsoft.com/office/drawing/2014/main" id="{9914EC17-B6EA-4071-9E7C-31C8576D6C1E}"/>
+                <a16:creationId xmlns:a16="http://schemas.microsoft.com/office/drawing/2014/main" id="{B0072C76-C970-46A5-A6AF-995494A63A7C}"/>
               </a:ext>
             </a:extLst>
           </p:cNvPr>
@@ -24404,7 +24506,7 @@
           <p:cNvPr id="5" name="d. Bereken CS en PS na subsidie. Bepaal CS + PS − U en ">
             <a:extLst xmlns:a="http://schemas.openxmlformats.org/drawingml/2006/main">
               <a:ext uri="{FF2B5EF4-FFF2-40B4-BE49-F238E27FC236}">
-                <a16:creationId xmlns:a16="http://schemas.microsoft.com/office/drawing/2014/main" id="{AB10E13F-DA3F-4CD3-BFB9-9295823B227D}"/>
+                <a16:creationId xmlns:a16="http://schemas.microsoft.com/office/drawing/2014/main" id="{FCFDE1A2-E382-432E-A476-8FE65569ADFE}"/>
               </a:ext>
             </a:extLst>
           </p:cNvPr>
@@ -24484,7 +24586,7 @@
           <p:cNvPr id="6" name="e. Markeer Qsub, Pc en Pp in de basisgrafiek.&#10;    Arcee">
             <a:extLst xmlns:a="http://schemas.openxmlformats.org/drawingml/2006/main">
               <a:ext uri="{FF2B5EF4-FFF2-40B4-BE49-F238E27FC236}">
-                <a16:creationId xmlns:a16="http://schemas.microsoft.com/office/drawing/2014/main" id="{BB625C96-69A6-4A22-AC3C-8A00BD3FC5BF}"/>
+                <a16:creationId xmlns:a16="http://schemas.microsoft.com/office/drawing/2014/main" id="{D7C1381F-6244-44DD-AA5A-CDD7B04EE20C}"/>
               </a:ext>
             </a:extLst>
           </p:cNvPr>
@@ -24608,7 +24710,7 @@
     </p:spTree>
     <p:extLst>
       <p:ext uri="{BB962C8B-B14F-4D97-AF65-F5344CB8AC3E}">
-        <p14:creationId xmlns:p14="http://schemas.microsoft.com/office/powerpoint/2010/main" val="773865472"/>
+        <p14:creationId xmlns:p14="http://schemas.microsoft.com/office/powerpoint/2010/main" val="1049994742"/>
       </p:ext>
     </p:extLst>
   </p:cSld>
@@ -24639,7 +24741,7 @@
           <p:cNvPr id="7" name="De subsidiewig">
             <a:extLst xmlns:a="http://schemas.openxmlformats.org/drawingml/2006/main">
               <a:ext uri="{FF2B5EF4-FFF2-40B4-BE49-F238E27FC236}">
-                <a16:creationId xmlns:a16="http://schemas.microsoft.com/office/drawing/2014/main" id="{A06FD2F2-3C15-447D-BFAF-917624FCDAF3}"/>
+                <a16:creationId xmlns:a16="http://schemas.microsoft.com/office/drawing/2014/main" id="{576D6D41-9231-4E68-8AD8-C2250F726735}"/>
               </a:ext>
             </a:extLst>
           </p:cNvPr>
@@ -24696,7 +24798,7 @@
           <p:cNvPr id="2" name="">
             <a:extLst xmlns:a="http://schemas.openxmlformats.org/drawingml/2006/main">
               <a:ext uri="{FF2B5EF4-FFF2-40B4-BE49-F238E27FC236}">
-                <a16:creationId xmlns:a16="http://schemas.microsoft.com/office/drawing/2014/main" id="{8B7D4E9B-62FB-41AC-995F-F740F340B8A4}"/>
+                <a16:creationId xmlns:a16="http://schemas.microsoft.com/office/drawing/2014/main" id="{289D62AD-7775-42EC-A694-7B5F29CD9B8F}"/>
               </a:ext>
             </a:extLst>
           </p:cNvPr>
@@ -24725,7 +24827,7 @@
           <p:cNvPr id="3" name="§3.1.3 Subsidies">
             <a:extLst xmlns:a="http://schemas.openxmlformats.org/drawingml/2006/main">
               <a:ext uri="{FF2B5EF4-FFF2-40B4-BE49-F238E27FC236}">
-                <a16:creationId xmlns:a16="http://schemas.microsoft.com/office/drawing/2014/main" id="{FECC150C-F5BC-40F8-9319-7FA681F65AF9}"/>
+                <a16:creationId xmlns:a16="http://schemas.microsoft.com/office/drawing/2014/main" id="{49484D69-7187-4FD0-B407-B6F03CD72405}"/>
               </a:ext>
             </a:extLst>
           </p:cNvPr>
@@ -24782,7 +24884,7 @@
           <p:cNvPr id="4" name="2">
             <a:extLst xmlns:a="http://schemas.openxmlformats.org/drawingml/2006/main">
               <a:ext uri="{FF2B5EF4-FFF2-40B4-BE49-F238E27FC236}">
-                <a16:creationId xmlns:a16="http://schemas.microsoft.com/office/drawing/2014/main" id="{FA77732C-48F7-48B5-8599-F5FFA12216F5}"/>
+                <a16:creationId xmlns:a16="http://schemas.microsoft.com/office/drawing/2014/main" id="{04D82BEA-9125-47D6-8C6D-DFF2938545DF}"/>
               </a:ext>
             </a:extLst>
           </p:cNvPr>
@@ -25158,7 +25260,7 @@
           <p:cNvPr id="6" name="Pp is de totale ontvangst vóór aftrek van productiekost">
             <a:extLst xmlns:a="http://schemas.openxmlformats.org/drawingml/2006/main">
               <a:ext uri="{FF2B5EF4-FFF2-40B4-BE49-F238E27FC236}">
-                <a16:creationId xmlns:a16="http://schemas.microsoft.com/office/drawing/2014/main" id="{0729869A-F38B-469C-949B-C96B6B5070B6}"/>
+                <a16:creationId xmlns:a16="http://schemas.microsoft.com/office/drawing/2014/main" id="{4DE295E2-C6F1-451A-AE2F-60D7F6C84D4B}"/>
               </a:ext>
             </a:extLst>
           </p:cNvPr>
@@ -25213,7 +25315,7 @@
     </p:spTree>
     <p:extLst>
       <p:ext uri="{BB962C8B-B14F-4D97-AF65-F5344CB8AC3E}">
-        <p14:creationId xmlns:p14="http://schemas.microsoft.com/office/powerpoint/2010/main" val="1656152653"/>
+        <p14:creationId xmlns:p14="http://schemas.microsoft.com/office/powerpoint/2010/main" val="625390455"/>
       </p:ext>
     </p:extLst>
   </p:cSld>
@@ -25244,7 +25346,7 @@
           <p:cNvPr id="9" name="Opgave 25 · Basisgrafiek">
             <a:extLst xmlns:a="http://schemas.openxmlformats.org/drawingml/2006/main">
               <a:ext uri="{FF2B5EF4-FFF2-40B4-BE49-F238E27FC236}">
-                <a16:creationId xmlns:a16="http://schemas.microsoft.com/office/drawing/2014/main" id="{C4134F93-0B0A-41B0-B963-5B96B384AB5A}"/>
+                <a16:creationId xmlns:a16="http://schemas.microsoft.com/office/drawing/2014/main" id="{C526FBF1-1280-4408-B1E4-D6401CD68C52}"/>
               </a:ext>
             </a:extLst>
           </p:cNvPr>
@@ -25301,7 +25403,7 @@
           <p:cNvPr id="2" name="">
             <a:extLst xmlns:a="http://schemas.openxmlformats.org/drawingml/2006/main">
               <a:ext uri="{FF2B5EF4-FFF2-40B4-BE49-F238E27FC236}">
-                <a16:creationId xmlns:a16="http://schemas.microsoft.com/office/drawing/2014/main" id="{FB67979C-87EC-4676-BD59-FF11607819AB}"/>
+                <a16:creationId xmlns:a16="http://schemas.microsoft.com/office/drawing/2014/main" id="{8EF02C8D-BE4A-4F99-B610-E1FF70BDCDB5}"/>
               </a:ext>
             </a:extLst>
           </p:cNvPr>
@@ -25330,7 +25432,7 @@
           <p:cNvPr id="3" name="§3.1.3 Subsidies">
             <a:extLst xmlns:a="http://schemas.openxmlformats.org/drawingml/2006/main">
               <a:ext uri="{FF2B5EF4-FFF2-40B4-BE49-F238E27FC236}">
-                <a16:creationId xmlns:a16="http://schemas.microsoft.com/office/drawing/2014/main" id="{AB227086-DCCC-4DFC-8DCE-81A87046E208}"/>
+                <a16:creationId xmlns:a16="http://schemas.microsoft.com/office/drawing/2014/main" id="{74330202-4DBC-4CFB-95E9-308CC0A50DD0}"/>
               </a:ext>
             </a:extLst>
           </p:cNvPr>
@@ -25387,7 +25489,7 @@
           <p:cNvPr id="4" name="20">
             <a:extLst xmlns:a="http://schemas.openxmlformats.org/drawingml/2006/main">
               <a:ext uri="{FF2B5EF4-FFF2-40B4-BE49-F238E27FC236}">
-                <a16:creationId xmlns:a16="http://schemas.microsoft.com/office/drawing/2014/main" id="{A70C7DE4-B352-4BFD-B271-51D75010519A}"/>
+                <a16:creationId xmlns:a16="http://schemas.microsoft.com/office/drawing/2014/main" id="{BBFA24A6-2DEC-44D4-9220-7F1E4895DE67}"/>
               </a:ext>
             </a:extLst>
           </p:cNvPr>
@@ -25451,7 +25553,7 @@
         </p:xfrm>
         <a:graphic xmlns:a="http://schemas.openxmlformats.org/drawingml/2006/main">
           <a:graphicData uri="http://schemas.openxmlformats.org/drawingml/2006/chart">
-            <c:chart xmlns:r="http://schemas.openxmlformats.org/officeDocument/2006/relationships" xmlns:c="http://schemas.openxmlformats.org/drawingml/2006/chart" r:id="R8aaf4c675f29413f"/>
+            <c:chart xmlns:r="http://schemas.openxmlformats.org/officeDocument/2006/relationships" xmlns:c="http://schemas.openxmlformats.org/drawingml/2006/chart" r:id="Raa6a21f0bf164417"/>
           </a:graphicData>
         </a:graphic>
       </p:graphicFrame>
@@ -25460,7 +25562,7 @@
           <p:cNvPr id="6" name="Gegeven lijnen">
             <a:extLst xmlns:a="http://schemas.openxmlformats.org/drawingml/2006/main">
               <a:ext uri="{FF2B5EF4-FFF2-40B4-BE49-F238E27FC236}">
-                <a16:creationId xmlns:a16="http://schemas.microsoft.com/office/drawing/2014/main" id="{8E0D6E1B-BD34-4B01-AAFA-86A579FB931B}"/>
+                <a16:creationId xmlns:a16="http://schemas.microsoft.com/office/drawing/2014/main" id="{80CB6D31-BBE3-4A23-91FC-EC64DA66AE63}"/>
               </a:ext>
             </a:extLst>
           </p:cNvPr>
@@ -25517,7 +25619,7 @@
           <p:cNvPr id="7" name="V: Pc = 26 − 0,20Q&#10;&#10;A: Pp = 8 + 0,10Q">
             <a:extLst xmlns:a="http://schemas.openxmlformats.org/drawingml/2006/main">
               <a:ext uri="{FF2B5EF4-FFF2-40B4-BE49-F238E27FC236}">
-                <a16:creationId xmlns:a16="http://schemas.microsoft.com/office/drawing/2014/main" id="{054AA182-DCE6-4480-B563-B182BC3807BF}"/>
+                <a16:creationId xmlns:a16="http://schemas.microsoft.com/office/drawing/2014/main" id="{2492BD18-A1F0-49F3-842C-B42A8239AED7}"/>
               </a:ext>
             </a:extLst>
           </p:cNvPr>
@@ -25602,7 +25704,7 @@
           <p:cNvPr id="8" name="Q in cursusplaatsen&#10;per week">
             <a:extLst xmlns:a="http://schemas.openxmlformats.org/drawingml/2006/main">
               <a:ext uri="{FF2B5EF4-FFF2-40B4-BE49-F238E27FC236}">
-                <a16:creationId xmlns:a16="http://schemas.microsoft.com/office/drawing/2014/main" id="{A0026A83-3400-45E7-822E-64D982B39E9A}"/>
+                <a16:creationId xmlns:a16="http://schemas.microsoft.com/office/drawing/2014/main" id="{892BE152-247A-4381-9DA1-754EF9B0F33B}"/>
               </a:ext>
             </a:extLst>
           </p:cNvPr>
@@ -25680,7 +25782,7 @@
     </p:spTree>
     <p:extLst>
       <p:ext uri="{BB962C8B-B14F-4D97-AF65-F5344CB8AC3E}">
-        <p14:creationId xmlns:p14="http://schemas.microsoft.com/office/powerpoint/2010/main" val="1025550118"/>
+        <p14:creationId xmlns:p14="http://schemas.microsoft.com/office/powerpoint/2010/main" val="379674490"/>
       </p:ext>
     </p:extLst>
   </p:cSld>
@@ -25711,7 +25813,7 @@
           <p:cNvPr id="9" name="25a · Nieuw aanbod en nieuwe hoeveelheid">
             <a:extLst xmlns:a="http://schemas.openxmlformats.org/drawingml/2006/main">
               <a:ext uri="{FF2B5EF4-FFF2-40B4-BE49-F238E27FC236}">
-                <a16:creationId xmlns:a16="http://schemas.microsoft.com/office/drawing/2014/main" id="{E0DE29D0-949D-4983-B182-FDC0767A7293}"/>
+                <a16:creationId xmlns:a16="http://schemas.microsoft.com/office/drawing/2014/main" id="{8D903BC6-8A87-4E7C-AECC-B0EBBBFB1760}"/>
               </a:ext>
             </a:extLst>
           </p:cNvPr>
@@ -25768,7 +25870,7 @@
           <p:cNvPr id="2" name="">
             <a:extLst xmlns:a="http://schemas.openxmlformats.org/drawingml/2006/main">
               <a:ext uri="{FF2B5EF4-FFF2-40B4-BE49-F238E27FC236}">
-                <a16:creationId xmlns:a16="http://schemas.microsoft.com/office/drawing/2014/main" id="{E81859FF-23C4-4472-9D34-DCC32FA2C24D}"/>
+                <a16:creationId xmlns:a16="http://schemas.microsoft.com/office/drawing/2014/main" id="{A9CA2D9A-AF6C-4774-B573-414EE3B59F5F}"/>
               </a:ext>
             </a:extLst>
           </p:cNvPr>
@@ -25797,7 +25899,7 @@
           <p:cNvPr id="3" name="§3.1.3 Subsidies">
             <a:extLst xmlns:a="http://schemas.openxmlformats.org/drawingml/2006/main">
               <a:ext uri="{FF2B5EF4-FFF2-40B4-BE49-F238E27FC236}">
-                <a16:creationId xmlns:a16="http://schemas.microsoft.com/office/drawing/2014/main" id="{E8ADA9CC-680C-4E82-8E48-62C3A039029B}"/>
+                <a16:creationId xmlns:a16="http://schemas.microsoft.com/office/drawing/2014/main" id="{0321D6E8-3F49-4FE8-8F60-3CF7A981ADF0}"/>
               </a:ext>
             </a:extLst>
           </p:cNvPr>
@@ -25854,7 +25956,7 @@
           <p:cNvPr id="4" name="21">
             <a:extLst xmlns:a="http://schemas.openxmlformats.org/drawingml/2006/main">
               <a:ext uri="{FF2B5EF4-FFF2-40B4-BE49-F238E27FC236}">
-                <a16:creationId xmlns:a16="http://schemas.microsoft.com/office/drawing/2014/main" id="{95FFDBE9-A8CA-4BD1-B713-EAB37E2BE6EE}"/>
+                <a16:creationId xmlns:a16="http://schemas.microsoft.com/office/drawing/2014/main" id="{718CEFAC-D382-479F-A5A0-F158586DECFE}"/>
               </a:ext>
             </a:extLst>
           </p:cNvPr>
@@ -25911,7 +26013,7 @@
           <p:cNvPr id="5" name="Pc = Pp − 3 = 5 + 0,10Q">
             <a:extLst xmlns:a="http://schemas.openxmlformats.org/drawingml/2006/main">
               <a:ext uri="{FF2B5EF4-FFF2-40B4-BE49-F238E27FC236}">
-                <a16:creationId xmlns:a16="http://schemas.microsoft.com/office/drawing/2014/main" id="{8D212DB9-D698-4FB0-9944-3E90AAB7916A}"/>
+                <a16:creationId xmlns:a16="http://schemas.microsoft.com/office/drawing/2014/main" id="{519BED27-8FF1-4595-A4B9-FD911E93AD06}"/>
               </a:ext>
             </a:extLst>
           </p:cNvPr>
@@ -25968,7 +26070,7 @@
           <p:cNvPr id="6" name="26 − 0,20Q = 5 + 0,10Q">
             <a:extLst xmlns:a="http://schemas.openxmlformats.org/drawingml/2006/main">
               <a:ext uri="{FF2B5EF4-FFF2-40B4-BE49-F238E27FC236}">
-                <a16:creationId xmlns:a16="http://schemas.microsoft.com/office/drawing/2014/main" id="{FB475AF1-18E5-45DE-BFE3-A909FCBFDF91}"/>
+                <a16:creationId xmlns:a16="http://schemas.microsoft.com/office/drawing/2014/main" id="{932E629E-52E8-45B4-BC54-642C47878A65}"/>
               </a:ext>
             </a:extLst>
           </p:cNvPr>
@@ -26025,7 +26127,7 @@
           <p:cNvPr id="7" name="21 = 0,30Q">
             <a:extLst xmlns:a="http://schemas.openxmlformats.org/drawingml/2006/main">
               <a:ext uri="{FF2B5EF4-FFF2-40B4-BE49-F238E27FC236}">
-                <a16:creationId xmlns:a16="http://schemas.microsoft.com/office/drawing/2014/main" id="{0C17DDBE-7D84-435B-A143-7D7C55130214}"/>
+                <a16:creationId xmlns:a16="http://schemas.microsoft.com/office/drawing/2014/main" id="{22E8B81E-80D6-4769-80F4-5AC2CA5D3F27}"/>
               </a:ext>
             </a:extLst>
           </p:cNvPr>
@@ -26082,7 +26184,7 @@
           <p:cNvPr id="8" name="Qsub = 70 cursusplaatsen per week">
             <a:extLst xmlns:a="http://schemas.openxmlformats.org/drawingml/2006/main">
               <a:ext uri="{FF2B5EF4-FFF2-40B4-BE49-F238E27FC236}">
-                <a16:creationId xmlns:a16="http://schemas.microsoft.com/office/drawing/2014/main" id="{10FF1CBE-08A9-485B-BEE8-6AC6FEA8BB50}"/>
+                <a16:creationId xmlns:a16="http://schemas.microsoft.com/office/drawing/2014/main" id="{49B2AF0F-872F-418B-A15F-045E2777AE68}"/>
               </a:ext>
             </a:extLst>
           </p:cNvPr>
@@ -26137,7 +26239,7 @@
     </p:spTree>
     <p:extLst>
       <p:ext uri="{BB962C8B-B14F-4D97-AF65-F5344CB8AC3E}">
-        <p14:creationId xmlns:p14="http://schemas.microsoft.com/office/powerpoint/2010/main" val="1003857489"/>
+        <p14:creationId xmlns:p14="http://schemas.microsoft.com/office/powerpoint/2010/main" val="905034811"/>
       </p:ext>
     </p:extLst>
   </p:cSld>
@@ -26168,7 +26270,7 @@
           <p:cNvPr id="8" name="25a · Beide prijzen en de controle">
             <a:extLst xmlns:a="http://schemas.openxmlformats.org/drawingml/2006/main">
               <a:ext uri="{FF2B5EF4-FFF2-40B4-BE49-F238E27FC236}">
-                <a16:creationId xmlns:a16="http://schemas.microsoft.com/office/drawing/2014/main" id="{EC6E2ED6-3E62-4838-9A62-C1CEAFA2F76D}"/>
+                <a16:creationId xmlns:a16="http://schemas.microsoft.com/office/drawing/2014/main" id="{DC504B24-7547-40DC-A48D-4C91AC520C75}"/>
               </a:ext>
             </a:extLst>
           </p:cNvPr>
@@ -26225,7 +26327,7 @@
           <p:cNvPr id="2" name="">
             <a:extLst xmlns:a="http://schemas.openxmlformats.org/drawingml/2006/main">
               <a:ext uri="{FF2B5EF4-FFF2-40B4-BE49-F238E27FC236}">
-                <a16:creationId xmlns:a16="http://schemas.microsoft.com/office/drawing/2014/main" id="{69FAB2CA-604E-4680-A0A0-456AEC81E084}"/>
+                <a16:creationId xmlns:a16="http://schemas.microsoft.com/office/drawing/2014/main" id="{ACB7F2EA-9E95-4405-8BE9-A8BD0AF41EAC}"/>
               </a:ext>
             </a:extLst>
           </p:cNvPr>
@@ -26254,7 +26356,7 @@
           <p:cNvPr id="3" name="§3.1.3 Subsidies">
             <a:extLst xmlns:a="http://schemas.openxmlformats.org/drawingml/2006/main">
               <a:ext uri="{FF2B5EF4-FFF2-40B4-BE49-F238E27FC236}">
-                <a16:creationId xmlns:a16="http://schemas.microsoft.com/office/drawing/2014/main" id="{8CFAE690-B259-49AA-A560-65235F17BD4B}"/>
+                <a16:creationId xmlns:a16="http://schemas.microsoft.com/office/drawing/2014/main" id="{8608F821-83C3-4A55-9358-CE269633B36B}"/>
               </a:ext>
             </a:extLst>
           </p:cNvPr>
@@ -26311,7 +26413,7 @@
           <p:cNvPr id="4" name="22">
             <a:extLst xmlns:a="http://schemas.openxmlformats.org/drawingml/2006/main">
               <a:ext uri="{FF2B5EF4-FFF2-40B4-BE49-F238E27FC236}">
-                <a16:creationId xmlns:a16="http://schemas.microsoft.com/office/drawing/2014/main" id="{E5DCE460-D277-4300-96A4-E6B1B9E752EB}"/>
+                <a16:creationId xmlns:a16="http://schemas.microsoft.com/office/drawing/2014/main" id="{C77E19C5-B3A0-434F-869D-22D135CD5E94}"/>
               </a:ext>
             </a:extLst>
           </p:cNvPr>
@@ -26368,7 +26470,7 @@
           <p:cNvPr id="5" name="Pc = 26 − 0,20 × 70 = € 12">
             <a:extLst xmlns:a="http://schemas.openxmlformats.org/drawingml/2006/main">
               <a:ext uri="{FF2B5EF4-FFF2-40B4-BE49-F238E27FC236}">
-                <a16:creationId xmlns:a16="http://schemas.microsoft.com/office/drawing/2014/main" id="{82D75A6C-7014-4261-960C-3D18C6954B28}"/>
+                <a16:creationId xmlns:a16="http://schemas.microsoft.com/office/drawing/2014/main" id="{31C0CBFF-4810-445E-9B94-6A9C0E83390E}"/>
               </a:ext>
             </a:extLst>
           </p:cNvPr>
@@ -26425,7 +26527,7 @@
           <p:cNvPr id="6" name="Pp = 8 + 0,10 × 70 = € 15">
             <a:extLst xmlns:a="http://schemas.openxmlformats.org/drawingml/2006/main">
               <a:ext uri="{FF2B5EF4-FFF2-40B4-BE49-F238E27FC236}">
-                <a16:creationId xmlns:a16="http://schemas.microsoft.com/office/drawing/2014/main" id="{3495D373-613E-4233-963E-48DA4055F27D}"/>
+                <a16:creationId xmlns:a16="http://schemas.microsoft.com/office/drawing/2014/main" id="{D9D094DD-405A-4764-AB9D-B2AECB316B50}"/>
               </a:ext>
             </a:extLst>
           </p:cNvPr>
@@ -26482,7 +26584,7 @@
           <p:cNvPr id="7" name="Pp − Pc = 15 − 12 = € 3 per cursusplaats">
             <a:extLst xmlns:a="http://schemas.openxmlformats.org/drawingml/2006/main">
               <a:ext uri="{FF2B5EF4-FFF2-40B4-BE49-F238E27FC236}">
-                <a16:creationId xmlns:a16="http://schemas.microsoft.com/office/drawing/2014/main" id="{C99A1779-59CE-4630-9E40-50AE91A68096}"/>
+                <a16:creationId xmlns:a16="http://schemas.microsoft.com/office/drawing/2014/main" id="{E2D8BBBE-7DD7-41D5-9B77-76AE2862DD0A}"/>
               </a:ext>
             </a:extLst>
           </p:cNvPr>
@@ -26537,7 +26639,7 @@
     </p:spTree>
     <p:extLst>
       <p:ext uri="{BB962C8B-B14F-4D97-AF65-F5344CB8AC3E}">
-        <p14:creationId xmlns:p14="http://schemas.microsoft.com/office/powerpoint/2010/main" val="941652093"/>
+        <p14:creationId xmlns:p14="http://schemas.microsoft.com/office/powerpoint/2010/main" val="691293716"/>
       </p:ext>
     </p:extLst>
   </p:cSld>
@@ -26568,7 +26670,7 @@
           <p:cNvPr id="9" name="25b · De overheidsuitgaven">
             <a:extLst xmlns:a="http://schemas.openxmlformats.org/drawingml/2006/main">
               <a:ext uri="{FF2B5EF4-FFF2-40B4-BE49-F238E27FC236}">
-                <a16:creationId xmlns:a16="http://schemas.microsoft.com/office/drawing/2014/main" id="{EB80A91D-26C2-4022-B0BD-893F77F0B320}"/>
+                <a16:creationId xmlns:a16="http://schemas.microsoft.com/office/drawing/2014/main" id="{7ACB6833-282E-43A4-AD62-F5E5E632C8CC}"/>
               </a:ext>
             </a:extLst>
           </p:cNvPr>
@@ -26625,7 +26727,7 @@
           <p:cNvPr id="2" name="">
             <a:extLst xmlns:a="http://schemas.openxmlformats.org/drawingml/2006/main">
               <a:ext uri="{FF2B5EF4-FFF2-40B4-BE49-F238E27FC236}">
-                <a16:creationId xmlns:a16="http://schemas.microsoft.com/office/drawing/2014/main" id="{3F3DA326-8D36-49F2-896B-552B7A647E82}"/>
+                <a16:creationId xmlns:a16="http://schemas.microsoft.com/office/drawing/2014/main" id="{8F373645-BB27-4680-86B8-86CE36C3B6DB}"/>
               </a:ext>
             </a:extLst>
           </p:cNvPr>
@@ -26654,7 +26756,7 @@
           <p:cNvPr id="3" name="§3.1.3 Subsidies">
             <a:extLst xmlns:a="http://schemas.openxmlformats.org/drawingml/2006/main">
               <a:ext uri="{FF2B5EF4-FFF2-40B4-BE49-F238E27FC236}">
-                <a16:creationId xmlns:a16="http://schemas.microsoft.com/office/drawing/2014/main" id="{67D8190E-FD2A-4E23-89F0-360253A3C982}"/>
+                <a16:creationId xmlns:a16="http://schemas.microsoft.com/office/drawing/2014/main" id="{514313CA-190F-4336-8D69-9C5DEE909420}"/>
               </a:ext>
             </a:extLst>
           </p:cNvPr>
@@ -26711,7 +26813,7 @@
           <p:cNvPr id="4" name="23">
             <a:extLst xmlns:a="http://schemas.openxmlformats.org/drawingml/2006/main">
               <a:ext uri="{FF2B5EF4-FFF2-40B4-BE49-F238E27FC236}">
-                <a16:creationId xmlns:a16="http://schemas.microsoft.com/office/drawing/2014/main" id="{29A45215-AC88-4EB0-A53E-E9D7B8C4D945}"/>
+                <a16:creationId xmlns:a16="http://schemas.microsoft.com/office/drawing/2014/main" id="{EF760066-A95C-4645-8F6C-8CB6D8FCC2EA}"/>
               </a:ext>
             </a:extLst>
           </p:cNvPr>
@@ -26768,7 +26870,7 @@
           <p:cNvPr id="5" name="U = s × Qsub">
             <a:extLst xmlns:a="http://schemas.openxmlformats.org/drawingml/2006/main">
               <a:ext uri="{FF2B5EF4-FFF2-40B4-BE49-F238E27FC236}">
-                <a16:creationId xmlns:a16="http://schemas.microsoft.com/office/drawing/2014/main" id="{60C7220C-2CFC-4238-9ABA-ECFFF878FBD2}"/>
+                <a16:creationId xmlns:a16="http://schemas.microsoft.com/office/drawing/2014/main" id="{53E0C3D5-5B8F-4247-839E-EFCCA30FD9C4}"/>
               </a:ext>
             </a:extLst>
           </p:cNvPr>
@@ -26825,7 +26927,7 @@
           <p:cNvPr id="6" name="U = € 3 per plaats × 70 plaatsen per week">
             <a:extLst xmlns:a="http://schemas.openxmlformats.org/drawingml/2006/main">
               <a:ext uri="{FF2B5EF4-FFF2-40B4-BE49-F238E27FC236}">
-                <a16:creationId xmlns:a16="http://schemas.microsoft.com/office/drawing/2014/main" id="{CB19AD2F-0634-43AF-8B19-FD0EB6023FC0}"/>
+                <a16:creationId xmlns:a16="http://schemas.microsoft.com/office/drawing/2014/main" id="{73815A95-280E-4AF7-9B35-303458F32049}"/>
               </a:ext>
             </a:extLst>
           </p:cNvPr>
@@ -26882,7 +26984,7 @@
           <p:cNvPr id="7" name="U = € 210 per week">
             <a:extLst xmlns:a="http://schemas.openxmlformats.org/drawingml/2006/main">
               <a:ext uri="{FF2B5EF4-FFF2-40B4-BE49-F238E27FC236}">
-                <a16:creationId xmlns:a16="http://schemas.microsoft.com/office/drawing/2014/main" id="{7589879E-B451-4E70-893C-1D7228AC919E}"/>
+                <a16:creationId xmlns:a16="http://schemas.microsoft.com/office/drawing/2014/main" id="{2EECD93F-8846-4865-A22D-61C57D8D3833}"/>
               </a:ext>
             </a:extLst>
           </p:cNvPr>
@@ -26939,7 +27041,7 @@
           <p:cNvPr id="8" name="De subsidie geldt voor alle 70 verkochte cursusplaatsen">
             <a:extLst xmlns:a="http://schemas.openxmlformats.org/drawingml/2006/main">
               <a:ext uri="{FF2B5EF4-FFF2-40B4-BE49-F238E27FC236}">
-                <a16:creationId xmlns:a16="http://schemas.microsoft.com/office/drawing/2014/main" id="{EB47080B-2754-4DFA-BA7E-8803ED97C425}"/>
+                <a16:creationId xmlns:a16="http://schemas.microsoft.com/office/drawing/2014/main" id="{1D90DED6-506A-4E41-B94E-E9DD02491EE3}"/>
               </a:ext>
             </a:extLst>
           </p:cNvPr>
@@ -26994,7 +27096,7 @@
     </p:spTree>
     <p:extLst>
       <p:ext uri="{BB962C8B-B14F-4D97-AF65-F5344CB8AC3E}">
-        <p14:creationId xmlns:p14="http://schemas.microsoft.com/office/powerpoint/2010/main" val="931361896"/>
+        <p14:creationId xmlns:p14="http://schemas.microsoft.com/office/powerpoint/2010/main" val="217950752"/>
       </p:ext>
     </p:extLst>
   </p:cSld>
@@ -27025,7 +27127,7 @@
           <p:cNvPr id="7" name="25c · Wie krijgt het voordeel?">
             <a:extLst xmlns:a="http://schemas.openxmlformats.org/drawingml/2006/main">
               <a:ext uri="{FF2B5EF4-FFF2-40B4-BE49-F238E27FC236}">
-                <a16:creationId xmlns:a16="http://schemas.microsoft.com/office/drawing/2014/main" id="{9FB06086-32A7-40D9-873E-67B6C093C05F}"/>
+                <a16:creationId xmlns:a16="http://schemas.microsoft.com/office/drawing/2014/main" id="{C9A8B471-33DA-4142-88EE-1BAD4BA4EB92}"/>
               </a:ext>
             </a:extLst>
           </p:cNvPr>
@@ -27082,7 +27184,7 @@
           <p:cNvPr id="2" name="">
             <a:extLst xmlns:a="http://schemas.openxmlformats.org/drawingml/2006/main">
               <a:ext uri="{FF2B5EF4-FFF2-40B4-BE49-F238E27FC236}">
-                <a16:creationId xmlns:a16="http://schemas.microsoft.com/office/drawing/2014/main" id="{86824190-B600-46F9-9D81-16F332512337}"/>
+                <a16:creationId xmlns:a16="http://schemas.microsoft.com/office/drawing/2014/main" id="{CDD917ED-08AF-48DD-9225-F69A3CCC02CC}"/>
               </a:ext>
             </a:extLst>
           </p:cNvPr>
@@ -27111,7 +27213,7 @@
           <p:cNvPr id="3" name="§3.1.3 Subsidies">
             <a:extLst xmlns:a="http://schemas.openxmlformats.org/drawingml/2006/main">
               <a:ext uri="{FF2B5EF4-FFF2-40B4-BE49-F238E27FC236}">
-                <a16:creationId xmlns:a16="http://schemas.microsoft.com/office/drawing/2014/main" id="{92A2CC2F-3852-4FBA-B942-63DE5161AC79}"/>
+                <a16:creationId xmlns:a16="http://schemas.microsoft.com/office/drawing/2014/main" id="{49580431-7A43-4D3E-8136-E2EEC1516634}"/>
               </a:ext>
             </a:extLst>
           </p:cNvPr>
@@ -27168,7 +27270,7 @@
           <p:cNvPr id="4" name="24">
             <a:extLst xmlns:a="http://schemas.openxmlformats.org/drawingml/2006/main">
               <a:ext uri="{FF2B5EF4-FFF2-40B4-BE49-F238E27FC236}">
-                <a16:creationId xmlns:a16="http://schemas.microsoft.com/office/drawing/2014/main" id="{A453A15D-AFA1-48F4-A2F1-291FE45B47BE}"/>
+                <a16:creationId xmlns:a16="http://schemas.microsoft.com/office/drawing/2014/main" id="{9BEBA22C-8EEB-4F9B-8407-5DDF8BB323AA}"/>
               </a:ext>
             </a:extLst>
           </p:cNvPr>
@@ -27470,7 +27572,7 @@
           <p:cNvPr id="6" name="De lagere kopersprijs geeft ook de koper een deel van h">
             <a:extLst xmlns:a="http://schemas.openxmlformats.org/drawingml/2006/main">
               <a:ext uri="{FF2B5EF4-FFF2-40B4-BE49-F238E27FC236}">
-                <a16:creationId xmlns:a16="http://schemas.microsoft.com/office/drawing/2014/main" id="{5D186255-2A69-4453-8456-E13A17E33B53}"/>
+                <a16:creationId xmlns:a16="http://schemas.microsoft.com/office/drawing/2014/main" id="{97429A88-3754-4A00-824B-750CBAF70878}"/>
               </a:ext>
             </a:extLst>
           </p:cNvPr>
@@ -27525,7 +27627,7 @@
     </p:spTree>
     <p:extLst>
       <p:ext uri="{BB962C8B-B14F-4D97-AF65-F5344CB8AC3E}">
-        <p14:creationId xmlns:p14="http://schemas.microsoft.com/office/powerpoint/2010/main" val="1851164355"/>
+        <p14:creationId xmlns:p14="http://schemas.microsoft.com/office/powerpoint/2010/main" val="1244741087"/>
       </p:ext>
     </p:extLst>
   </p:cSld>
@@ -27556,7 +27658,7 @@
           <p:cNvPr id="8" name="25d · CS en PS na subsidie">
             <a:extLst xmlns:a="http://schemas.openxmlformats.org/drawingml/2006/main">
               <a:ext uri="{FF2B5EF4-FFF2-40B4-BE49-F238E27FC236}">
-                <a16:creationId xmlns:a16="http://schemas.microsoft.com/office/drawing/2014/main" id="{2D6600F3-276C-4BF0-AA17-170CA3984600}"/>
+                <a16:creationId xmlns:a16="http://schemas.microsoft.com/office/drawing/2014/main" id="{46FB3309-A9FC-4095-9FD8-18C5882D4243}"/>
               </a:ext>
             </a:extLst>
           </p:cNvPr>
@@ -27613,7 +27715,7 @@
           <p:cNvPr id="2" name="">
             <a:extLst xmlns:a="http://schemas.openxmlformats.org/drawingml/2006/main">
               <a:ext uri="{FF2B5EF4-FFF2-40B4-BE49-F238E27FC236}">
-                <a16:creationId xmlns:a16="http://schemas.microsoft.com/office/drawing/2014/main" id="{8B556D1E-CDBC-494F-A1B8-B42E4FC4250A}"/>
+                <a16:creationId xmlns:a16="http://schemas.microsoft.com/office/drawing/2014/main" id="{A73F365F-0D74-446E-A0C9-1DFE72200380}"/>
               </a:ext>
             </a:extLst>
           </p:cNvPr>
@@ -27642,7 +27744,7 @@
           <p:cNvPr id="3" name="§3.1.3 Subsidies">
             <a:extLst xmlns:a="http://schemas.openxmlformats.org/drawingml/2006/main">
               <a:ext uri="{FF2B5EF4-FFF2-40B4-BE49-F238E27FC236}">
-                <a16:creationId xmlns:a16="http://schemas.microsoft.com/office/drawing/2014/main" id="{3B1CB995-2E2B-44A2-96D0-4BB848BCBE90}"/>
+                <a16:creationId xmlns:a16="http://schemas.microsoft.com/office/drawing/2014/main" id="{4F958F6A-AB90-4FF5-BCD8-DB36AEB5EF70}"/>
               </a:ext>
             </a:extLst>
           </p:cNvPr>
@@ -27699,7 +27801,7 @@
           <p:cNvPr id="4" name="25">
             <a:extLst xmlns:a="http://schemas.openxmlformats.org/drawingml/2006/main">
               <a:ext uri="{FF2B5EF4-FFF2-40B4-BE49-F238E27FC236}">
-                <a16:creationId xmlns:a16="http://schemas.microsoft.com/office/drawing/2014/main" id="{3E4ADA37-E2BF-40FA-88B1-11DD755B3435}"/>
+                <a16:creationId xmlns:a16="http://schemas.microsoft.com/office/drawing/2014/main" id="{2A0109F0-EC80-40D2-A354-894C08951B6A}"/>
               </a:ext>
             </a:extLst>
           </p:cNvPr>
@@ -27756,7 +27858,7 @@
           <p:cNvPr id="5" name="Basis: 70 cursusplaatsen per week">
             <a:extLst xmlns:a="http://schemas.openxmlformats.org/drawingml/2006/main">
               <a:ext uri="{FF2B5EF4-FFF2-40B4-BE49-F238E27FC236}">
-                <a16:creationId xmlns:a16="http://schemas.microsoft.com/office/drawing/2014/main" id="{0BC4CC69-DF6D-4FDF-9C0D-52222C28BB72}"/>
+                <a16:creationId xmlns:a16="http://schemas.microsoft.com/office/drawing/2014/main" id="{C8186227-436D-4E56-8613-8825363F03A1}"/>
               </a:ext>
             </a:extLst>
           </p:cNvPr>
@@ -28058,7 +28160,7 @@
           <p:cNvPr id="7" name="CS gebruikt Pc. PS gebruikt Pp en de oorspronkelijke aa">
             <a:extLst xmlns:a="http://schemas.openxmlformats.org/drawingml/2006/main">
               <a:ext uri="{FF2B5EF4-FFF2-40B4-BE49-F238E27FC236}">
-                <a16:creationId xmlns:a16="http://schemas.microsoft.com/office/drawing/2014/main" id="{002DFB18-DA61-4CB4-83C3-7464C8F6DC5C}"/>
+                <a16:creationId xmlns:a16="http://schemas.microsoft.com/office/drawing/2014/main" id="{37FF8D2E-358C-4A5F-BD0F-83D26B319851}"/>
               </a:ext>
             </a:extLst>
           </p:cNvPr>
@@ -28113,7 +28215,7 @@
     </p:spTree>
     <p:extLst>
       <p:ext uri="{BB962C8B-B14F-4D97-AF65-F5344CB8AC3E}">
-        <p14:creationId xmlns:p14="http://schemas.microsoft.com/office/powerpoint/2010/main" val="170696359"/>
+        <p14:creationId xmlns:p14="http://schemas.microsoft.com/office/powerpoint/2010/main" val="33041550"/>
       </p:ext>
     </p:extLst>
   </p:cSld>
@@ -28144,7 +28246,7 @@
           <p:cNvPr id="9" name="25d · De welvaartsmaat en het verlies">
             <a:extLst xmlns:a="http://schemas.openxmlformats.org/drawingml/2006/main">
               <a:ext uri="{FF2B5EF4-FFF2-40B4-BE49-F238E27FC236}">
-                <a16:creationId xmlns:a16="http://schemas.microsoft.com/office/drawing/2014/main" id="{3FC7B4F2-7C24-4730-BF13-CDD1C2C61A15}"/>
+                <a16:creationId xmlns:a16="http://schemas.microsoft.com/office/drawing/2014/main" id="{B403BCCF-4546-4E06-B87B-F7B2BAEB2B0A}"/>
               </a:ext>
             </a:extLst>
           </p:cNvPr>
@@ -28201,7 +28303,7 @@
           <p:cNvPr id="2" name="">
             <a:extLst xmlns:a="http://schemas.openxmlformats.org/drawingml/2006/main">
               <a:ext uri="{FF2B5EF4-FFF2-40B4-BE49-F238E27FC236}">
-                <a16:creationId xmlns:a16="http://schemas.microsoft.com/office/drawing/2014/main" id="{16F41A8C-4EA6-4F79-9A31-D56497CDE560}"/>
+                <a16:creationId xmlns:a16="http://schemas.microsoft.com/office/drawing/2014/main" id="{23859A6F-352C-4DD5-9AA0-60D88F0EEF5A}"/>
               </a:ext>
             </a:extLst>
           </p:cNvPr>
@@ -28230,7 +28332,7 @@
           <p:cNvPr id="3" name="§3.1.3 Subsidies">
             <a:extLst xmlns:a="http://schemas.openxmlformats.org/drawingml/2006/main">
               <a:ext uri="{FF2B5EF4-FFF2-40B4-BE49-F238E27FC236}">
-                <a16:creationId xmlns:a16="http://schemas.microsoft.com/office/drawing/2014/main" id="{55B109BB-02CD-418D-9C03-87E514A07684}"/>
+                <a16:creationId xmlns:a16="http://schemas.microsoft.com/office/drawing/2014/main" id="{09CE6575-D6B3-40CA-8430-3DEC9E5CEC03}"/>
               </a:ext>
             </a:extLst>
           </p:cNvPr>
@@ -28287,7 +28389,7 @@
           <p:cNvPr id="4" name="26">
             <a:extLst xmlns:a="http://schemas.openxmlformats.org/drawingml/2006/main">
               <a:ext uri="{FF2B5EF4-FFF2-40B4-BE49-F238E27FC236}">
-                <a16:creationId xmlns:a16="http://schemas.microsoft.com/office/drawing/2014/main" id="{16712136-990A-4B9F-BA6B-8C5FCFC24CD0}"/>
+                <a16:creationId xmlns:a16="http://schemas.microsoft.com/office/drawing/2014/main" id="{23E60B55-E8E4-433C-A904-BDCFA95A833D}"/>
               </a:ext>
             </a:extLst>
           </p:cNvPr>
@@ -28344,7 +28446,7 @@
           <p:cNvPr id="5" name="Oud: CS + PS = 360 + 180 = € 540">
             <a:extLst xmlns:a="http://schemas.openxmlformats.org/drawingml/2006/main">
               <a:ext uri="{FF2B5EF4-FFF2-40B4-BE49-F238E27FC236}">
-                <a16:creationId xmlns:a16="http://schemas.microsoft.com/office/drawing/2014/main" id="{51635308-55B3-4124-8D71-56B0A9907E08}"/>
+                <a16:creationId xmlns:a16="http://schemas.microsoft.com/office/drawing/2014/main" id="{0AD958A9-B587-4C32-9F92-F96995B3379A}"/>
               </a:ext>
             </a:extLst>
           </p:cNvPr>
@@ -28401,7 +28503,7 @@
           <p:cNvPr id="6" name="Nieuw: CS + PS − U = 490 + 245 − 210 = € 525">
             <a:extLst xmlns:a="http://schemas.openxmlformats.org/drawingml/2006/main">
               <a:ext uri="{FF2B5EF4-FFF2-40B4-BE49-F238E27FC236}">
-                <a16:creationId xmlns:a16="http://schemas.microsoft.com/office/drawing/2014/main" id="{7B662C77-778F-4CCE-91B7-8FADBF50755E}"/>
+                <a16:creationId xmlns:a16="http://schemas.microsoft.com/office/drawing/2014/main" id="{83ADCB60-9C48-4205-8F9E-62BA5F6539BE}"/>
               </a:ext>
             </a:extLst>
           </p:cNvPr>
@@ -28458,7 +28560,7 @@
           <p:cNvPr id="7" name="W = 540 − 525 = € 15 per week">
             <a:extLst xmlns:a="http://schemas.openxmlformats.org/drawingml/2006/main">
               <a:ext uri="{FF2B5EF4-FFF2-40B4-BE49-F238E27FC236}">
-                <a16:creationId xmlns:a16="http://schemas.microsoft.com/office/drawing/2014/main" id="{55DAB677-2AE6-473D-994C-0D01F2F87782}"/>
+                <a16:creationId xmlns:a16="http://schemas.microsoft.com/office/drawing/2014/main" id="{5F686EE3-94D0-4A04-ACCE-AB444563EFA0}"/>
               </a:ext>
             </a:extLst>
           </p:cNvPr>
@@ -28515,7 +28617,7 @@
           <p:cNvPr id="8" name="Controle: ½ × (70 − 60) × 3 = € 15 per week">
             <a:extLst xmlns:a="http://schemas.openxmlformats.org/drawingml/2006/main">
               <a:ext uri="{FF2B5EF4-FFF2-40B4-BE49-F238E27FC236}">
-                <a16:creationId xmlns:a16="http://schemas.microsoft.com/office/drawing/2014/main" id="{921B8DF4-B2C3-4E71-8F7C-30F55D5AEE6C}"/>
+                <a16:creationId xmlns:a16="http://schemas.microsoft.com/office/drawing/2014/main" id="{81BD14A2-751C-4BFD-8998-53FC0334CDD3}"/>
               </a:ext>
             </a:extLst>
           </p:cNvPr>
@@ -28570,7 +28672,7 @@
     </p:spTree>
     <p:extLst>
       <p:ext uri="{BB962C8B-B14F-4D97-AF65-F5344CB8AC3E}">
-        <p14:creationId xmlns:p14="http://schemas.microsoft.com/office/powerpoint/2010/main" val="680985241"/>
+        <p14:creationId xmlns:p14="http://schemas.microsoft.com/office/powerpoint/2010/main" val="1926631281"/>
       </p:ext>
     </p:extLst>
   </p:cSld>
@@ -28601,7 +28703,7 @@
           <p:cNvPr id="9" name="25e · Prijzen, hoeveelheid en uitgaven">
             <a:extLst xmlns:a="http://schemas.openxmlformats.org/drawingml/2006/main">
               <a:ext uri="{FF2B5EF4-FFF2-40B4-BE49-F238E27FC236}">
-                <a16:creationId xmlns:a16="http://schemas.microsoft.com/office/drawing/2014/main" id="{A5FD2DAC-6FD0-4656-AFDE-801C81EC4EFB}"/>
+                <a16:creationId xmlns:a16="http://schemas.microsoft.com/office/drawing/2014/main" id="{1DD3564B-6B30-4633-B524-DFEEC7B8479F}"/>
               </a:ext>
             </a:extLst>
           </p:cNvPr>
@@ -28658,7 +28760,7 @@
           <p:cNvPr id="2" name="">
             <a:extLst xmlns:a="http://schemas.openxmlformats.org/drawingml/2006/main">
               <a:ext uri="{FF2B5EF4-FFF2-40B4-BE49-F238E27FC236}">
-                <a16:creationId xmlns:a16="http://schemas.microsoft.com/office/drawing/2014/main" id="{BFD74FEB-2EA1-4F8C-8968-8B1778D9E486}"/>
+                <a16:creationId xmlns:a16="http://schemas.microsoft.com/office/drawing/2014/main" id="{AA9F347B-6548-47CD-B4F3-0137AE393F70}"/>
               </a:ext>
             </a:extLst>
           </p:cNvPr>
@@ -28687,7 +28789,7 @@
           <p:cNvPr id="3" name="§3.1.3 Subsidies">
             <a:extLst xmlns:a="http://schemas.openxmlformats.org/drawingml/2006/main">
               <a:ext uri="{FF2B5EF4-FFF2-40B4-BE49-F238E27FC236}">
-                <a16:creationId xmlns:a16="http://schemas.microsoft.com/office/drawing/2014/main" id="{0E800038-1F88-470C-B356-A0E90C40D4DE}"/>
+                <a16:creationId xmlns:a16="http://schemas.microsoft.com/office/drawing/2014/main" id="{5F9F0DCC-E5C3-4D5D-A167-29D8CCCC45A6}"/>
               </a:ext>
             </a:extLst>
           </p:cNvPr>
@@ -28744,7 +28846,7 @@
           <p:cNvPr id="4" name="27">
             <a:extLst xmlns:a="http://schemas.openxmlformats.org/drawingml/2006/main">
               <a:ext uri="{FF2B5EF4-FFF2-40B4-BE49-F238E27FC236}">
-                <a16:creationId xmlns:a16="http://schemas.microsoft.com/office/drawing/2014/main" id="{6B476FD5-D648-4D4B-8C5B-2E6C6FEA89F2}"/>
+                <a16:creationId xmlns:a16="http://schemas.microsoft.com/office/drawing/2014/main" id="{8A73F232-0681-4F44-9AA8-7AC5D4563199}"/>
               </a:ext>
             </a:extLst>
           </p:cNvPr>
@@ -28808,7 +28910,7 @@
         </p:xfrm>
         <a:graphic xmlns:a="http://schemas.openxmlformats.org/drawingml/2006/main">
           <a:graphicData uri="http://schemas.openxmlformats.org/drawingml/2006/chart">
-            <c:chart xmlns:r="http://schemas.openxmlformats.org/officeDocument/2006/relationships" xmlns:c="http://schemas.openxmlformats.org/drawingml/2006/chart" r:id="Ra44ebc67ba30431d"/>
+            <c:chart xmlns:r="http://schemas.openxmlformats.org/officeDocument/2006/relationships" xmlns:c="http://schemas.openxmlformats.org/drawingml/2006/chart" r:id="R6d6436c1689f42e7"/>
           </a:graphicData>
         </a:graphic>
       </p:graphicFrame>
@@ -28817,7 +28919,7 @@
           <p:cNvPr id="6" name="Markeringen">
             <a:extLst xmlns:a="http://schemas.openxmlformats.org/drawingml/2006/main">
               <a:ext uri="{FF2B5EF4-FFF2-40B4-BE49-F238E27FC236}">
-                <a16:creationId xmlns:a16="http://schemas.microsoft.com/office/drawing/2014/main" id="{0BA0DF66-3DD0-4449-97CC-091C39A9D78D}"/>
+                <a16:creationId xmlns:a16="http://schemas.microsoft.com/office/drawing/2014/main" id="{D9F9F873-E848-4781-8AF1-BE65D2FF6DA9}"/>
               </a:ext>
             </a:extLst>
           </p:cNvPr>
@@ -28874,7 +28976,7 @@
           <p:cNvPr id="7" name="Qsub = 70&#10;Pc = € 12&#10;Pp = € 15&#10;&#10;U: 70 × € 3&#10;= € 210 per ">
             <a:extLst xmlns:a="http://schemas.openxmlformats.org/drawingml/2006/main">
               <a:ext uri="{FF2B5EF4-FFF2-40B4-BE49-F238E27FC236}">
-                <a16:creationId xmlns:a16="http://schemas.microsoft.com/office/drawing/2014/main" id="{6C0128C1-40BC-47CC-BCFB-E80C77424259}"/>
+                <a16:creationId xmlns:a16="http://schemas.microsoft.com/office/drawing/2014/main" id="{E26D6209-37A6-4915-986C-926204E5861F}"/>
               </a:ext>
             </a:extLst>
           </p:cNvPr>
@@ -29028,7 +29130,7 @@
           <p:cNvPr id="8" name="Rechthoek:&#10;Q = 0 tot 70&#10;P = 12 tot 15">
             <a:extLst xmlns:a="http://schemas.openxmlformats.org/drawingml/2006/main">
               <a:ext uri="{FF2B5EF4-FFF2-40B4-BE49-F238E27FC236}">
-                <a16:creationId xmlns:a16="http://schemas.microsoft.com/office/drawing/2014/main" id="{4E2122CC-0DCA-4B0C-A784-CC0D8231ABF4}"/>
+                <a16:creationId xmlns:a16="http://schemas.microsoft.com/office/drawing/2014/main" id="{DD4DE7E9-1DE8-429C-A28E-D14A9EED44EB}"/>
               </a:ext>
             </a:extLst>
           </p:cNvPr>
@@ -29129,7 +29231,7 @@
     </p:spTree>
     <p:extLst>
       <p:ext uri="{BB962C8B-B14F-4D97-AF65-F5344CB8AC3E}">
-        <p14:creationId xmlns:p14="http://schemas.microsoft.com/office/powerpoint/2010/main" val="425639799"/>
+        <p14:creationId xmlns:p14="http://schemas.microsoft.com/office/powerpoint/2010/main" val="591111583"/>
       </p:ext>
     </p:extLst>
   </p:cSld>
@@ -29160,7 +29262,7 @@
           <p:cNvPr id="9" name="25e · De welvaartsclaim">
             <a:extLst xmlns:a="http://schemas.openxmlformats.org/drawingml/2006/main">
               <a:ext uri="{FF2B5EF4-FFF2-40B4-BE49-F238E27FC236}">
-                <a16:creationId xmlns:a16="http://schemas.microsoft.com/office/drawing/2014/main" id="{BDCC4B2D-287D-416B-92B5-F0347D89928D}"/>
+                <a16:creationId xmlns:a16="http://schemas.microsoft.com/office/drawing/2014/main" id="{86268DFC-800A-4802-B644-47FBA5DDBAC1}"/>
               </a:ext>
             </a:extLst>
           </p:cNvPr>
@@ -29217,7 +29319,7 @@
           <p:cNvPr id="2" name="">
             <a:extLst xmlns:a="http://schemas.openxmlformats.org/drawingml/2006/main">
               <a:ext uri="{FF2B5EF4-FFF2-40B4-BE49-F238E27FC236}">
-                <a16:creationId xmlns:a16="http://schemas.microsoft.com/office/drawing/2014/main" id="{8F3BA063-D1CA-45BD-9276-D7AD88B91532}"/>
+                <a16:creationId xmlns:a16="http://schemas.microsoft.com/office/drawing/2014/main" id="{DFEBE50E-29A9-47EE-8A5D-B14B200CBB3A}"/>
               </a:ext>
             </a:extLst>
           </p:cNvPr>
@@ -29246,7 +29348,7 @@
           <p:cNvPr id="3" name="§3.1.3 Subsidies">
             <a:extLst xmlns:a="http://schemas.openxmlformats.org/drawingml/2006/main">
               <a:ext uri="{FF2B5EF4-FFF2-40B4-BE49-F238E27FC236}">
-                <a16:creationId xmlns:a16="http://schemas.microsoft.com/office/drawing/2014/main" id="{D639508C-1CDC-4900-97FF-AF03AF9EF6AE}"/>
+                <a16:creationId xmlns:a16="http://schemas.microsoft.com/office/drawing/2014/main" id="{448A526B-9BF3-4D62-9C67-BB1010E57A15}"/>
               </a:ext>
             </a:extLst>
           </p:cNvPr>
@@ -29303,7 +29405,7 @@
           <p:cNvPr id="4" name="28">
             <a:extLst xmlns:a="http://schemas.openxmlformats.org/drawingml/2006/main">
               <a:ext uri="{FF2B5EF4-FFF2-40B4-BE49-F238E27FC236}">
-                <a16:creationId xmlns:a16="http://schemas.microsoft.com/office/drawing/2014/main" id="{C31E9B49-0FD3-4719-B5CB-61D1D495683D}"/>
+                <a16:creationId xmlns:a16="http://schemas.microsoft.com/office/drawing/2014/main" id="{74B756C2-6BEC-4FB0-934E-3CCCCE30E1C3}"/>
               </a:ext>
             </a:extLst>
           </p:cNvPr>
@@ -29360,7 +29462,7 @@
           <p:cNvPr id="5" name="“De subsidie verhoogt in dit model automatisch de welva">
             <a:extLst xmlns:a="http://schemas.openxmlformats.org/drawingml/2006/main">
               <a:ext uri="{FF2B5EF4-FFF2-40B4-BE49-F238E27FC236}">
-                <a16:creationId xmlns:a16="http://schemas.microsoft.com/office/drawing/2014/main" id="{8021A84F-C516-431C-9F89-7AEF74BB1050}"/>
+                <a16:creationId xmlns:a16="http://schemas.microsoft.com/office/drawing/2014/main" id="{FDC24195-CE9B-4724-AA04-D585846596AB}"/>
               </a:ext>
             </a:extLst>
           </p:cNvPr>
@@ -29417,7 +29519,7 @@
           <p:cNvPr id="6" name="Onjuist: de welvaartsmaat daalt van € 540 naar € 525 pe">
             <a:extLst xmlns:a="http://schemas.openxmlformats.org/drawingml/2006/main">
               <a:ext uri="{FF2B5EF4-FFF2-40B4-BE49-F238E27FC236}">
-                <a16:creationId xmlns:a16="http://schemas.microsoft.com/office/drawing/2014/main" id="{6801AA44-A388-4C66-B653-C5F553C97FB5}"/>
+                <a16:creationId xmlns:a16="http://schemas.microsoft.com/office/drawing/2014/main" id="{9E983181-4BBF-40BB-8010-5605AF8A67B1}"/>
               </a:ext>
             </a:extLst>
           </p:cNvPr>
@@ -29474,7 +29576,7 @@
           <p:cNvPr id="7" name="De extra transacties kosten meer dan hun betalingsberei">
             <a:extLst xmlns:a="http://schemas.openxmlformats.org/drawingml/2006/main">
               <a:ext uri="{FF2B5EF4-FFF2-40B4-BE49-F238E27FC236}">
-                <a16:creationId xmlns:a16="http://schemas.microsoft.com/office/drawing/2014/main" id="{B8E450D1-9E1A-4075-B6F6-4A8261A92ABF}"/>
+                <a16:creationId xmlns:a16="http://schemas.microsoft.com/office/drawing/2014/main" id="{0AC61612-1504-47F1-B370-72D4EE718404}"/>
               </a:ext>
             </a:extLst>
           </p:cNvPr>
@@ -29531,7 +29633,7 @@
           <p:cNvPr id="8" name="Er zijn geen baten voor buitenstaanders die dat compens">
             <a:extLst xmlns:a="http://schemas.openxmlformats.org/drawingml/2006/main">
               <a:ext uri="{FF2B5EF4-FFF2-40B4-BE49-F238E27FC236}">
-                <a16:creationId xmlns:a16="http://schemas.microsoft.com/office/drawing/2014/main" id="{3CE9B3B2-4BC3-42B7-A223-8BA795AF1EC0}"/>
+                <a16:creationId xmlns:a16="http://schemas.microsoft.com/office/drawing/2014/main" id="{EBAE5ADC-3C11-43ED-A0E2-E2F95B8403FA}"/>
               </a:ext>
             </a:extLst>
           </p:cNvPr>
@@ -29586,7 +29688,7 @@
     </p:spTree>
     <p:extLst>
       <p:ext uri="{BB962C8B-B14F-4D97-AF65-F5344CB8AC3E}">
-        <p14:creationId xmlns:p14="http://schemas.microsoft.com/office/powerpoint/2010/main" val="1014106906"/>
+        <p14:creationId xmlns:p14="http://schemas.microsoft.com/office/powerpoint/2010/main" val="385857933"/>
       </p:ext>
     </p:extLst>
   </p:cSld>
@@ -29617,7 +29719,7 @@
           <p:cNvPr id="29" name="Deze les: §3.1.3 Subsidies">
             <a:extLst xmlns:a="http://schemas.openxmlformats.org/drawingml/2006/main">
               <a:ext uri="{FF2B5EF4-FFF2-40B4-BE49-F238E27FC236}">
-                <a16:creationId xmlns:a16="http://schemas.microsoft.com/office/drawing/2014/main" id="{E0333B72-2B9F-4E18-9AA9-8989435BD3D2}"/>
+                <a16:creationId xmlns:a16="http://schemas.microsoft.com/office/drawing/2014/main" id="{E931D42F-899E-4375-864A-6D65867B16DC}"/>
               </a:ext>
             </a:extLst>
           </p:cNvPr>
@@ -29674,7 +29776,7 @@
           <p:cNvPr id="2" name="">
             <a:extLst xmlns:a="http://schemas.openxmlformats.org/drawingml/2006/main">
               <a:ext uri="{FF2B5EF4-FFF2-40B4-BE49-F238E27FC236}">
-                <a16:creationId xmlns:a16="http://schemas.microsoft.com/office/drawing/2014/main" id="{0BD78F63-E180-46CC-A5EF-7A22B3D33C57}"/>
+                <a16:creationId xmlns:a16="http://schemas.microsoft.com/office/drawing/2014/main" id="{0EA272AB-42AA-45C1-A08D-37F4B3DCECE6}"/>
               </a:ext>
             </a:extLst>
           </p:cNvPr>
@@ -29703,7 +29805,7 @@
           <p:cNvPr id="3" name="§3.1.3 Subsidies">
             <a:extLst xmlns:a="http://schemas.openxmlformats.org/drawingml/2006/main">
               <a:ext uri="{FF2B5EF4-FFF2-40B4-BE49-F238E27FC236}">
-                <a16:creationId xmlns:a16="http://schemas.microsoft.com/office/drawing/2014/main" id="{F45E78F8-88D0-4665-9C70-DBD5FA1C2584}"/>
+                <a16:creationId xmlns:a16="http://schemas.microsoft.com/office/drawing/2014/main" id="{18CD7ED1-BC3D-4155-B666-566FF4FC36BF}"/>
               </a:ext>
             </a:extLst>
           </p:cNvPr>
@@ -29760,7 +29862,7 @@
           <p:cNvPr id="4" name="29">
             <a:extLst xmlns:a="http://schemas.openxmlformats.org/drawingml/2006/main">
               <a:ext uri="{FF2B5EF4-FFF2-40B4-BE49-F238E27FC236}">
-                <a16:creationId xmlns:a16="http://schemas.microsoft.com/office/drawing/2014/main" id="{80CAD040-F007-44E1-9CA8-F83421134A19}"/>
+                <a16:creationId xmlns:a16="http://schemas.microsoft.com/office/drawing/2014/main" id="{4846CEC6-21D9-4799-9CD5-532338E90903}"/>
               </a:ext>
             </a:extLst>
           </p:cNvPr>
@@ -29817,7 +29919,7 @@
           <p:cNvPr id="5" name="phase">
             <a:extLst xmlns:a="http://schemas.openxmlformats.org/drawingml/2006/main">
               <a:ext uri="{FF2B5EF4-FFF2-40B4-BE49-F238E27FC236}">
-                <a16:creationId xmlns:a16="http://schemas.microsoft.com/office/drawing/2014/main" id="{3D5F84DB-7671-4873-8405-6905B8F97CCA}"/>
+                <a16:creationId xmlns:a16="http://schemas.microsoft.com/office/drawing/2014/main" id="{D6D3754A-E4B1-4229-94A8-9BD075B50821}"/>
               </a:ext>
             </a:extLst>
           </p:cNvPr>
@@ -29874,7 +29976,7 @@
           <p:cNvPr id="6" name="Lesroute">
             <a:extLst xmlns:a="http://schemas.openxmlformats.org/drawingml/2006/main">
               <a:ext uri="{FF2B5EF4-FFF2-40B4-BE49-F238E27FC236}">
-                <a16:creationId xmlns:a16="http://schemas.microsoft.com/office/drawing/2014/main" id="{E4021823-FE46-4455-98FB-973FB3F03D57}"/>
+                <a16:creationId xmlns:a16="http://schemas.microsoft.com/office/drawing/2014/main" id="{D7809E81-C7A3-4F8E-ABE7-CFC9870796AB}"/>
               </a:ext>
             </a:extLst>
           </p:cNvPr>
@@ -29931,7 +30033,7 @@
           <p:cNvPr id="7" name="route-number-0">
             <a:extLst xmlns:a="http://schemas.openxmlformats.org/drawingml/2006/main">
               <a:ext uri="{FF2B5EF4-FFF2-40B4-BE49-F238E27FC236}">
-                <a16:creationId xmlns:a16="http://schemas.microsoft.com/office/drawing/2014/main" id="{560DD99C-89FD-4CC9-AEF4-7B245021BEEA}"/>
+                <a16:creationId xmlns:a16="http://schemas.microsoft.com/office/drawing/2014/main" id="{D3F1D103-F091-457F-97CD-F1005229AD29}"/>
               </a:ext>
             </a:extLst>
           </p:cNvPr>
@@ -29988,7 +30090,7 @@
           <p:cNvPr id="8" name="route-0">
             <a:extLst xmlns:a="http://schemas.openxmlformats.org/drawingml/2006/main">
               <a:ext uri="{FF2B5EF4-FFF2-40B4-BE49-F238E27FC236}">
-                <a16:creationId xmlns:a16="http://schemas.microsoft.com/office/drawing/2014/main" id="{5FA04921-C904-400E-AEDA-B56F80C397D0}"/>
+                <a16:creationId xmlns:a16="http://schemas.microsoft.com/office/drawing/2014/main" id="{A8E1782C-F4F1-49F4-BA99-41E17F49172F}"/>
               </a:ext>
             </a:extLst>
           </p:cNvPr>
@@ -30045,7 +30147,7 @@
           <p:cNvPr id="9" name="route-number-1">
             <a:extLst xmlns:a="http://schemas.openxmlformats.org/drawingml/2006/main">
               <a:ext uri="{FF2B5EF4-FFF2-40B4-BE49-F238E27FC236}">
-                <a16:creationId xmlns:a16="http://schemas.microsoft.com/office/drawing/2014/main" id="{CA78D944-FE2B-47D7-8F22-0AA34D123648}"/>
+                <a16:creationId xmlns:a16="http://schemas.microsoft.com/office/drawing/2014/main" id="{BD77E639-0643-435D-B447-83F21BB1AEA1}"/>
               </a:ext>
             </a:extLst>
           </p:cNvPr>
@@ -30102,7 +30204,7 @@
           <p:cNvPr id="10" name="route-1">
             <a:extLst xmlns:a="http://schemas.openxmlformats.org/drawingml/2006/main">
               <a:ext uri="{FF2B5EF4-FFF2-40B4-BE49-F238E27FC236}">
-                <a16:creationId xmlns:a16="http://schemas.microsoft.com/office/drawing/2014/main" id="{66C991D4-CE21-4FCA-A93F-965D493ED68A}"/>
+                <a16:creationId xmlns:a16="http://schemas.microsoft.com/office/drawing/2014/main" id="{5AFE6F51-ACC9-4294-ABC7-022100B9987D}"/>
               </a:ext>
             </a:extLst>
           </p:cNvPr>
@@ -30159,7 +30261,7 @@
           <p:cNvPr id="11" name="route-number-2">
             <a:extLst xmlns:a="http://schemas.openxmlformats.org/drawingml/2006/main">
               <a:ext uri="{FF2B5EF4-FFF2-40B4-BE49-F238E27FC236}">
-                <a16:creationId xmlns:a16="http://schemas.microsoft.com/office/drawing/2014/main" id="{EFC4951C-6F87-4349-83EC-A508CE1839D7}"/>
+                <a16:creationId xmlns:a16="http://schemas.microsoft.com/office/drawing/2014/main" id="{CBCD0CC3-7A65-4C63-B72F-2ACFAC7BB262}"/>
               </a:ext>
             </a:extLst>
           </p:cNvPr>
@@ -30216,7 +30318,7 @@
           <p:cNvPr id="12" name="route-2">
             <a:extLst xmlns:a="http://schemas.openxmlformats.org/drawingml/2006/main">
               <a:ext uri="{FF2B5EF4-FFF2-40B4-BE49-F238E27FC236}">
-                <a16:creationId xmlns:a16="http://schemas.microsoft.com/office/drawing/2014/main" id="{F30F32E1-CD29-46D6-8F59-FFED1545CEF7}"/>
+                <a16:creationId xmlns:a16="http://schemas.microsoft.com/office/drawing/2014/main" id="{DFB0FDF2-DC75-4391-A4F4-FEB2B21CFCC7}"/>
               </a:ext>
             </a:extLst>
           </p:cNvPr>
@@ -30273,7 +30375,7 @@
           <p:cNvPr id="13" name="route-number-3">
             <a:extLst xmlns:a="http://schemas.openxmlformats.org/drawingml/2006/main">
               <a:ext uri="{FF2B5EF4-FFF2-40B4-BE49-F238E27FC236}">
-                <a16:creationId xmlns:a16="http://schemas.microsoft.com/office/drawing/2014/main" id="{824D7B93-CEAA-4AD9-B037-13635F91CB2F}"/>
+                <a16:creationId xmlns:a16="http://schemas.microsoft.com/office/drawing/2014/main" id="{49B099E6-5D57-4020-AC07-683ED700F65E}"/>
               </a:ext>
             </a:extLst>
           </p:cNvPr>
@@ -30330,7 +30432,7 @@
           <p:cNvPr id="14" name="route-3">
             <a:extLst xmlns:a="http://schemas.openxmlformats.org/drawingml/2006/main">
               <a:ext uri="{FF2B5EF4-FFF2-40B4-BE49-F238E27FC236}">
-                <a16:creationId xmlns:a16="http://schemas.microsoft.com/office/drawing/2014/main" id="{F3BDD81D-B153-4DB5-8DF5-CFF5C21DC3C1}"/>
+                <a16:creationId xmlns:a16="http://schemas.microsoft.com/office/drawing/2014/main" id="{3EC20D05-6DBE-4DFD-8693-C8232CC60C1A}"/>
               </a:ext>
             </a:extLst>
           </p:cNvPr>
@@ -30387,7 +30489,7 @@
           <p:cNvPr id="15" name="route-number-4">
             <a:extLst xmlns:a="http://schemas.openxmlformats.org/drawingml/2006/main">
               <a:ext uri="{FF2B5EF4-FFF2-40B4-BE49-F238E27FC236}">
-                <a16:creationId xmlns:a16="http://schemas.microsoft.com/office/drawing/2014/main" id="{98F025F1-E8C3-4191-A5B6-2FDFFBC3FDE7}"/>
+                <a16:creationId xmlns:a16="http://schemas.microsoft.com/office/drawing/2014/main" id="{F0DBC9A7-ECBF-4CF1-A123-2E4B206E6F5F}"/>
               </a:ext>
             </a:extLst>
           </p:cNvPr>
@@ -30444,7 +30546,7 @@
           <p:cNvPr id="16" name="route-4">
             <a:extLst xmlns:a="http://schemas.openxmlformats.org/drawingml/2006/main">
               <a:ext uri="{FF2B5EF4-FFF2-40B4-BE49-F238E27FC236}">
-                <a16:creationId xmlns:a16="http://schemas.microsoft.com/office/drawing/2014/main" id="{E17955BD-4E74-4F6A-9556-03B802BB4C1A}"/>
+                <a16:creationId xmlns:a16="http://schemas.microsoft.com/office/drawing/2014/main" id="{CC0D11E2-8663-4959-AE8F-DDA95B4AC726}"/>
               </a:ext>
             </a:extLst>
           </p:cNvPr>
@@ -30501,7 +30603,7 @@
           <p:cNvPr id="17" name="route-number-5">
             <a:extLst xmlns:a="http://schemas.openxmlformats.org/drawingml/2006/main">
               <a:ext uri="{FF2B5EF4-FFF2-40B4-BE49-F238E27FC236}">
-                <a16:creationId xmlns:a16="http://schemas.microsoft.com/office/drawing/2014/main" id="{ECDB1191-04EA-4D3F-A26B-4F53909E0437}"/>
+                <a16:creationId xmlns:a16="http://schemas.microsoft.com/office/drawing/2014/main" id="{2594BCDB-C41C-4003-B44B-C8713156F938}"/>
               </a:ext>
             </a:extLst>
           </p:cNvPr>
@@ -30558,7 +30660,7 @@
           <p:cNvPr id="18" name="route-5">
             <a:extLst xmlns:a="http://schemas.openxmlformats.org/drawingml/2006/main">
               <a:ext uri="{FF2B5EF4-FFF2-40B4-BE49-F238E27FC236}">
-                <a16:creationId xmlns:a16="http://schemas.microsoft.com/office/drawing/2014/main" id="{8FCECC5D-A6CF-41BB-8D2E-F77C68DAA142}"/>
+                <a16:creationId xmlns:a16="http://schemas.microsoft.com/office/drawing/2014/main" id="{FF5766F2-E05F-405A-996B-D9442B599E84}"/>
               </a:ext>
             </a:extLst>
           </p:cNvPr>
@@ -30615,7 +30717,7 @@
           <p:cNvPr id="19" name="route-number-6">
             <a:extLst xmlns:a="http://schemas.openxmlformats.org/drawingml/2006/main">
               <a:ext uri="{FF2B5EF4-FFF2-40B4-BE49-F238E27FC236}">
-                <a16:creationId xmlns:a16="http://schemas.microsoft.com/office/drawing/2014/main" id="{8CD91FFA-EE74-48EA-952D-B9F397E5B5DC}"/>
+                <a16:creationId xmlns:a16="http://schemas.microsoft.com/office/drawing/2014/main" id="{DD788056-87B9-4EF7-924A-C94D386816F7}"/>
               </a:ext>
             </a:extLst>
           </p:cNvPr>
@@ -30672,7 +30774,7 @@
           <p:cNvPr id="20" name="route-6">
             <a:extLst xmlns:a="http://schemas.openxmlformats.org/drawingml/2006/main">
               <a:ext uri="{FF2B5EF4-FFF2-40B4-BE49-F238E27FC236}">
-                <a16:creationId xmlns:a16="http://schemas.microsoft.com/office/drawing/2014/main" id="{DA4DBE39-3D72-4103-AA1A-A89A36C954E3}"/>
+                <a16:creationId xmlns:a16="http://schemas.microsoft.com/office/drawing/2014/main" id="{67E29A6C-1663-4163-9812-4C2DD6C18338}"/>
               </a:ext>
             </a:extLst>
           </p:cNvPr>
@@ -30729,7 +30831,7 @@
           <p:cNvPr id="21" name="Lesdoelen">
             <a:extLst xmlns:a="http://schemas.openxmlformats.org/drawingml/2006/main">
               <a:ext uri="{FF2B5EF4-FFF2-40B4-BE49-F238E27FC236}">
-                <a16:creationId xmlns:a16="http://schemas.microsoft.com/office/drawing/2014/main" id="{E5227048-E2FB-4C37-9D15-2E45E75400E7}"/>
+                <a16:creationId xmlns:a16="http://schemas.microsoft.com/office/drawing/2014/main" id="{D1A0C231-78EC-4940-997E-C27E12158564}"/>
               </a:ext>
             </a:extLst>
           </p:cNvPr>
@@ -30786,7 +30888,7 @@
           <p:cNvPr id="22" name="overview-goals">
             <a:extLst xmlns:a="http://schemas.openxmlformats.org/drawingml/2006/main">
               <a:ext uri="{FF2B5EF4-FFF2-40B4-BE49-F238E27FC236}">
-                <a16:creationId xmlns:a16="http://schemas.microsoft.com/office/drawing/2014/main" id="{0FA3A1C3-69A2-4121-ADF3-608C1EA46768}"/>
+                <a16:creationId xmlns:a16="http://schemas.microsoft.com/office/drawing/2014/main" id="{012B5CC4-FFFB-487F-A07E-5E8F9C58CD4C}"/>
               </a:ext>
             </a:extLst>
           </p:cNvPr>
@@ -30889,7 +30991,7 @@
           <p:cNvPr id="23" name="">
             <a:extLst xmlns:a="http://schemas.openxmlformats.org/drawingml/2006/main">
               <a:ext uri="{FF2B5EF4-FFF2-40B4-BE49-F238E27FC236}">
-                <a16:creationId xmlns:a16="http://schemas.microsoft.com/office/drawing/2014/main" id="{F6D91A4D-3942-4D7B-B5EF-3B04C180D5FD}"/>
+                <a16:creationId xmlns:a16="http://schemas.microsoft.com/office/drawing/2014/main" id="{1492B11C-FD39-4D27-B2B5-6E23DAA2253E}"/>
               </a:ext>
             </a:extLst>
           </p:cNvPr>
@@ -30918,7 +31020,7 @@
           <p:cNvPr id="24" name="Startopdracht">
             <a:extLst xmlns:a="http://schemas.openxmlformats.org/drawingml/2006/main">
               <a:ext uri="{FF2B5EF4-FFF2-40B4-BE49-F238E27FC236}">
-                <a16:creationId xmlns:a16="http://schemas.microsoft.com/office/drawing/2014/main" id="{82F3E485-E2AC-43EC-A4B6-1D20ABFEF91C}"/>
+                <a16:creationId xmlns:a16="http://schemas.microsoft.com/office/drawing/2014/main" id="{870284AD-03F0-40CF-91B7-CDB20525F30B}"/>
               </a:ext>
             </a:extLst>
           </p:cNvPr>
@@ -30975,7 +31077,7 @@
           <p:cNvPr id="25" name="overview-start">
             <a:extLst xmlns:a="http://schemas.openxmlformats.org/drawingml/2006/main">
               <a:ext uri="{FF2B5EF4-FFF2-40B4-BE49-F238E27FC236}">
-                <a16:creationId xmlns:a16="http://schemas.microsoft.com/office/drawing/2014/main" id="{4F8EAFFE-3FE8-409B-83AF-B2CD9FAF0699}"/>
+                <a16:creationId xmlns:a16="http://schemas.microsoft.com/office/drawing/2014/main" id="{CEBDCD87-E7F8-4AD9-BA44-AD84020F55FC}"/>
               </a:ext>
             </a:extLst>
           </p:cNvPr>
@@ -31078,7 +31180,7 @@
           <p:cNvPr id="26" name="">
             <a:extLst xmlns:a="http://schemas.openxmlformats.org/drawingml/2006/main">
               <a:ext uri="{FF2B5EF4-FFF2-40B4-BE49-F238E27FC236}">
-                <a16:creationId xmlns:a16="http://schemas.microsoft.com/office/drawing/2014/main" id="{55E371AE-ECF9-429C-8CEC-0F5F75EBCA93}"/>
+                <a16:creationId xmlns:a16="http://schemas.microsoft.com/office/drawing/2014/main" id="{A921F0EA-440C-4FAE-BB67-D7508B29C463}"/>
               </a:ext>
             </a:extLst>
           </p:cNvPr>
@@ -31107,7 +31209,7 @@
           <p:cNvPr id="27" name="Huiswerk">
             <a:extLst xmlns:a="http://schemas.openxmlformats.org/drawingml/2006/main">
               <a:ext uri="{FF2B5EF4-FFF2-40B4-BE49-F238E27FC236}">
-                <a16:creationId xmlns:a16="http://schemas.microsoft.com/office/drawing/2014/main" id="{ED77E88F-E411-40C4-B595-FB09057F9E1A}"/>
+                <a16:creationId xmlns:a16="http://schemas.microsoft.com/office/drawing/2014/main" id="{BFDFC5DD-9926-48C9-B307-F8F73203DBA9}"/>
               </a:ext>
             </a:extLst>
           </p:cNvPr>
@@ -31164,7 +31266,7 @@
           <p:cNvPr id="28" name="overview-homework">
             <a:extLst xmlns:a="http://schemas.openxmlformats.org/drawingml/2006/main">
               <a:ext uri="{FF2B5EF4-FFF2-40B4-BE49-F238E27FC236}">
-                <a16:creationId xmlns:a16="http://schemas.microsoft.com/office/drawing/2014/main" id="{F18BBDD0-F6B2-45D3-BB7C-20B244BE935E}"/>
+                <a16:creationId xmlns:a16="http://schemas.microsoft.com/office/drawing/2014/main" id="{0D9F79CD-D045-4883-A3C8-F34DB01224CA}"/>
               </a:ext>
             </a:extLst>
           </p:cNvPr>
@@ -31311,7 +31413,7 @@
     </p:spTree>
     <p:extLst>
       <p:ext uri="{BB962C8B-B14F-4D97-AF65-F5344CB8AC3E}">
-        <p14:creationId xmlns:p14="http://schemas.microsoft.com/office/powerpoint/2010/main" val="1422616291"/>
+        <p14:creationId xmlns:p14="http://schemas.microsoft.com/office/powerpoint/2010/main" val="1165150176"/>
       </p:ext>
     </p:extLst>
   </p:cSld>
@@ -31342,7 +31444,7 @@
           <p:cNvPr id="8" name="Fietscontroles">
             <a:extLst xmlns:a="http://schemas.openxmlformats.org/drawingml/2006/main">
               <a:ext uri="{FF2B5EF4-FFF2-40B4-BE49-F238E27FC236}">
-                <a16:creationId xmlns:a16="http://schemas.microsoft.com/office/drawing/2014/main" id="{B0973E3D-3B0C-4D16-B3A4-5125AE9BEED9}"/>
+                <a16:creationId xmlns:a16="http://schemas.microsoft.com/office/drawing/2014/main" id="{26D53DCB-9814-42DA-A43D-7A685376EE2E}"/>
               </a:ext>
             </a:extLst>
           </p:cNvPr>
@@ -31399,7 +31501,7 @@
           <p:cNvPr id="2" name="">
             <a:extLst xmlns:a="http://schemas.openxmlformats.org/drawingml/2006/main">
               <a:ext uri="{FF2B5EF4-FFF2-40B4-BE49-F238E27FC236}">
-                <a16:creationId xmlns:a16="http://schemas.microsoft.com/office/drawing/2014/main" id="{D5049864-497A-45F6-BFEF-20B96512DEDC}"/>
+                <a16:creationId xmlns:a16="http://schemas.microsoft.com/office/drawing/2014/main" id="{F9720B5D-304A-478F-BA58-389E1BBD9062}"/>
               </a:ext>
             </a:extLst>
           </p:cNvPr>
@@ -31428,7 +31530,7 @@
           <p:cNvPr id="3" name="Uitlegvoorbeeld — niet uit het boek">
             <a:extLst xmlns:a="http://schemas.openxmlformats.org/drawingml/2006/main">
               <a:ext uri="{FF2B5EF4-FFF2-40B4-BE49-F238E27FC236}">
-                <a16:creationId xmlns:a16="http://schemas.microsoft.com/office/drawing/2014/main" id="{3EFC2C94-3D5B-4B2B-AE0C-4BA0FEFD8AB7}"/>
+                <a16:creationId xmlns:a16="http://schemas.microsoft.com/office/drawing/2014/main" id="{E403C0F1-FD74-4C4C-91D6-188B79DA58A6}"/>
               </a:ext>
             </a:extLst>
           </p:cNvPr>
@@ -31485,7 +31587,7 @@
           <p:cNvPr id="4" name="3">
             <a:extLst xmlns:a="http://schemas.openxmlformats.org/drawingml/2006/main">
               <a:ext uri="{FF2B5EF4-FFF2-40B4-BE49-F238E27FC236}">
-                <a16:creationId xmlns:a16="http://schemas.microsoft.com/office/drawing/2014/main" id="{85B2ADE2-9D29-43FE-BE81-7A99C7C429A1}"/>
+                <a16:creationId xmlns:a16="http://schemas.microsoft.com/office/drawing/2014/main" id="{F38F45BC-6825-4A55-BBFD-D0BBC47D5C85}"/>
               </a:ext>
             </a:extLst>
           </p:cNvPr>
@@ -31542,7 +31644,7 @@
           <p:cNvPr id="5" name="Een fictieve markt voor een eenvoudige fietscontrole">
             <a:extLst xmlns:a="http://schemas.openxmlformats.org/drawingml/2006/main">
               <a:ext uri="{FF2B5EF4-FFF2-40B4-BE49-F238E27FC236}">
-                <a16:creationId xmlns:a16="http://schemas.microsoft.com/office/drawing/2014/main" id="{49CA8573-10C4-490A-A16B-C2F4DE082287}"/>
+                <a16:creationId xmlns:a16="http://schemas.microsoft.com/office/drawing/2014/main" id="{38E55F82-0E33-4EF4-9703-3AC23A2CC603}"/>
               </a:ext>
             </a:extLst>
           </p:cNvPr>
@@ -31821,7 +31923,7 @@
           <p:cNvPr id="7" name="Geen baten voor buitenstaanders en geen uitvoeringskost">
             <a:extLst xmlns:a="http://schemas.openxmlformats.org/drawingml/2006/main">
               <a:ext uri="{FF2B5EF4-FFF2-40B4-BE49-F238E27FC236}">
-                <a16:creationId xmlns:a16="http://schemas.microsoft.com/office/drawing/2014/main" id="{817705D3-61A8-480B-A9BB-D13F1D23AA0C}"/>
+                <a16:creationId xmlns:a16="http://schemas.microsoft.com/office/drawing/2014/main" id="{E884D2A5-BD8E-4822-8A8D-83A21E79731A}"/>
               </a:ext>
             </a:extLst>
           </p:cNvPr>
@@ -31876,7 +31978,7 @@
     </p:spTree>
     <p:extLst>
       <p:ext uri="{BB962C8B-B14F-4D97-AF65-F5344CB8AC3E}">
-        <p14:creationId xmlns:p14="http://schemas.microsoft.com/office/powerpoint/2010/main" val="639641860"/>
+        <p14:creationId xmlns:p14="http://schemas.microsoft.com/office/powerpoint/2010/main" val="939572058"/>
       </p:ext>
     </p:extLst>
   </p:cSld>
@@ -31907,7 +32009,7 @@
           <p:cNvPr id="9" name="Zonder subsidie: één evenwichtsprijs">
             <a:extLst xmlns:a="http://schemas.openxmlformats.org/drawingml/2006/main">
               <a:ext uri="{FF2B5EF4-FFF2-40B4-BE49-F238E27FC236}">
-                <a16:creationId xmlns:a16="http://schemas.microsoft.com/office/drawing/2014/main" id="{8C145979-A5CF-4E12-A105-024BB6765568}"/>
+                <a16:creationId xmlns:a16="http://schemas.microsoft.com/office/drawing/2014/main" id="{B536A247-1A44-464C-ACD8-C96663BE5FC3}"/>
               </a:ext>
             </a:extLst>
           </p:cNvPr>
@@ -31964,7 +32066,7 @@
           <p:cNvPr id="2" name="">
             <a:extLst xmlns:a="http://schemas.openxmlformats.org/drawingml/2006/main">
               <a:ext uri="{FF2B5EF4-FFF2-40B4-BE49-F238E27FC236}">
-                <a16:creationId xmlns:a16="http://schemas.microsoft.com/office/drawing/2014/main" id="{2ABB625F-909F-4729-849D-B23A5DF0D794}"/>
+                <a16:creationId xmlns:a16="http://schemas.microsoft.com/office/drawing/2014/main" id="{AD07D8BB-2AE1-4FBB-A6BB-C80FAD88BE64}"/>
               </a:ext>
             </a:extLst>
           </p:cNvPr>
@@ -31993,7 +32095,7 @@
           <p:cNvPr id="3" name="Uitlegvoorbeeld — niet uit het boek">
             <a:extLst xmlns:a="http://schemas.openxmlformats.org/drawingml/2006/main">
               <a:ext uri="{FF2B5EF4-FFF2-40B4-BE49-F238E27FC236}">
-                <a16:creationId xmlns:a16="http://schemas.microsoft.com/office/drawing/2014/main" id="{0570A171-B9F7-41ED-9F4A-77984720616E}"/>
+                <a16:creationId xmlns:a16="http://schemas.microsoft.com/office/drawing/2014/main" id="{B06C0C3C-BD8F-4126-91FD-2BDE36A8563C}"/>
               </a:ext>
             </a:extLst>
           </p:cNvPr>
@@ -32050,7 +32152,7 @@
           <p:cNvPr id="4" name="4">
             <a:extLst xmlns:a="http://schemas.openxmlformats.org/drawingml/2006/main">
               <a:ext uri="{FF2B5EF4-FFF2-40B4-BE49-F238E27FC236}">
-                <a16:creationId xmlns:a16="http://schemas.microsoft.com/office/drawing/2014/main" id="{CFAC73FD-26F3-49FB-9D8D-281C41B30BE9}"/>
+                <a16:creationId xmlns:a16="http://schemas.microsoft.com/office/drawing/2014/main" id="{7D983FD5-F481-49B3-8A92-EA71D8A11EDF}"/>
               </a:ext>
             </a:extLst>
           </p:cNvPr>
@@ -32114,7 +32216,7 @@
         </p:xfrm>
         <a:graphic xmlns:a="http://schemas.openxmlformats.org/drawingml/2006/main">
           <a:graphicData uri="http://schemas.openxmlformats.org/drawingml/2006/chart">
-            <c:chart xmlns:r="http://schemas.openxmlformats.org/officeDocument/2006/relationships" xmlns:c="http://schemas.openxmlformats.org/drawingml/2006/chart" r:id="R4aa67554d66f4aa7"/>
+            <c:chart xmlns:r="http://schemas.openxmlformats.org/officeDocument/2006/relationships" xmlns:c="http://schemas.openxmlformats.org/drawingml/2006/chart" r:id="Rb873160e3b864649"/>
           </a:graphicData>
         </a:graphic>
       </p:graphicFrame>
@@ -32123,7 +32225,7 @@
           <p:cNvPr id="6" name="V = A">
             <a:extLst xmlns:a="http://schemas.openxmlformats.org/drawingml/2006/main">
               <a:ext uri="{FF2B5EF4-FFF2-40B4-BE49-F238E27FC236}">
-                <a16:creationId xmlns:a16="http://schemas.microsoft.com/office/drawing/2014/main" id="{D14A6146-5047-4F76-A909-142701FA46A5}"/>
+                <a16:creationId xmlns:a16="http://schemas.microsoft.com/office/drawing/2014/main" id="{896581EC-FFF9-4B52-9154-B8223303451C}"/>
               </a:ext>
             </a:extLst>
           </p:cNvPr>
@@ -32180,7 +32282,7 @@
           <p:cNvPr id="7" name="32 − 0,20Q&#10;= 8 + 0,10Q&#10;&#10;24 = 0,30Q&#10;Q₀ = 80&#10;P₀ = € 16">
             <a:extLst xmlns:a="http://schemas.openxmlformats.org/drawingml/2006/main">
               <a:ext uri="{FF2B5EF4-FFF2-40B4-BE49-F238E27FC236}">
-                <a16:creationId xmlns:a16="http://schemas.microsoft.com/office/drawing/2014/main" id="{5BFCC87D-08C2-4F8F-8D57-8D03DE793F23}"/>
+                <a16:creationId xmlns:a16="http://schemas.microsoft.com/office/drawing/2014/main" id="{10D2DD65-C57F-42D2-9C5B-D431CE778D4E}"/>
               </a:ext>
             </a:extLst>
           </p:cNvPr>
@@ -32334,7 +32436,7 @@
           <p:cNvPr id="8" name="80 controles&#10;per week">
             <a:extLst xmlns:a="http://schemas.openxmlformats.org/drawingml/2006/main">
               <a:ext uri="{FF2B5EF4-FFF2-40B4-BE49-F238E27FC236}">
-                <a16:creationId xmlns:a16="http://schemas.microsoft.com/office/drawing/2014/main" id="{3C02F9C2-957D-44EF-A532-F68053EAFC8F}"/>
+                <a16:creationId xmlns:a16="http://schemas.microsoft.com/office/drawing/2014/main" id="{F184A7D9-4F33-41B3-9C42-85DE024260BC}"/>
               </a:ext>
             </a:extLst>
           </p:cNvPr>
@@ -32412,7 +32514,7 @@
     </p:spTree>
     <p:extLst>
       <p:ext uri="{BB962C8B-B14F-4D97-AF65-F5344CB8AC3E}">
-        <p14:creationId xmlns:p14="http://schemas.microsoft.com/office/powerpoint/2010/main" val="2048759420"/>
+        <p14:creationId xmlns:p14="http://schemas.microsoft.com/office/powerpoint/2010/main" val="1430735247"/>
       </p:ext>
     </p:extLst>
   </p:cSld>
@@ -32443,7 +32545,7 @@
           <p:cNvPr id="9" name="Het aanbod in kopersprijzen">
             <a:extLst xmlns:a="http://schemas.openxmlformats.org/drawingml/2006/main">
               <a:ext uri="{FF2B5EF4-FFF2-40B4-BE49-F238E27FC236}">
-                <a16:creationId xmlns:a16="http://schemas.microsoft.com/office/drawing/2014/main" id="{61968271-FAE0-4597-AD97-837799143857}"/>
+                <a16:creationId xmlns:a16="http://schemas.microsoft.com/office/drawing/2014/main" id="{9E29A980-E271-433A-96AA-B3ADFA114EFC}"/>
               </a:ext>
             </a:extLst>
           </p:cNvPr>
@@ -32500,7 +32602,7 @@
           <p:cNvPr id="2" name="">
             <a:extLst xmlns:a="http://schemas.openxmlformats.org/drawingml/2006/main">
               <a:ext uri="{FF2B5EF4-FFF2-40B4-BE49-F238E27FC236}">
-                <a16:creationId xmlns:a16="http://schemas.microsoft.com/office/drawing/2014/main" id="{5E2D4E0E-91B3-401E-A8D9-C6C8748BF0D0}"/>
+                <a16:creationId xmlns:a16="http://schemas.microsoft.com/office/drawing/2014/main" id="{05E3690D-D91D-4009-BE31-280F58D7EBE2}"/>
               </a:ext>
             </a:extLst>
           </p:cNvPr>
@@ -32529,7 +32631,7 @@
           <p:cNvPr id="3" name="Uitlegvoorbeeld — niet uit het boek">
             <a:extLst xmlns:a="http://schemas.openxmlformats.org/drawingml/2006/main">
               <a:ext uri="{FF2B5EF4-FFF2-40B4-BE49-F238E27FC236}">
-                <a16:creationId xmlns:a16="http://schemas.microsoft.com/office/drawing/2014/main" id="{4B5D614D-BA56-4D9F-B37A-F9CDBCDFD18D}"/>
+                <a16:creationId xmlns:a16="http://schemas.microsoft.com/office/drawing/2014/main" id="{AD8EE225-F382-4A3B-9195-C4B6160AFE99}"/>
               </a:ext>
             </a:extLst>
           </p:cNvPr>
@@ -32586,7 +32688,7 @@
           <p:cNvPr id="4" name="5">
             <a:extLst xmlns:a="http://schemas.openxmlformats.org/drawingml/2006/main">
               <a:ext uri="{FF2B5EF4-FFF2-40B4-BE49-F238E27FC236}">
-                <a16:creationId xmlns:a16="http://schemas.microsoft.com/office/drawing/2014/main" id="{DA1C32C0-93BD-47D8-BAA2-2DBE2635981F}"/>
+                <a16:creationId xmlns:a16="http://schemas.microsoft.com/office/drawing/2014/main" id="{0058F308-CDD8-4948-A69E-AD651F5FA7E0}"/>
               </a:ext>
             </a:extLst>
           </p:cNvPr>
@@ -32643,7 +32745,7 @@
           <p:cNvPr id="5" name="Pp = 8 + 0,10Q">
             <a:extLst xmlns:a="http://schemas.openxmlformats.org/drawingml/2006/main">
               <a:ext uri="{FF2B5EF4-FFF2-40B4-BE49-F238E27FC236}">
-                <a16:creationId xmlns:a16="http://schemas.microsoft.com/office/drawing/2014/main" id="{C4C621DC-CE47-4F00-BA21-B9C5D497268F}"/>
+                <a16:creationId xmlns:a16="http://schemas.microsoft.com/office/drawing/2014/main" id="{63F6E0F3-A9E9-4DFB-94BE-85DCB1C05F26}"/>
               </a:ext>
             </a:extLst>
           </p:cNvPr>
@@ -32700,7 +32802,7 @@
           <p:cNvPr id="6" name="Pc = Pp − s">
             <a:extLst xmlns:a="http://schemas.openxmlformats.org/drawingml/2006/main">
               <a:ext uri="{FF2B5EF4-FFF2-40B4-BE49-F238E27FC236}">
-                <a16:creationId xmlns:a16="http://schemas.microsoft.com/office/drawing/2014/main" id="{DC1F55F7-A0FB-4CF7-B3E6-A264DA9AB105}"/>
+                <a16:creationId xmlns:a16="http://schemas.microsoft.com/office/drawing/2014/main" id="{41B2159F-F0E0-42F3-B13C-BB8CA1D8AEB7}"/>
               </a:ext>
             </a:extLst>
           </p:cNvPr>
@@ -32757,7 +32859,7 @@
           <p:cNvPr id="7" name="Pc = (8 + 0,10Q) − 6 = 2 + 0,10Q">
             <a:extLst xmlns:a="http://schemas.openxmlformats.org/drawingml/2006/main">
               <a:ext uri="{FF2B5EF4-FFF2-40B4-BE49-F238E27FC236}">
-                <a16:creationId xmlns:a16="http://schemas.microsoft.com/office/drawing/2014/main" id="{7EDE61DC-6208-4E06-B29E-531E66517C16}"/>
+                <a16:creationId xmlns:a16="http://schemas.microsoft.com/office/drawing/2014/main" id="{B75CF167-0A34-4CAC-BBDB-F3142E6DC4F1}"/>
               </a:ext>
             </a:extLst>
           </p:cNvPr>
@@ -32814,7 +32916,7 @@
           <p:cNvPr id="8" name="Dezelfde gewenste ontvangst, € 6 minder van de koper.">
             <a:extLst xmlns:a="http://schemas.openxmlformats.org/drawingml/2006/main">
               <a:ext uri="{FF2B5EF4-FFF2-40B4-BE49-F238E27FC236}">
-                <a16:creationId xmlns:a16="http://schemas.microsoft.com/office/drawing/2014/main" id="{479CAC93-3BFC-4855-B2D6-46B6195503FC}"/>
+                <a16:creationId xmlns:a16="http://schemas.microsoft.com/office/drawing/2014/main" id="{5A7B63D1-9293-4D6D-B6E3-4DFA77894DBA}"/>
               </a:ext>
             </a:extLst>
           </p:cNvPr>
@@ -32869,7 +32971,7 @@
     </p:spTree>
     <p:extLst>
       <p:ext uri="{BB962C8B-B14F-4D97-AF65-F5344CB8AC3E}">
-        <p14:creationId xmlns:p14="http://schemas.microsoft.com/office/powerpoint/2010/main" val="1880394071"/>
+        <p14:creationId xmlns:p14="http://schemas.microsoft.com/office/powerpoint/2010/main" val="1307408704"/>
       </p:ext>
     </p:extLst>
   </p:cSld>
@@ -32900,7 +33002,7 @@
           <p:cNvPr id="9" name="A − s ligt € 6 onder A">
             <a:extLst xmlns:a="http://schemas.openxmlformats.org/drawingml/2006/main">
               <a:ext uri="{FF2B5EF4-FFF2-40B4-BE49-F238E27FC236}">
-                <a16:creationId xmlns:a16="http://schemas.microsoft.com/office/drawing/2014/main" id="{DD6179E0-FC6E-4545-9789-89BE68B556AF}"/>
+                <a16:creationId xmlns:a16="http://schemas.microsoft.com/office/drawing/2014/main" id="{894ECF5E-CAF9-457D-AC57-27F323CE0E69}"/>
               </a:ext>
             </a:extLst>
           </p:cNvPr>
@@ -32957,7 +33059,7 @@
           <p:cNvPr id="2" name="">
             <a:extLst xmlns:a="http://schemas.openxmlformats.org/drawingml/2006/main">
               <a:ext uri="{FF2B5EF4-FFF2-40B4-BE49-F238E27FC236}">
-                <a16:creationId xmlns:a16="http://schemas.microsoft.com/office/drawing/2014/main" id="{570D4CA3-305B-4F05-8EBC-6082FEFC9B22}"/>
+                <a16:creationId xmlns:a16="http://schemas.microsoft.com/office/drawing/2014/main" id="{B178AC2F-BC27-4201-B6F4-2D907E74CC10}"/>
               </a:ext>
             </a:extLst>
           </p:cNvPr>
@@ -32986,7 +33088,7 @@
           <p:cNvPr id="3" name="Uitlegvoorbeeld — niet uit het boek">
             <a:extLst xmlns:a="http://schemas.openxmlformats.org/drawingml/2006/main">
               <a:ext uri="{FF2B5EF4-FFF2-40B4-BE49-F238E27FC236}">
-                <a16:creationId xmlns:a16="http://schemas.microsoft.com/office/drawing/2014/main" id="{B99B846F-3552-4132-A2AC-39325DF557C0}"/>
+                <a16:creationId xmlns:a16="http://schemas.microsoft.com/office/drawing/2014/main" id="{CB339CB6-7D70-4CCE-9F8C-265555712E74}"/>
               </a:ext>
             </a:extLst>
           </p:cNvPr>
@@ -33043,7 +33145,7 @@
           <p:cNvPr id="4" name="6">
             <a:extLst xmlns:a="http://schemas.openxmlformats.org/drawingml/2006/main">
               <a:ext uri="{FF2B5EF4-FFF2-40B4-BE49-F238E27FC236}">
-                <a16:creationId xmlns:a16="http://schemas.microsoft.com/office/drawing/2014/main" id="{729EE19A-D823-4EBF-A2C0-CFC8EAB45DD4}"/>
+                <a16:creationId xmlns:a16="http://schemas.microsoft.com/office/drawing/2014/main" id="{0DA5DA2B-9D37-443C-8E4A-5FAA58AA977B}"/>
               </a:ext>
             </a:extLst>
           </p:cNvPr>
@@ -33107,7 +33209,7 @@
         </p:xfrm>
         <a:graphic xmlns:a="http://schemas.openxmlformats.org/drawingml/2006/main">
           <a:graphicData uri="http://schemas.openxmlformats.org/drawingml/2006/chart">
-            <c:chart xmlns:r="http://schemas.openxmlformats.org/officeDocument/2006/relationships" xmlns:c="http://schemas.openxmlformats.org/drawingml/2006/chart" r:id="Rd89014ceb0624a96"/>
+            <c:chart xmlns:r="http://schemas.openxmlformats.org/officeDocument/2006/relationships" xmlns:c="http://schemas.openxmlformats.org/drawingml/2006/chart" r:id="R7bf64a4f968743a9"/>
           </a:graphicData>
         </a:graphic>
       </p:graphicFrame>
@@ -33116,7 +33218,7 @@
           <p:cNvPr id="6" name="Twee aanbodlijnen">
             <a:extLst xmlns:a="http://schemas.openxmlformats.org/drawingml/2006/main">
               <a:ext uri="{FF2B5EF4-FFF2-40B4-BE49-F238E27FC236}">
-                <a16:creationId xmlns:a16="http://schemas.microsoft.com/office/drawing/2014/main" id="{B8EA9A7A-912F-4E2C-B515-AD88F24B8FE6}"/>
+                <a16:creationId xmlns:a16="http://schemas.microsoft.com/office/drawing/2014/main" id="{195AB3F5-D28A-4F10-888D-53DF4C6E978F}"/>
               </a:ext>
             </a:extLst>
           </p:cNvPr>
@@ -33173,7 +33275,7 @@
           <p:cNvPr id="7" name="A: Pp = 8 + 0,10Q&#10;&#10;A − s:&#10;Pc = 2 + 0,10Q">
             <a:extLst xmlns:a="http://schemas.openxmlformats.org/drawingml/2006/main">
               <a:ext uri="{FF2B5EF4-FFF2-40B4-BE49-F238E27FC236}">
-                <a16:creationId xmlns:a16="http://schemas.microsoft.com/office/drawing/2014/main" id="{21AF7241-C5A7-434B-9078-0D8273EB2383}"/>
+                <a16:creationId xmlns:a16="http://schemas.microsoft.com/office/drawing/2014/main" id="{26639E0F-B846-44BA-80CF-10916AA619AC}"/>
               </a:ext>
             </a:extLst>
           </p:cNvPr>
@@ -33281,7 +33383,7 @@
           <p:cNvPr id="8" name="V blijft gelijk">
             <a:extLst xmlns:a="http://schemas.openxmlformats.org/drawingml/2006/main">
               <a:ext uri="{FF2B5EF4-FFF2-40B4-BE49-F238E27FC236}">
-                <a16:creationId xmlns:a16="http://schemas.microsoft.com/office/drawing/2014/main" id="{7496E1AF-84D3-42AB-9700-A2F0FFE27BBB}"/>
+                <a16:creationId xmlns:a16="http://schemas.microsoft.com/office/drawing/2014/main" id="{348F8D04-889C-4A03-8796-1A00B27E2260}"/>
               </a:ext>
             </a:extLst>
           </p:cNvPr>
@@ -33336,7 +33438,7 @@
     </p:spTree>
     <p:extLst>
       <p:ext uri="{BB962C8B-B14F-4D97-AF65-F5344CB8AC3E}">
-        <p14:creationId xmlns:p14="http://schemas.microsoft.com/office/powerpoint/2010/main" val="317063985"/>
+        <p14:creationId xmlns:p14="http://schemas.microsoft.com/office/powerpoint/2010/main" val="936313950"/>
       </p:ext>
     </p:extLst>
   </p:cSld>
@@ -33367,7 +33469,7 @@
           <p:cNvPr id="10" name="De nieuwe hoeveelheid en beide prijzen">
             <a:extLst xmlns:a="http://schemas.openxmlformats.org/drawingml/2006/main">
               <a:ext uri="{FF2B5EF4-FFF2-40B4-BE49-F238E27FC236}">
-                <a16:creationId xmlns:a16="http://schemas.microsoft.com/office/drawing/2014/main" id="{1CDF8449-9BA3-495B-B907-6D1C4B3AE215}"/>
+                <a16:creationId xmlns:a16="http://schemas.microsoft.com/office/drawing/2014/main" id="{76E3CE8D-681F-431D-B41C-BB9B65D22D8F}"/>
               </a:ext>
             </a:extLst>
           </p:cNvPr>
@@ -33424,7 +33526,7 @@
           <p:cNvPr id="2" name="">
             <a:extLst xmlns:a="http://schemas.openxmlformats.org/drawingml/2006/main">
               <a:ext uri="{FF2B5EF4-FFF2-40B4-BE49-F238E27FC236}">
-                <a16:creationId xmlns:a16="http://schemas.microsoft.com/office/drawing/2014/main" id="{529028E3-6A7E-41EE-876A-1778D531A9FC}"/>
+                <a16:creationId xmlns:a16="http://schemas.microsoft.com/office/drawing/2014/main" id="{205545F3-5BFF-4AE0-990F-92A671223D6D}"/>
               </a:ext>
             </a:extLst>
           </p:cNvPr>
@@ -33453,7 +33555,7 @@
           <p:cNvPr id="3" name="Uitlegvoorbeeld — niet uit het boek">
             <a:extLst xmlns:a="http://schemas.openxmlformats.org/drawingml/2006/main">
               <a:ext uri="{FF2B5EF4-FFF2-40B4-BE49-F238E27FC236}">
-                <a16:creationId xmlns:a16="http://schemas.microsoft.com/office/drawing/2014/main" id="{E355D9F1-4845-4165-A992-74C06ECCA6EA}"/>
+                <a16:creationId xmlns:a16="http://schemas.microsoft.com/office/drawing/2014/main" id="{24A9BAEF-AD91-456B-8347-8E7A5220D879}"/>
               </a:ext>
             </a:extLst>
           </p:cNvPr>
@@ -33510,7 +33612,7 @@
           <p:cNvPr id="4" name="7">
             <a:extLst xmlns:a="http://schemas.openxmlformats.org/drawingml/2006/main">
               <a:ext uri="{FF2B5EF4-FFF2-40B4-BE49-F238E27FC236}">
-                <a16:creationId xmlns:a16="http://schemas.microsoft.com/office/drawing/2014/main" id="{7AD1E0D4-88B3-4517-8393-86729A0DEDFC}"/>
+                <a16:creationId xmlns:a16="http://schemas.microsoft.com/office/drawing/2014/main" id="{C4B5EA44-C90D-4034-82E9-8F4B2DFFEA65}"/>
               </a:ext>
             </a:extLst>
           </p:cNvPr>
@@ -33567,7 +33669,7 @@
           <p:cNvPr id="5" name="32 − 0,20Q = 2 + 0,10Q">
             <a:extLst xmlns:a="http://schemas.openxmlformats.org/drawingml/2006/main">
               <a:ext uri="{FF2B5EF4-FFF2-40B4-BE49-F238E27FC236}">
-                <a16:creationId xmlns:a16="http://schemas.microsoft.com/office/drawing/2014/main" id="{31945D05-77B4-47C0-89BF-F58B8D07C571}"/>
+                <a16:creationId xmlns:a16="http://schemas.microsoft.com/office/drawing/2014/main" id="{0397B571-6065-485A-917E-9C045DA4DFC2}"/>
               </a:ext>
             </a:extLst>
           </p:cNvPr>
@@ -33624,7 +33726,7 @@
           <p:cNvPr id="6" name="30 = 0,30Q       Qsub = 100 controles per week">
             <a:extLst xmlns:a="http://schemas.openxmlformats.org/drawingml/2006/main">
               <a:ext uri="{FF2B5EF4-FFF2-40B4-BE49-F238E27FC236}">
-                <a16:creationId xmlns:a16="http://schemas.microsoft.com/office/drawing/2014/main" id="{F5964D2E-58F8-4C80-A789-58FBAC0E82B3}"/>
+                <a16:creationId xmlns:a16="http://schemas.microsoft.com/office/drawing/2014/main" id="{0BA26C77-4E5C-47E1-A150-1792DF13A28C}"/>
               </a:ext>
             </a:extLst>
           </p:cNvPr>
@@ -33681,7 +33783,7 @@
           <p:cNvPr id="7" name="Pc = 32 − 0,20 × 100 = € 12">
             <a:extLst xmlns:a="http://schemas.openxmlformats.org/drawingml/2006/main">
               <a:ext uri="{FF2B5EF4-FFF2-40B4-BE49-F238E27FC236}">
-                <a16:creationId xmlns:a16="http://schemas.microsoft.com/office/drawing/2014/main" id="{A8B4C2B3-7EA0-45AA-90F4-1FEA3C357F09}"/>
+                <a16:creationId xmlns:a16="http://schemas.microsoft.com/office/drawing/2014/main" id="{41ED509A-A513-4527-BDE7-8FA7B3EB023A}"/>
               </a:ext>
             </a:extLst>
           </p:cNvPr>
@@ -33738,7 +33840,7 @@
           <p:cNvPr id="8" name="Pp = 8 + 0,10 × 100 = € 18">
             <a:extLst xmlns:a="http://schemas.openxmlformats.org/drawingml/2006/main">
               <a:ext uri="{FF2B5EF4-FFF2-40B4-BE49-F238E27FC236}">
-                <a16:creationId xmlns:a16="http://schemas.microsoft.com/office/drawing/2014/main" id="{113629C3-00AC-4733-9A24-C21D9AA000AF}"/>
+                <a16:creationId xmlns:a16="http://schemas.microsoft.com/office/drawing/2014/main" id="{0A6DFED7-3DE8-4E16-B378-DEB65D0069E2}"/>
               </a:ext>
             </a:extLst>
           </p:cNvPr>
@@ -33795,7 +33897,7 @@
           <p:cNvPr id="9" name="Controle: Pp − Pc = 18 − 12 = € 6 per controle">
             <a:extLst xmlns:a="http://schemas.openxmlformats.org/drawingml/2006/main">
               <a:ext uri="{FF2B5EF4-FFF2-40B4-BE49-F238E27FC236}">
-                <a16:creationId xmlns:a16="http://schemas.microsoft.com/office/drawing/2014/main" id="{5A3756BF-44F2-4DDF-9422-735C8100F252}"/>
+                <a16:creationId xmlns:a16="http://schemas.microsoft.com/office/drawing/2014/main" id="{4CD9DCA6-14C3-480F-B4D2-B4BFFAB4F70B}"/>
               </a:ext>
             </a:extLst>
           </p:cNvPr>
@@ -33850,7 +33952,7 @@
     </p:spTree>
     <p:extLst>
       <p:ext uri="{BB962C8B-B14F-4D97-AF65-F5344CB8AC3E}">
-        <p14:creationId xmlns:p14="http://schemas.microsoft.com/office/powerpoint/2010/main" val="1080901444"/>
+        <p14:creationId xmlns:p14="http://schemas.microsoft.com/office/powerpoint/2010/main" val="761341358"/>
       </p:ext>
     </p:extLst>
   </p:cSld>
@@ -33881,7 +33983,7 @@
           <p:cNvPr id="9" name="Twee prijzen bij dezelfde hoeveelheid">
             <a:extLst xmlns:a="http://schemas.openxmlformats.org/drawingml/2006/main">
               <a:ext uri="{FF2B5EF4-FFF2-40B4-BE49-F238E27FC236}">
-                <a16:creationId xmlns:a16="http://schemas.microsoft.com/office/drawing/2014/main" id="{A4D0F42B-3CDF-4EE6-993B-9C2974D5601D}"/>
+                <a16:creationId xmlns:a16="http://schemas.microsoft.com/office/drawing/2014/main" id="{341C2CC4-5E33-44F4-8632-4078DEECC750}"/>
               </a:ext>
             </a:extLst>
           </p:cNvPr>
@@ -33938,7 +34040,7 @@
           <p:cNvPr id="2" name="">
             <a:extLst xmlns:a="http://schemas.openxmlformats.org/drawingml/2006/main">
               <a:ext uri="{FF2B5EF4-FFF2-40B4-BE49-F238E27FC236}">
-                <a16:creationId xmlns:a16="http://schemas.microsoft.com/office/drawing/2014/main" id="{260DB82A-1D45-4556-A2BB-877F9AEDFD99}"/>
+                <a16:creationId xmlns:a16="http://schemas.microsoft.com/office/drawing/2014/main" id="{3ADF7B38-3B5B-4183-A532-06FA479466DF}"/>
               </a:ext>
             </a:extLst>
           </p:cNvPr>
@@ -33967,7 +34069,7 @@
           <p:cNvPr id="3" name="Uitlegvoorbeeld — niet uit het boek">
             <a:extLst xmlns:a="http://schemas.openxmlformats.org/drawingml/2006/main">
               <a:ext uri="{FF2B5EF4-FFF2-40B4-BE49-F238E27FC236}">
-                <a16:creationId xmlns:a16="http://schemas.microsoft.com/office/drawing/2014/main" id="{B3136AEF-E523-49CE-950C-33F39C996162}"/>
+                <a16:creationId xmlns:a16="http://schemas.microsoft.com/office/drawing/2014/main" id="{7FED6F25-9DBA-43A6-91FA-082EB3B61A98}"/>
               </a:ext>
             </a:extLst>
           </p:cNvPr>
@@ -34024,7 +34126,7 @@
           <p:cNvPr id="4" name="8">
             <a:extLst xmlns:a="http://schemas.openxmlformats.org/drawingml/2006/main">
               <a:ext uri="{FF2B5EF4-FFF2-40B4-BE49-F238E27FC236}">
-                <a16:creationId xmlns:a16="http://schemas.microsoft.com/office/drawing/2014/main" id="{E7FE48EF-409F-437C-BA17-DD4ECBFC43C3}"/>
+                <a16:creationId xmlns:a16="http://schemas.microsoft.com/office/drawing/2014/main" id="{41F3F818-142F-4491-A576-15CDE6C4828C}"/>
               </a:ext>
             </a:extLst>
           </p:cNvPr>
@@ -34088,7 +34190,7 @@
         </p:xfrm>
         <a:graphic xmlns:a="http://schemas.openxmlformats.org/drawingml/2006/main">
           <a:graphicData uri="http://schemas.openxmlformats.org/drawingml/2006/chart">
-            <c:chart xmlns:r="http://schemas.openxmlformats.org/officeDocument/2006/relationships" xmlns:c="http://schemas.openxmlformats.org/drawingml/2006/chart" r:id="R1cdc87ce3d7c4907"/>
+            <c:chart xmlns:r="http://schemas.openxmlformats.org/officeDocument/2006/relationships" xmlns:c="http://schemas.openxmlformats.org/drawingml/2006/chart" r:id="R38838fcd9a924db1"/>
           </a:graphicData>
         </a:graphic>
       </p:graphicFrame>
@@ -34097,7 +34199,7 @@
           <p:cNvPr id="6" name="Qsub = 100">
             <a:extLst xmlns:a="http://schemas.openxmlformats.org/drawingml/2006/main">
               <a:ext uri="{FF2B5EF4-FFF2-40B4-BE49-F238E27FC236}">
-                <a16:creationId xmlns:a16="http://schemas.microsoft.com/office/drawing/2014/main" id="{FC239666-527A-4A94-AC2D-DA98F1BD8869}"/>
+                <a16:creationId xmlns:a16="http://schemas.microsoft.com/office/drawing/2014/main" id="{6B6CA123-A290-48FF-ADA9-8E4566FECAE2}"/>
               </a:ext>
             </a:extLst>
           </p:cNvPr>
@@ -34154,7 +34256,7 @@
           <p:cNvPr id="7" name="Op V: Pc = € 12&#10;&#10;Op A: Pp = € 18&#10;&#10;Wig: € 6">
             <a:extLst xmlns:a="http://schemas.openxmlformats.org/drawingml/2006/main">
               <a:ext uri="{FF2B5EF4-FFF2-40B4-BE49-F238E27FC236}">
-                <a16:creationId xmlns:a16="http://schemas.microsoft.com/office/drawing/2014/main" id="{07C5D244-682D-4CE2-8517-42B3E9C62CAA}"/>
+                <a16:creationId xmlns:a16="http://schemas.microsoft.com/office/drawing/2014/main" id="{1DA125B1-646E-4110-8379-5C2F4FE0452A}"/>
               </a:ext>
             </a:extLst>
           </p:cNvPr>
@@ -34267,7 +34369,7 @@
           <p:cNvPr id="8" name="Pp is inclusief&#10;de subsidie">
             <a:extLst xmlns:a="http://schemas.openxmlformats.org/drawingml/2006/main">
               <a:ext uri="{FF2B5EF4-FFF2-40B4-BE49-F238E27FC236}">
-                <a16:creationId xmlns:a16="http://schemas.microsoft.com/office/drawing/2014/main" id="{9E9C47F3-D9B8-4CA0-B15C-36520C5C2F18}"/>
+                <a16:creationId xmlns:a16="http://schemas.microsoft.com/office/drawing/2014/main" id="{13C6EB0D-1154-4F45-86B7-04F4833EA1D6}"/>
               </a:ext>
             </a:extLst>
           </p:cNvPr>
@@ -34345,7 +34447,7 @@
     </p:spTree>
     <p:extLst>
       <p:ext uri="{BB962C8B-B14F-4D97-AF65-F5344CB8AC3E}">
-        <p14:creationId xmlns:p14="http://schemas.microsoft.com/office/powerpoint/2010/main" val="920569800"/>
+        <p14:creationId xmlns:p14="http://schemas.microsoft.com/office/powerpoint/2010/main" val="604700285"/>
       </p:ext>
     </p:extLst>
   </p:cSld>
@@ -34376,7 +34478,7 @@
           <p:cNvPr id="7" name="De verdeling van het voordeel">
             <a:extLst xmlns:a="http://schemas.openxmlformats.org/drawingml/2006/main">
               <a:ext uri="{FF2B5EF4-FFF2-40B4-BE49-F238E27FC236}">
-                <a16:creationId xmlns:a16="http://schemas.microsoft.com/office/drawing/2014/main" id="{C68FDE7F-E9A4-4145-B97D-91C49C814931}"/>
+                <a16:creationId xmlns:a16="http://schemas.microsoft.com/office/drawing/2014/main" id="{E3708D71-1C57-48EE-AEE9-C79B6AED2F0F}"/>
               </a:ext>
             </a:extLst>
           </p:cNvPr>
@@ -34433,7 +34535,7 @@
           <p:cNvPr id="2" name="">
             <a:extLst xmlns:a="http://schemas.openxmlformats.org/drawingml/2006/main">
               <a:ext uri="{FF2B5EF4-FFF2-40B4-BE49-F238E27FC236}">
-                <a16:creationId xmlns:a16="http://schemas.microsoft.com/office/drawing/2014/main" id="{EE6590C2-AE0E-4884-9C0D-72D5F335F565}"/>
+                <a16:creationId xmlns:a16="http://schemas.microsoft.com/office/drawing/2014/main" id="{B08F6EB5-A561-46FF-9477-66620C9B93DD}"/>
               </a:ext>
             </a:extLst>
           </p:cNvPr>
@@ -34462,7 +34564,7 @@
           <p:cNvPr id="3" name="Uitlegvoorbeeld — niet uit het boek">
             <a:extLst xmlns:a="http://schemas.openxmlformats.org/drawingml/2006/main">
               <a:ext uri="{FF2B5EF4-FFF2-40B4-BE49-F238E27FC236}">
-                <a16:creationId xmlns:a16="http://schemas.microsoft.com/office/drawing/2014/main" id="{448A97D8-C9FF-4499-A6DD-74A8A97F46A2}"/>
+                <a16:creationId xmlns:a16="http://schemas.microsoft.com/office/drawing/2014/main" id="{92F5C08B-9C55-455E-A162-0A219B387D2F}"/>
               </a:ext>
             </a:extLst>
           </p:cNvPr>
@@ -34519,7 +34621,7 @@
           <p:cNvPr id="4" name="9">
             <a:extLst xmlns:a="http://schemas.openxmlformats.org/drawingml/2006/main">
               <a:ext uri="{FF2B5EF4-FFF2-40B4-BE49-F238E27FC236}">
-                <a16:creationId xmlns:a16="http://schemas.microsoft.com/office/drawing/2014/main" id="{DC18B1B6-2BBD-4E27-BB0A-618357988583}"/>
+                <a16:creationId xmlns:a16="http://schemas.microsoft.com/office/drawing/2014/main" id="{760F85C4-5736-4C3A-AC37-1A087910064D}"/>
               </a:ext>
             </a:extLst>
           </p:cNvPr>
@@ -34821,7 +34923,7 @@
           <p:cNvPr id="6" name="€ 4 + € 2 = € 6 subsidie per verkochte controle">
             <a:extLst xmlns:a="http://schemas.openxmlformats.org/drawingml/2006/main">
               <a:ext uri="{FF2B5EF4-FFF2-40B4-BE49-F238E27FC236}">
-                <a16:creationId xmlns:a16="http://schemas.microsoft.com/office/drawing/2014/main" id="{2109922F-9C9C-423C-B661-92D99758DF54}"/>
+                <a16:creationId xmlns:a16="http://schemas.microsoft.com/office/drawing/2014/main" id="{818C9517-D750-4CF4-9361-FAF1F8E79C15}"/>
               </a:ext>
             </a:extLst>
           </p:cNvPr>
@@ -34876,7 +34978,7 @@
     </p:spTree>
     <p:extLst>
       <p:ext uri="{BB962C8B-B14F-4D97-AF65-F5344CB8AC3E}">
-        <p14:creationId xmlns:p14="http://schemas.microsoft.com/office/powerpoint/2010/main" val="46152680"/>
+        <p14:creationId xmlns:p14="http://schemas.microsoft.com/office/powerpoint/2010/main" val="52571156"/>
       </p:ext>
     </p:extLst>
   </p:cSld>

</xml_diff>